<commit_message>
Slide 4: swap the confusing item-level-adaptivity bullet for the intuitive speed failure
- Item 2 is now '실제로는 별로 빨라지지 않았다' (42% theoretical vs 9.7% measured TTFT)
- The +2.7pp item-level result moves to a dedicated appendix slide that states plainly
  what it means: no per-item controller needed, so 'adaptive' cannot be claimed, but
  the method gets simpler
- Slide 4 takeaway now carries the good news explicitly (+30.7pp, 80% retained under
  position swap) instead of mixing two opposing numbers in one bullet

Co-Authored-By: Claude Fable 5 <noreply@anthropic.com>
</commit_message>
<xml_diff>
--- a/meeting/SourceDepth_meeting_FINAL.pptx
+++ b/meeting/SourceDepth_meeting_FINAL.pptx
@@ -15,9 +15,10 @@
     <p:sldId id="263" r:id="rId9"/>
     <p:sldId id="264" r:id="rId10"/>
     <p:sldId id="265" r:id="rId11"/>
+    <p:sldId id="266" r:id="rId12"/>
   </p:sldIdLst>
   <p:notesMasterIdLst>
-    <p:notesMasterId r:id="rId12"/>
+    <p:notesMasterId r:id="rId13"/>
   </p:notesMasterIdLst>
   <p:sldSz cx="12192000" cy="6858000"/>
   <p:notesSz cx="6858000" cy="12192000"/>
@@ -623,6 +624,94 @@
             <a:fld id="{F7021451-1387-4CA6-816F-3879F97B5CBC}" type="slidenum">
               <a:rPr lang="en-US"/>
               <a:t>10</a:t>
+            </a:fld>
+            <a:endParaRPr lang="en-US"/>
+          </a:p>
+        </p:txBody>
+      </p:sp>
+    </p:spTree>
+    <p:extLst>
+      <p:ext uri="{BB962C8B-B14F-4D97-AF65-F5344CB8AC3E}">
+        <p14:creationId xmlns:p14="http://schemas.microsoft.com/office/powerpoint/2010/main" val="1024086991"/>
+      </p:ext>
+    </p:extLst>
+  </p:cSld>
+  <p:clrMapOvr>
+    <a:masterClrMapping/>
+  </p:clrMapOvr>
+</p:notes>
+</file>
+
+<file path=ppt/notesSlides/notesSlide11.xml><?xml version="1.0" encoding="utf-8"?>
+<p:notes xmlns:a="http://schemas.openxmlformats.org/drawingml/2006/main" xmlns:r="http://schemas.openxmlformats.org/officeDocument/2006/relationships" xmlns:p="http://schemas.openxmlformats.org/presentationml/2006/main">
+  <p:cSld>
+    <p:spTree>
+      <p:nvGrpSpPr>
+        <p:cNvPr id="1" name=""/>
+        <p:cNvGrpSpPr/>
+        <p:nvPr/>
+      </p:nvGrpSpPr>
+      <p:grpSpPr>
+        <a:xfrm>
+          <a:off x="0" y="0"/>
+          <a:ext cx="0" cy="0"/>
+          <a:chOff x="0" y="0"/>
+          <a:chExt cx="0" cy="0"/>
+        </a:xfrm>
+      </p:grpSpPr>
+      <p:sp>
+        <p:nvSpPr>
+          <p:cNvPr id="2" name="Slide Image Placeholder 1"/>
+          <p:cNvSpPr>
+            <a:spLocks noGrp="1" noRot="1" noChangeAspect="1"/>
+          </p:cNvSpPr>
+          <p:nvPr>
+            <p:ph type="sldImg"/>
+          </p:nvPr>
+        </p:nvSpPr>
+        <p:spPr/>
+      </p:sp>
+      <p:sp>
+        <p:nvSpPr>
+          <p:cNvPr id="3" name="Notes Placeholder 2"/>
+          <p:cNvSpPr>
+            <a:spLocks noGrp="1"/>
+          </p:cNvSpPr>
+          <p:nvPr>
+            <p:ph type="body" idx="1"/>
+          </p:nvPr>
+        </p:nvSpPr>
+        <p:spPr/>
+        <p:txBody>
+          <a:bodyPr/>
+          <a:lstStyle/>
+          <a:p>
+            <a:r>
+              <a:rPr lang="en-US" dirty="0"/>
+              <a:t/>
+            </a:r>
+            <a:endParaRPr lang="en-US" dirty="0"/>
+          </a:p>
+        </p:txBody>
+      </p:sp>
+      <p:sp>
+        <p:nvSpPr>
+          <p:cNvPr id="4" name="Slide Number Placeholder 3"/>
+          <p:cNvSpPr>
+            <a:spLocks noGrp="1"/>
+          </p:cNvSpPr>
+          <p:nvPr>
+            <p:ph type="sldNum" sz="quarter" idx="10"/>
+          </p:nvPr>
+        </p:nvSpPr>
+        <p:spPr/>
+        <p:txBody>
+          <a:bodyPr/>
+          <a:lstStyle/>
+          <a:p>
+            <a:fld id="{F7021451-1387-4CA6-816F-3879F97B5CBC}" type="slidenum">
+              <a:rPr lang="en-US"/>
+              <a:t>11</a:t>
             </a:fld>
             <a:endParaRPr lang="en-US"/>
           </a:p>
@@ -2474,6 +2563,172 @@
                 <a:ea typeface="Arial" pitchFamily="34" charset="-122"/>
                 <a:cs typeface="Arial" pitchFamily="34" charset="-120"/>
               </a:rPr>
+              <a:t>컨트롤러 신호를 층·head별로 전수 탐색한 결과</a:t>
+            </a:r>
+            <a:endParaRPr lang="en-US" sz="2300" dirty="0"/>
+          </a:p>
+        </p:txBody>
+      </p:sp>
+      <p:pic>
+        <p:nvPicPr>
+          <p:cNvPr id="4" name="Image 0" descr="/Users/hansangmin/Source-Depth/results/fig4_controller_feature_sweep.png">    </p:cNvPr>
+          <p:cNvPicPr>
+            <a:picLocks noChangeAspect="1"/>
+          </p:cNvPicPr>
+          <p:nvPr/>
+        </p:nvPicPr>
+        <p:blipFill>
+          <a:blip r:embed="rId1"/>
+          <a:stretch>
+            <a:fillRect/>
+          </a:stretch>
+        </p:blipFill>
+        <p:spPr>
+          <a:xfrm>
+            <a:off x="731520" y="1554480"/>
+            <a:ext cx="10698480" cy="3931920"/>
+          </a:xfrm>
+          <a:prstGeom prst="rect">
+            <a:avLst/>
+          </a:prstGeom>
+        </p:spPr>
+      </p:pic>
+      <p:sp>
+        <p:nvSpPr>
+          <p:cNvPr id="5" name="Text 2"/>
+          <p:cNvSpPr/>
+          <p:nvPr/>
+        </p:nvSpPr>
+        <p:spPr>
+          <a:xfrm>
+            <a:off x="502920" y="5852160"/>
+            <a:ext cx="11155680" cy="548640"/>
+          </a:xfrm>
+          <a:prstGeom prst="rect">
+            <a:avLst/>
+          </a:prstGeom>
+          <a:noFill/>
+          <a:ln/>
+        </p:spPr>
+        <p:txBody>
+          <a:bodyPr wrap="square" lIns="0" tIns="0" rIns="0" bIns="0" rtlCol="0" anchor="ctr"/>
+          <a:lstStyle/>
+          <a:p>
+            <a:pPr indent="0" marL="0">
+              <a:buNone/>
+            </a:pPr>
+            <a:r>
+              <a:rPr lang="en-US" sz="1100" dirty="0">
+                <a:solidFill>
+                  <a:srgbClr val="6B7280"/>
+                </a:solidFill>
+                <a:latin typeface="Arial" pitchFamily="34" charset="0"/>
+                <a:ea typeface="Arial" pitchFamily="34" charset="-122"/>
+                <a:cs typeface="Arial" pitchFamily="34" charset="-120"/>
+              </a:rPr>
+              <a:t>순서를 뒤집어도 맞는 head: 얕은 층 0.31~0.51(무작위), layer 22에서 0.882가 최고. 개입이 유효한 구간은 16층 이전</a:t>
+            </a:r>
+            <a:endParaRPr lang="en-US" sz="1100" dirty="0"/>
+          </a:p>
+        </p:txBody>
+      </p:sp>
+    </p:spTree>
+  </p:cSld>
+  <p:clrMapOvr>
+    <a:masterClrMapping/>
+  </p:clrMapOvr>
+</p:sld>
+</file>
+
+<file path=ppt/slides/slide11.xml><?xml version="1.0" encoding="utf-8"?>
+<p:sld xmlns:a="http://schemas.openxmlformats.org/drawingml/2006/main" xmlns:r="http://schemas.openxmlformats.org/officeDocument/2006/relationships" xmlns:p="http://schemas.openxmlformats.org/presentationml/2006/main">
+  <p:cSld name="Slide 11">
+    <p:spTree>
+      <p:nvGrpSpPr>
+        <p:cNvPr id="1" name=""/>
+        <p:cNvGrpSpPr/>
+        <p:nvPr/>
+      </p:nvGrpSpPr>
+      <p:grpSpPr>
+        <a:xfrm>
+          <a:off x="0" y="0"/>
+          <a:ext cx="0" cy="0"/>
+          <a:chOff x="0" y="0"/>
+          <a:chExt cx="0" cy="0"/>
+        </a:xfrm>
+      </p:grpSpPr>
+      <p:sp>
+        <p:nvSpPr>
+          <p:cNvPr id="2" name="Text 0"/>
+          <p:cNvSpPr/>
+          <p:nvPr/>
+        </p:nvSpPr>
+        <p:spPr>
+          <a:xfrm>
+            <a:off x="502920" y="256032"/>
+            <a:ext cx="9601200" cy="292608"/>
+          </a:xfrm>
+          <a:prstGeom prst="rect">
+            <a:avLst/>
+          </a:prstGeom>
+          <a:noFill/>
+          <a:ln/>
+        </p:spPr>
+        <p:txBody>
+          <a:bodyPr wrap="square" lIns="0" tIns="0" rIns="0" bIns="0" rtlCol="0" anchor="ctr"/>
+          <a:lstStyle/>
+          <a:p>
+            <a:pPr indent="0" marL="0">
+              <a:buNone/>
+            </a:pPr>
+            <a:r>
+              <a:rPr lang="en-US" sz="1150" b="1" dirty="0">
+                <a:solidFill>
+                  <a:srgbClr val="1F77B4"/>
+                </a:solidFill>
+                <a:latin typeface="Arial" pitchFamily="34" charset="0"/>
+                <a:ea typeface="Arial" pitchFamily="34" charset="-122"/>
+                <a:cs typeface="Arial" pitchFamily="34" charset="-120"/>
+              </a:rPr>
+              <a:t>APPENDIX</a:t>
+            </a:r>
+            <a:endParaRPr lang="en-US" sz="1150" dirty="0"/>
+          </a:p>
+        </p:txBody>
+      </p:sp>
+      <p:sp>
+        <p:nvSpPr>
+          <p:cNvPr id="3" name="Text 1"/>
+          <p:cNvSpPr/>
+          <p:nvPr/>
+        </p:nvSpPr>
+        <p:spPr>
+          <a:xfrm>
+            <a:off x="502920" y="530352"/>
+            <a:ext cx="11155680" cy="731520"/>
+          </a:xfrm>
+          <a:prstGeom prst="rect">
+            <a:avLst/>
+          </a:prstGeom>
+          <a:noFill/>
+          <a:ln/>
+        </p:spPr>
+        <p:txBody>
+          <a:bodyPr wrap="square" lIns="0" tIns="0" rIns="0" bIns="0" rtlCol="0" anchor="ctr"/>
+          <a:lstStyle/>
+          <a:p>
+            <a:pPr indent="0" marL="0">
+              <a:buNone/>
+            </a:pPr>
+            <a:r>
+              <a:rPr lang="en-US" sz="2300" b="1" dirty="0">
+                <a:solidFill>
+                  <a:srgbClr val="1F3B57"/>
+                </a:solidFill>
+                <a:latin typeface="Arial" pitchFamily="34" charset="0"/>
+                <a:ea typeface="Arial" pitchFamily="34" charset="-122"/>
+                <a:cs typeface="Arial" pitchFamily="34" charset="-120"/>
+              </a:rPr>
               <a:t>재현성 · 한계</a:t>
             </a:r>
             <a:endParaRPr lang="en-US" sz="2300" dirty="0"/>
@@ -5028,7 +5283,7 @@
                 <a:ea typeface="Arial" pitchFamily="34" charset="-122"/>
                 <a:cs typeface="Arial" pitchFamily="34" charset="-120"/>
               </a:rPr>
-              <a:t>문항마다 맞출 필요는 없었다</a:t>
+              <a:t>실제로는 별로 빨라지지 않았다</a:t>
             </a:r>
             <a:endParaRPr lang="en-US" sz="1350" dirty="0"/>
           </a:p>
@@ -5070,7 +5325,7 @@
                 <a:ea typeface="Arial" pitchFamily="34" charset="-122"/>
                 <a:cs typeface="Arial" pitchFamily="34" charset="-120"/>
               </a:rPr>
-              <a:t>문항별 최적 깊이를 완벽히 안다고 가정해도 전역 최적 하나 대비 +2.7%p.</a:t>
+              <a:t>계산량 기준으로는 42% 절약인데, 실제 응답 시작 시간은 510ms → 461ms.</a:t>
             </a:r>
             <a:endParaRPr lang="en-US" sz="1080" dirty="0"/>
           </a:p>
@@ -5090,7 +5345,7 @@
                 <a:ea typeface="Arial" pitchFamily="34" charset="-122"/>
                 <a:cs typeface="Arial" pitchFamily="34" charset="-120"/>
               </a:rPr>
-              <a:t>문항의 66%는 어느 깊이에서 잘라도 정답. 단 '이미지 간' 차등은 유효(+30.7%p).</a:t>
+              <a:t>이론치의 23%밖에 실현되지 않았다.</a:t>
             </a:r>
             <a:endParaRPr lang="en-US" sz="1080" dirty="0"/>
           </a:p>
@@ -5129,7 +5384,7 @@
                 <a:ea typeface="Arial" pitchFamily="34" charset="-122"/>
                 <a:cs typeface="Arial" pitchFamily="34" charset="-120"/>
               </a:rPr>
-              <a:t>→ 적응은 문항이 아니라 질문 유형 단위면 충분</a:t>
+              <a:t>→ 9.7% 단축으로는 쓸 이유가 없다</a:t>
             </a:r>
             <a:endParaRPr lang="en-US" sz="1100" dirty="0"/>
           </a:p>
@@ -5416,7 +5671,7 @@
                 <a:ea typeface="Arial" pitchFamily="34" charset="-122"/>
                 <a:cs typeface="Arial" pitchFamily="34" charset="-120"/>
               </a:rPr>
-              <a:t>→ 단, 위치 confound를 제거해도 이미지 간 차등 배분 이득은 80% 유지됐습니다 (+34.2%p → +27.3%p, 275문항 중간집계) — 게이트 1은 통과 방향</a:t>
+              <a:t>→ 다만 좋은 소식도 있습니다: 이미지 간 차등 배분 이득(+30.7%p)은 이미지 순서를 뒤집어도 80% 유지됐습니다 — 위치 때문에 생긴 착시가 아닙니다</a:t>
             </a:r>
             <a:endParaRPr lang="en-US" sz="1300" dirty="0"/>
           </a:p>
@@ -8253,36 +8508,866 @@
                 <a:ea typeface="Arial" pitchFamily="34" charset="-122"/>
                 <a:cs typeface="Arial" pitchFamily="34" charset="-120"/>
               </a:rPr>
-              <a:t>컨트롤러 신호를 층·head별로 전수 탐색한 결과</a:t>
+              <a:t>"적응적"이라는 표현은 못 쓴다 — 문항마다 깊이를 바꿀 필요가 없었다</a:t>
             </a:r>
             <a:endParaRPr lang="en-US" sz="2300" dirty="0"/>
           </a:p>
         </p:txBody>
       </p:sp>
-      <p:pic>
-        <p:nvPicPr>
-          <p:cNvPr id="4" name="Image 0" descr="/Users/hansangmin/Source-Depth/results/fig4_controller_feature_sweep.png">    </p:cNvPr>
-          <p:cNvPicPr>
-            <a:picLocks noChangeAspect="1"/>
-          </p:cNvPicPr>
-          <p:nvPr/>
-        </p:nvPicPr>
-        <p:blipFill>
-          <a:blip r:embed="rId1"/>
-          <a:stretch>
-            <a:fillRect/>
-          </a:stretch>
-        </p:blipFill>
-        <p:spPr>
-          <a:xfrm>
-            <a:off x="731520" y="1554480"/>
-            <a:ext cx="10698480" cy="3931920"/>
-          </a:xfrm>
-          <a:prstGeom prst="rect">
-            <a:avLst/>
-          </a:prstGeom>
-        </p:spPr>
-      </p:pic>
+      <p:graphicFrame>
+        <p:nvGraphicFramePr>
+          <p:cNvPr id="10" name="Table 0"/>
+          <p:cNvGraphicFramePr>
+            <a:graphicFrameLocks noGrp="1"/>
+          </p:cNvGraphicFramePr>
+          <p:nvPr>
+            <p:extLst>
+              <p:ext uri="{D42A27DB-BD31-4B8C-83A1-F6EECF244321}">
+                <p14:modId xmlns:p14="http://schemas.microsoft.com/office/powerpoint/2010/main" val="1579011935"/>
+              </p:ext>
+            </p:extLst>
+          </p:nvPr>
+        </p:nvGraphicFramePr>
+        <p:xfrm>
+          <a:off x="1463040" y="1691640"/>
+          <a:ext cx="9235440" cy="1554480"/>
+        </p:xfrm>
+        <a:graphic>
+          <a:graphicData uri="http://schemas.openxmlformats.org/drawingml/2006/table">
+            <a:tbl>
+              <a:tblPr/>
+              <a:tblGrid>
+                <a:gridCol w="2308860"/>
+                <a:gridCol w="2308860"/>
+                <a:gridCol w="2308860"/>
+                <a:gridCol w="2308860"/>
+              </a:tblGrid>
+              <a:tr h="502920">
+                <a:tc>
+                  <a:txBody>
+                    <a:bodyPr/>
+                    <a:lstStyle/>
+                    <a:p>
+                      <a:pPr algn="ctr" indent="0" marL="0">
+                        <a:buNone/>
+                      </a:pPr>
+                      <a:r>
+                        <a:rPr lang="en-US" sz="1150" b="1" dirty="0">
+                          <a:solidFill>
+                            <a:srgbClr val="FFFFFF"/>
+                          </a:solidFill>
+                          <a:latin typeface="Arial" pitchFamily="34" charset="0"/>
+                          <a:ea typeface="Arial" pitchFamily="34" charset="-122"/>
+                          <a:cs typeface="Arial" pitchFamily="34" charset="-120"/>
+                        </a:rPr>
+                        <a:t>문항군</a:t>
+                      </a:r>
+                      <a:endParaRPr lang="en-US" sz="1150" dirty="0">
+                        <a:latin typeface="Arial" charset="0"/>
+                        <a:ea typeface="Arial" charset="0"/>
+                        <a:cs typeface="Arial" charset="0"/>
+                      </a:endParaRPr>
+                    </a:p>
+                  </a:txBody>
+                  <a:tcPr marL="91440" marR="91440" marT="45720" marB="45720" anchor="ctr">
+                    <a:lnL w="9525" cap="flat" cmpd="sng" algn="ctr">
+                      <a:solidFill>
+                        <a:srgbClr val="E2E8F0"/>
+                      </a:solidFill>
+                      <a:prstDash val="solid"/>
+                      <a:round/>
+                      <a:headEnd type="none" w="med" len="med"/>
+                      <a:tailEnd type="none" w="med" len="med"/>
+                    </a:lnL>
+                    <a:lnR w="9525" cap="flat" cmpd="sng" algn="ctr">
+                      <a:solidFill>
+                        <a:srgbClr val="E2E8F0"/>
+                      </a:solidFill>
+                      <a:prstDash val="solid"/>
+                      <a:round/>
+                      <a:headEnd type="none" w="med" len="med"/>
+                      <a:tailEnd type="none" w="med" len="med"/>
+                    </a:lnR>
+                    <a:lnT w="9525" cap="flat" cmpd="sng" algn="ctr">
+                      <a:solidFill>
+                        <a:srgbClr val="E2E8F0"/>
+                      </a:solidFill>
+                      <a:prstDash val="solid"/>
+                      <a:round/>
+                      <a:headEnd type="none" w="med" len="med"/>
+                      <a:tailEnd type="none" w="med" len="med"/>
+                    </a:lnT>
+                    <a:lnB w="9525" cap="flat" cmpd="sng" algn="ctr">
+                      <a:solidFill>
+                        <a:srgbClr val="E2E8F0"/>
+                      </a:solidFill>
+                      <a:prstDash val="solid"/>
+                      <a:round/>
+                      <a:headEnd type="none" w="med" len="med"/>
+                      <a:tailEnd type="none" w="med" len="med"/>
+                    </a:lnB>
+                    <a:solidFill>
+                      <a:srgbClr val="1F3B57"/>
+                    </a:solidFill>
+                  </a:tcPr>
+                </a:tc>
+                <a:tc>
+                  <a:txBody>
+                    <a:bodyPr/>
+                    <a:lstStyle/>
+                    <a:p>
+                      <a:pPr algn="ctr" indent="0" marL="0">
+                        <a:buNone/>
+                      </a:pPr>
+                      <a:r>
+                        <a:rPr lang="en-US" sz="1150" b="1" dirty="0">
+                          <a:solidFill>
+                            <a:srgbClr val="FFFFFF"/>
+                          </a:solidFill>
+                          <a:latin typeface="Arial" pitchFamily="34" charset="0"/>
+                          <a:ea typeface="Arial" pitchFamily="34" charset="-122"/>
+                          <a:cs typeface="Arial" pitchFamily="34" charset="-120"/>
+                        </a:rPr>
+                        <a:t>모든 문항에 같은 층 하나</a:t>
+                      </a:r>
+                      <a:endParaRPr lang="en-US" sz="1150" dirty="0">
+                        <a:latin typeface="Arial" charset="0"/>
+                        <a:ea typeface="Arial" charset="0"/>
+                        <a:cs typeface="Arial" charset="0"/>
+                      </a:endParaRPr>
+                    </a:p>
+                  </a:txBody>
+                  <a:tcPr marL="91440" marR="91440" marT="45720" marB="45720" anchor="ctr">
+                    <a:lnL w="9525" cap="flat" cmpd="sng" algn="ctr">
+                      <a:solidFill>
+                        <a:srgbClr val="E2E8F0"/>
+                      </a:solidFill>
+                      <a:prstDash val="solid"/>
+                      <a:round/>
+                      <a:headEnd type="none" w="med" len="med"/>
+                      <a:tailEnd type="none" w="med" len="med"/>
+                    </a:lnL>
+                    <a:lnR w="9525" cap="flat" cmpd="sng" algn="ctr">
+                      <a:solidFill>
+                        <a:srgbClr val="E2E8F0"/>
+                      </a:solidFill>
+                      <a:prstDash val="solid"/>
+                      <a:round/>
+                      <a:headEnd type="none" w="med" len="med"/>
+                      <a:tailEnd type="none" w="med" len="med"/>
+                    </a:lnR>
+                    <a:lnT w="9525" cap="flat" cmpd="sng" algn="ctr">
+                      <a:solidFill>
+                        <a:srgbClr val="E2E8F0"/>
+                      </a:solidFill>
+                      <a:prstDash val="solid"/>
+                      <a:round/>
+                      <a:headEnd type="none" w="med" len="med"/>
+                      <a:tailEnd type="none" w="med" len="med"/>
+                    </a:lnT>
+                    <a:lnB w="9525" cap="flat" cmpd="sng" algn="ctr">
+                      <a:solidFill>
+                        <a:srgbClr val="E2E8F0"/>
+                      </a:solidFill>
+                      <a:prstDash val="solid"/>
+                      <a:round/>
+                      <a:headEnd type="none" w="med" len="med"/>
+                      <a:tailEnd type="none" w="med" len="med"/>
+                    </a:lnB>
+                    <a:solidFill>
+                      <a:srgbClr val="1F3B57"/>
+                    </a:solidFill>
+                  </a:tcPr>
+                </a:tc>
+                <a:tc>
+                  <a:txBody>
+                    <a:bodyPr/>
+                    <a:lstStyle/>
+                    <a:p>
+                      <a:pPr algn="ctr" indent="0" marL="0">
+                        <a:buNone/>
+                      </a:pPr>
+                      <a:r>
+                        <a:rPr lang="en-US" sz="1150" b="1" dirty="0">
+                          <a:solidFill>
+                            <a:srgbClr val="FFFFFF"/>
+                          </a:solidFill>
+                          <a:latin typeface="Arial" pitchFamily="34" charset="0"/>
+                          <a:ea typeface="Arial" pitchFamily="34" charset="-122"/>
+                          <a:cs typeface="Arial" pitchFamily="34" charset="-120"/>
+                        </a:rPr>
+                        <a:t>문항마다 최적 층을 안다면</a:t>
+                      </a:r>
+                      <a:endParaRPr lang="en-US" sz="1150" dirty="0">
+                        <a:latin typeface="Arial" charset="0"/>
+                        <a:ea typeface="Arial" charset="0"/>
+                        <a:cs typeface="Arial" charset="0"/>
+                      </a:endParaRPr>
+                    </a:p>
+                  </a:txBody>
+                  <a:tcPr marL="91440" marR="91440" marT="45720" marB="45720" anchor="ctr">
+                    <a:lnL w="9525" cap="flat" cmpd="sng" algn="ctr">
+                      <a:solidFill>
+                        <a:srgbClr val="E2E8F0"/>
+                      </a:solidFill>
+                      <a:prstDash val="solid"/>
+                      <a:round/>
+                      <a:headEnd type="none" w="med" len="med"/>
+                      <a:tailEnd type="none" w="med" len="med"/>
+                    </a:lnL>
+                    <a:lnR w="9525" cap="flat" cmpd="sng" algn="ctr">
+                      <a:solidFill>
+                        <a:srgbClr val="E2E8F0"/>
+                      </a:solidFill>
+                      <a:prstDash val="solid"/>
+                      <a:round/>
+                      <a:headEnd type="none" w="med" len="med"/>
+                      <a:tailEnd type="none" w="med" len="med"/>
+                    </a:lnR>
+                    <a:lnT w="9525" cap="flat" cmpd="sng" algn="ctr">
+                      <a:solidFill>
+                        <a:srgbClr val="E2E8F0"/>
+                      </a:solidFill>
+                      <a:prstDash val="solid"/>
+                      <a:round/>
+                      <a:headEnd type="none" w="med" len="med"/>
+                      <a:tailEnd type="none" w="med" len="med"/>
+                    </a:lnT>
+                    <a:lnB w="9525" cap="flat" cmpd="sng" algn="ctr">
+                      <a:solidFill>
+                        <a:srgbClr val="E2E8F0"/>
+                      </a:solidFill>
+                      <a:prstDash val="solid"/>
+                      <a:round/>
+                      <a:headEnd type="none" w="med" len="med"/>
+                      <a:tailEnd type="none" w="med" len="med"/>
+                    </a:lnB>
+                    <a:solidFill>
+                      <a:srgbClr val="1F3B57"/>
+                    </a:solidFill>
+                  </a:tcPr>
+                </a:tc>
+                <a:tc>
+                  <a:txBody>
+                    <a:bodyPr/>
+                    <a:lstStyle/>
+                    <a:p>
+                      <a:pPr algn="ctr" indent="0" marL="0">
+                        <a:buNone/>
+                      </a:pPr>
+                      <a:r>
+                        <a:rPr lang="en-US" sz="1150" b="1" dirty="0">
+                          <a:solidFill>
+                            <a:srgbClr val="FFFFFF"/>
+                          </a:solidFill>
+                          <a:latin typeface="Arial" pitchFamily="34" charset="0"/>
+                          <a:ea typeface="Arial" pitchFamily="34" charset="-122"/>
+                          <a:cs typeface="Arial" pitchFamily="34" charset="-120"/>
+                        </a:rPr>
+                        <a:t>차이</a:t>
+                      </a:r>
+                      <a:endParaRPr lang="en-US" sz="1150" dirty="0">
+                        <a:latin typeface="Arial" charset="0"/>
+                        <a:ea typeface="Arial" charset="0"/>
+                        <a:cs typeface="Arial" charset="0"/>
+                      </a:endParaRPr>
+                    </a:p>
+                  </a:txBody>
+                  <a:tcPr marL="91440" marR="91440" marT="45720" marB="45720" anchor="ctr">
+                    <a:lnL w="9525" cap="flat" cmpd="sng" algn="ctr">
+                      <a:solidFill>
+                        <a:srgbClr val="E2E8F0"/>
+                      </a:solidFill>
+                      <a:prstDash val="solid"/>
+                      <a:round/>
+                      <a:headEnd type="none" w="med" len="med"/>
+                      <a:tailEnd type="none" w="med" len="med"/>
+                    </a:lnL>
+                    <a:lnR w="9525" cap="flat" cmpd="sng" algn="ctr">
+                      <a:solidFill>
+                        <a:srgbClr val="E2E8F0"/>
+                      </a:solidFill>
+                      <a:prstDash val="solid"/>
+                      <a:round/>
+                      <a:headEnd type="none" w="med" len="med"/>
+                      <a:tailEnd type="none" w="med" len="med"/>
+                    </a:lnR>
+                    <a:lnT w="9525" cap="flat" cmpd="sng" algn="ctr">
+                      <a:solidFill>
+                        <a:srgbClr val="E2E8F0"/>
+                      </a:solidFill>
+                      <a:prstDash val="solid"/>
+                      <a:round/>
+                      <a:headEnd type="none" w="med" len="med"/>
+                      <a:tailEnd type="none" w="med" len="med"/>
+                    </a:lnT>
+                    <a:lnB w="9525" cap="flat" cmpd="sng" algn="ctr">
+                      <a:solidFill>
+                        <a:srgbClr val="E2E8F0"/>
+                      </a:solidFill>
+                      <a:prstDash val="solid"/>
+                      <a:round/>
+                      <a:headEnd type="none" w="med" len="med"/>
+                      <a:tailEnd type="none" w="med" len="med"/>
+                    </a:lnB>
+                    <a:solidFill>
+                      <a:srgbClr val="1F3B57"/>
+                    </a:solidFill>
+                  </a:tcPr>
+                </a:tc>
+              </a:tr>
+              <a:tr h="502920">
+                <a:tc>
+                  <a:txBody>
+                    <a:bodyPr/>
+                    <a:lstStyle/>
+                    <a:p>
+                      <a:pPr algn="ctr" indent="0" marL="0">
+                        <a:buNone/>
+                      </a:pPr>
+                      <a:r>
+                        <a:rPr lang="en-US" sz="1150" b="1" dirty="0">
+                          <a:solidFill>
+                            <a:srgbClr val="1F3B57"/>
+                          </a:solidFill>
+                          <a:latin typeface="Arial" pitchFamily="34" charset="0"/>
+                          <a:ea typeface="Arial" pitchFamily="34" charset="-122"/>
+                          <a:cs typeface="Arial" pitchFamily="34" charset="-120"/>
+                        </a:rPr>
+                        <a:t>셀 1 (n=150)</a:t>
+                      </a:r>
+                      <a:endParaRPr lang="en-US" sz="1150" dirty="0">
+                        <a:latin typeface="Arial" charset="0"/>
+                        <a:ea typeface="Arial" charset="0"/>
+                        <a:cs typeface="Arial" charset="0"/>
+                      </a:endParaRPr>
+                    </a:p>
+                  </a:txBody>
+                  <a:tcPr marL="91440" marR="91440" marT="45720" marB="45720" anchor="ctr">
+                    <a:lnL w="9525" cap="flat" cmpd="sng" algn="ctr">
+                      <a:solidFill>
+                        <a:srgbClr val="E2E8F0"/>
+                      </a:solidFill>
+                      <a:prstDash val="solid"/>
+                      <a:round/>
+                      <a:headEnd type="none" w="med" len="med"/>
+                      <a:tailEnd type="none" w="med" len="med"/>
+                    </a:lnL>
+                    <a:lnR w="9525" cap="flat" cmpd="sng" algn="ctr">
+                      <a:solidFill>
+                        <a:srgbClr val="E2E8F0"/>
+                      </a:solidFill>
+                      <a:prstDash val="solid"/>
+                      <a:round/>
+                      <a:headEnd type="none" w="med" len="med"/>
+                      <a:tailEnd type="none" w="med" len="med"/>
+                    </a:lnR>
+                    <a:lnT w="9525" cap="flat" cmpd="sng" algn="ctr">
+                      <a:solidFill>
+                        <a:srgbClr val="E2E8F0"/>
+                      </a:solidFill>
+                      <a:prstDash val="solid"/>
+                      <a:round/>
+                      <a:headEnd type="none" w="med" len="med"/>
+                      <a:tailEnd type="none" w="med" len="med"/>
+                    </a:lnT>
+                    <a:lnB w="9525" cap="flat" cmpd="sng" algn="ctr">
+                      <a:solidFill>
+                        <a:srgbClr val="E2E8F0"/>
+                      </a:solidFill>
+                      <a:prstDash val="solid"/>
+                      <a:round/>
+                      <a:headEnd type="none" w="med" len="med"/>
+                      <a:tailEnd type="none" w="med" len="med"/>
+                    </a:lnB>
+                    <a:solidFill>
+                      <a:srgbClr val="FFFFFF"/>
+                    </a:solidFill>
+                  </a:tcPr>
+                </a:tc>
+                <a:tc>
+                  <a:txBody>
+                    <a:bodyPr/>
+                    <a:lstStyle/>
+                    <a:p>
+                      <a:pPr algn="ctr" indent="0" marL="0">
+                        <a:buNone/>
+                      </a:pPr>
+                      <a:r>
+                        <a:rPr lang="en-US" sz="1150" dirty="0">
+                          <a:solidFill>
+                            <a:srgbClr val="1F3B57"/>
+                          </a:solidFill>
+                          <a:latin typeface="Arial" pitchFamily="34" charset="0"/>
+                          <a:ea typeface="Arial" pitchFamily="34" charset="-122"/>
+                          <a:cs typeface="Arial" pitchFamily="34" charset="-120"/>
+                        </a:rPr>
+                        <a:t>0.933</a:t>
+                      </a:r>
+                      <a:endParaRPr lang="en-US" sz="1150" dirty="0">
+                        <a:latin typeface="Arial" charset="0"/>
+                        <a:ea typeface="Arial" charset="0"/>
+                        <a:cs typeface="Arial" charset="0"/>
+                      </a:endParaRPr>
+                    </a:p>
+                  </a:txBody>
+                  <a:tcPr marL="91440" marR="91440" marT="45720" marB="45720" anchor="ctr">
+                    <a:lnL w="9525" cap="flat" cmpd="sng" algn="ctr">
+                      <a:solidFill>
+                        <a:srgbClr val="E2E8F0"/>
+                      </a:solidFill>
+                      <a:prstDash val="solid"/>
+                      <a:round/>
+                      <a:headEnd type="none" w="med" len="med"/>
+                      <a:tailEnd type="none" w="med" len="med"/>
+                    </a:lnL>
+                    <a:lnR w="9525" cap="flat" cmpd="sng" algn="ctr">
+                      <a:solidFill>
+                        <a:srgbClr val="E2E8F0"/>
+                      </a:solidFill>
+                      <a:prstDash val="solid"/>
+                      <a:round/>
+                      <a:headEnd type="none" w="med" len="med"/>
+                      <a:tailEnd type="none" w="med" len="med"/>
+                    </a:lnR>
+                    <a:lnT w="9525" cap="flat" cmpd="sng" algn="ctr">
+                      <a:solidFill>
+                        <a:srgbClr val="E2E8F0"/>
+                      </a:solidFill>
+                      <a:prstDash val="solid"/>
+                      <a:round/>
+                      <a:headEnd type="none" w="med" len="med"/>
+                      <a:tailEnd type="none" w="med" len="med"/>
+                    </a:lnT>
+                    <a:lnB w="9525" cap="flat" cmpd="sng" algn="ctr">
+                      <a:solidFill>
+                        <a:srgbClr val="E2E8F0"/>
+                      </a:solidFill>
+                      <a:prstDash val="solid"/>
+                      <a:round/>
+                      <a:headEnd type="none" w="med" len="med"/>
+                      <a:tailEnd type="none" w="med" len="med"/>
+                    </a:lnB>
+                    <a:solidFill>
+                      <a:srgbClr val="FFFFFF"/>
+                    </a:solidFill>
+                  </a:tcPr>
+                </a:tc>
+                <a:tc>
+                  <a:txBody>
+                    <a:bodyPr/>
+                    <a:lstStyle/>
+                    <a:p>
+                      <a:pPr algn="ctr" indent="0" marL="0">
+                        <a:buNone/>
+                      </a:pPr>
+                      <a:r>
+                        <a:rPr lang="en-US" sz="1150" dirty="0">
+                          <a:solidFill>
+                            <a:srgbClr val="1F3B57"/>
+                          </a:solidFill>
+                          <a:latin typeface="Arial" pitchFamily="34" charset="0"/>
+                          <a:ea typeface="Arial" pitchFamily="34" charset="-122"/>
+                          <a:cs typeface="Arial" pitchFamily="34" charset="-120"/>
+                        </a:rPr>
+                        <a:t>0.960</a:t>
+                      </a:r>
+                      <a:endParaRPr lang="en-US" sz="1150" dirty="0">
+                        <a:latin typeface="Arial" charset="0"/>
+                        <a:ea typeface="Arial" charset="0"/>
+                        <a:cs typeface="Arial" charset="0"/>
+                      </a:endParaRPr>
+                    </a:p>
+                  </a:txBody>
+                  <a:tcPr marL="91440" marR="91440" marT="45720" marB="45720" anchor="ctr">
+                    <a:lnL w="9525" cap="flat" cmpd="sng" algn="ctr">
+                      <a:solidFill>
+                        <a:srgbClr val="E2E8F0"/>
+                      </a:solidFill>
+                      <a:prstDash val="solid"/>
+                      <a:round/>
+                      <a:headEnd type="none" w="med" len="med"/>
+                      <a:tailEnd type="none" w="med" len="med"/>
+                    </a:lnL>
+                    <a:lnR w="9525" cap="flat" cmpd="sng" algn="ctr">
+                      <a:solidFill>
+                        <a:srgbClr val="E2E8F0"/>
+                      </a:solidFill>
+                      <a:prstDash val="solid"/>
+                      <a:round/>
+                      <a:headEnd type="none" w="med" len="med"/>
+                      <a:tailEnd type="none" w="med" len="med"/>
+                    </a:lnR>
+                    <a:lnT w="9525" cap="flat" cmpd="sng" algn="ctr">
+                      <a:solidFill>
+                        <a:srgbClr val="E2E8F0"/>
+                      </a:solidFill>
+                      <a:prstDash val="solid"/>
+                      <a:round/>
+                      <a:headEnd type="none" w="med" len="med"/>
+                      <a:tailEnd type="none" w="med" len="med"/>
+                    </a:lnT>
+                    <a:lnB w="9525" cap="flat" cmpd="sng" algn="ctr">
+                      <a:solidFill>
+                        <a:srgbClr val="E2E8F0"/>
+                      </a:solidFill>
+                      <a:prstDash val="solid"/>
+                      <a:round/>
+                      <a:headEnd type="none" w="med" len="med"/>
+                      <a:tailEnd type="none" w="med" len="med"/>
+                    </a:lnB>
+                    <a:solidFill>
+                      <a:srgbClr val="FFFFFF"/>
+                    </a:solidFill>
+                  </a:tcPr>
+                </a:tc>
+                <a:tc>
+                  <a:txBody>
+                    <a:bodyPr/>
+                    <a:lstStyle/>
+                    <a:p>
+                      <a:pPr algn="ctr" indent="0" marL="0">
+                        <a:buNone/>
+                      </a:pPr>
+                      <a:r>
+                        <a:rPr lang="en-US" sz="1150" b="1" dirty="0">
+                          <a:solidFill>
+                            <a:srgbClr val="D62728"/>
+                          </a:solidFill>
+                          <a:latin typeface="Arial" pitchFamily="34" charset="0"/>
+                          <a:ea typeface="Arial" pitchFamily="34" charset="-122"/>
+                          <a:cs typeface="Arial" pitchFamily="34" charset="-120"/>
+                        </a:rPr>
+                        <a:t>+2.7%p</a:t>
+                      </a:r>
+                      <a:endParaRPr lang="en-US" sz="1150" dirty="0">
+                        <a:latin typeface="Arial" charset="0"/>
+                        <a:ea typeface="Arial" charset="0"/>
+                        <a:cs typeface="Arial" charset="0"/>
+                      </a:endParaRPr>
+                    </a:p>
+                  </a:txBody>
+                  <a:tcPr marL="91440" marR="91440" marT="45720" marB="45720" anchor="ctr">
+                    <a:lnL w="9525" cap="flat" cmpd="sng" algn="ctr">
+                      <a:solidFill>
+                        <a:srgbClr val="E2E8F0"/>
+                      </a:solidFill>
+                      <a:prstDash val="solid"/>
+                      <a:round/>
+                      <a:headEnd type="none" w="med" len="med"/>
+                      <a:tailEnd type="none" w="med" len="med"/>
+                    </a:lnL>
+                    <a:lnR w="9525" cap="flat" cmpd="sng" algn="ctr">
+                      <a:solidFill>
+                        <a:srgbClr val="E2E8F0"/>
+                      </a:solidFill>
+                      <a:prstDash val="solid"/>
+                      <a:round/>
+                      <a:headEnd type="none" w="med" len="med"/>
+                      <a:tailEnd type="none" w="med" len="med"/>
+                    </a:lnR>
+                    <a:lnT w="9525" cap="flat" cmpd="sng" algn="ctr">
+                      <a:solidFill>
+                        <a:srgbClr val="E2E8F0"/>
+                      </a:solidFill>
+                      <a:prstDash val="solid"/>
+                      <a:round/>
+                      <a:headEnd type="none" w="med" len="med"/>
+                      <a:tailEnd type="none" w="med" len="med"/>
+                    </a:lnT>
+                    <a:lnB w="9525" cap="flat" cmpd="sng" algn="ctr">
+                      <a:solidFill>
+                        <a:srgbClr val="E2E8F0"/>
+                      </a:solidFill>
+                      <a:prstDash val="solid"/>
+                      <a:round/>
+                      <a:headEnd type="none" w="med" len="med"/>
+                      <a:tailEnd type="none" w="med" len="med"/>
+                    </a:lnB>
+                    <a:solidFill>
+                      <a:srgbClr val="FFFFFF"/>
+                    </a:solidFill>
+                  </a:tcPr>
+                </a:tc>
+              </a:tr>
+              <a:tr h="502920">
+                <a:tc>
+                  <a:txBody>
+                    <a:bodyPr/>
+                    <a:lstStyle/>
+                    <a:p>
+                      <a:pPr algn="ctr" indent="0" marL="0">
+                        <a:buNone/>
+                      </a:pPr>
+                      <a:r>
+                        <a:rPr lang="en-US" sz="1150" b="1" dirty="0">
+                          <a:solidFill>
+                            <a:srgbClr val="1F3B57"/>
+                          </a:solidFill>
+                          <a:latin typeface="Arial" pitchFamily="34" charset="0"/>
+                          <a:ea typeface="Arial" pitchFamily="34" charset="-122"/>
+                          <a:cs typeface="Arial" pitchFamily="34" charset="-120"/>
+                        </a:rPr>
+                        <a:t>셀 2 (n=150)</a:t>
+                      </a:r>
+                      <a:endParaRPr lang="en-US" sz="1150" dirty="0">
+                        <a:latin typeface="Arial" charset="0"/>
+                        <a:ea typeface="Arial" charset="0"/>
+                        <a:cs typeface="Arial" charset="0"/>
+                      </a:endParaRPr>
+                    </a:p>
+                  </a:txBody>
+                  <a:tcPr marL="91440" marR="91440" marT="45720" marB="45720" anchor="ctr">
+                    <a:lnL w="9525" cap="flat" cmpd="sng" algn="ctr">
+                      <a:solidFill>
+                        <a:srgbClr val="E2E8F0"/>
+                      </a:solidFill>
+                      <a:prstDash val="solid"/>
+                      <a:round/>
+                      <a:headEnd type="none" w="med" len="med"/>
+                      <a:tailEnd type="none" w="med" len="med"/>
+                    </a:lnL>
+                    <a:lnR w="9525" cap="flat" cmpd="sng" algn="ctr">
+                      <a:solidFill>
+                        <a:srgbClr val="E2E8F0"/>
+                      </a:solidFill>
+                      <a:prstDash val="solid"/>
+                      <a:round/>
+                      <a:headEnd type="none" w="med" len="med"/>
+                      <a:tailEnd type="none" w="med" len="med"/>
+                    </a:lnR>
+                    <a:lnT w="9525" cap="flat" cmpd="sng" algn="ctr">
+                      <a:solidFill>
+                        <a:srgbClr val="E2E8F0"/>
+                      </a:solidFill>
+                      <a:prstDash val="solid"/>
+                      <a:round/>
+                      <a:headEnd type="none" w="med" len="med"/>
+                      <a:tailEnd type="none" w="med" len="med"/>
+                    </a:lnT>
+                    <a:lnB w="9525" cap="flat" cmpd="sng" algn="ctr">
+                      <a:solidFill>
+                        <a:srgbClr val="E2E8F0"/>
+                      </a:solidFill>
+                      <a:prstDash val="solid"/>
+                      <a:round/>
+                      <a:headEnd type="none" w="med" len="med"/>
+                      <a:tailEnd type="none" w="med" len="med"/>
+                    </a:lnB>
+                    <a:solidFill>
+                      <a:srgbClr val="FFFFFF"/>
+                    </a:solidFill>
+                  </a:tcPr>
+                </a:tc>
+                <a:tc>
+                  <a:txBody>
+                    <a:bodyPr/>
+                    <a:lstStyle/>
+                    <a:p>
+                      <a:pPr algn="ctr" indent="0" marL="0">
+                        <a:buNone/>
+                      </a:pPr>
+                      <a:r>
+                        <a:rPr lang="en-US" sz="1150" dirty="0">
+                          <a:solidFill>
+                            <a:srgbClr val="1F3B57"/>
+                          </a:solidFill>
+                          <a:latin typeface="Arial" pitchFamily="34" charset="0"/>
+                          <a:ea typeface="Arial" pitchFamily="34" charset="-122"/>
+                          <a:cs typeface="Arial" pitchFamily="34" charset="-120"/>
+                        </a:rPr>
+                        <a:t>0.720</a:t>
+                      </a:r>
+                      <a:endParaRPr lang="en-US" sz="1150" dirty="0">
+                        <a:latin typeface="Arial" charset="0"/>
+                        <a:ea typeface="Arial" charset="0"/>
+                        <a:cs typeface="Arial" charset="0"/>
+                      </a:endParaRPr>
+                    </a:p>
+                  </a:txBody>
+                  <a:tcPr marL="91440" marR="91440" marT="45720" marB="45720" anchor="ctr">
+                    <a:lnL w="9525" cap="flat" cmpd="sng" algn="ctr">
+                      <a:solidFill>
+                        <a:srgbClr val="E2E8F0"/>
+                      </a:solidFill>
+                      <a:prstDash val="solid"/>
+                      <a:round/>
+                      <a:headEnd type="none" w="med" len="med"/>
+                      <a:tailEnd type="none" w="med" len="med"/>
+                    </a:lnL>
+                    <a:lnR w="9525" cap="flat" cmpd="sng" algn="ctr">
+                      <a:solidFill>
+                        <a:srgbClr val="E2E8F0"/>
+                      </a:solidFill>
+                      <a:prstDash val="solid"/>
+                      <a:round/>
+                      <a:headEnd type="none" w="med" len="med"/>
+                      <a:tailEnd type="none" w="med" len="med"/>
+                    </a:lnR>
+                    <a:lnT w="9525" cap="flat" cmpd="sng" algn="ctr">
+                      <a:solidFill>
+                        <a:srgbClr val="E2E8F0"/>
+                      </a:solidFill>
+                      <a:prstDash val="solid"/>
+                      <a:round/>
+                      <a:headEnd type="none" w="med" len="med"/>
+                      <a:tailEnd type="none" w="med" len="med"/>
+                    </a:lnT>
+                    <a:lnB w="9525" cap="flat" cmpd="sng" algn="ctr">
+                      <a:solidFill>
+                        <a:srgbClr val="E2E8F0"/>
+                      </a:solidFill>
+                      <a:prstDash val="solid"/>
+                      <a:round/>
+                      <a:headEnd type="none" w="med" len="med"/>
+                      <a:tailEnd type="none" w="med" len="med"/>
+                    </a:lnB>
+                    <a:solidFill>
+                      <a:srgbClr val="FFFFFF"/>
+                    </a:solidFill>
+                  </a:tcPr>
+                </a:tc>
+                <a:tc>
+                  <a:txBody>
+                    <a:bodyPr/>
+                    <a:lstStyle/>
+                    <a:p>
+                      <a:pPr algn="ctr" indent="0" marL="0">
+                        <a:buNone/>
+                      </a:pPr>
+                      <a:r>
+                        <a:rPr lang="en-US" sz="1150" dirty="0">
+                          <a:solidFill>
+                            <a:srgbClr val="1F3B57"/>
+                          </a:solidFill>
+                          <a:latin typeface="Arial" pitchFamily="34" charset="0"/>
+                          <a:ea typeface="Arial" pitchFamily="34" charset="-122"/>
+                          <a:cs typeface="Arial" pitchFamily="34" charset="-120"/>
+                        </a:rPr>
+                        <a:t>0.747</a:t>
+                      </a:r>
+                      <a:endParaRPr lang="en-US" sz="1150" dirty="0">
+                        <a:latin typeface="Arial" charset="0"/>
+                        <a:ea typeface="Arial" charset="0"/>
+                        <a:cs typeface="Arial" charset="0"/>
+                      </a:endParaRPr>
+                    </a:p>
+                  </a:txBody>
+                  <a:tcPr marL="91440" marR="91440" marT="45720" marB="45720" anchor="ctr">
+                    <a:lnL w="9525" cap="flat" cmpd="sng" algn="ctr">
+                      <a:solidFill>
+                        <a:srgbClr val="E2E8F0"/>
+                      </a:solidFill>
+                      <a:prstDash val="solid"/>
+                      <a:round/>
+                      <a:headEnd type="none" w="med" len="med"/>
+                      <a:tailEnd type="none" w="med" len="med"/>
+                    </a:lnL>
+                    <a:lnR w="9525" cap="flat" cmpd="sng" algn="ctr">
+                      <a:solidFill>
+                        <a:srgbClr val="E2E8F0"/>
+                      </a:solidFill>
+                      <a:prstDash val="solid"/>
+                      <a:round/>
+                      <a:headEnd type="none" w="med" len="med"/>
+                      <a:tailEnd type="none" w="med" len="med"/>
+                    </a:lnR>
+                    <a:lnT w="9525" cap="flat" cmpd="sng" algn="ctr">
+                      <a:solidFill>
+                        <a:srgbClr val="E2E8F0"/>
+                      </a:solidFill>
+                      <a:prstDash val="solid"/>
+                      <a:round/>
+                      <a:headEnd type="none" w="med" len="med"/>
+                      <a:tailEnd type="none" w="med" len="med"/>
+                    </a:lnT>
+                    <a:lnB w="9525" cap="flat" cmpd="sng" algn="ctr">
+                      <a:solidFill>
+                        <a:srgbClr val="E2E8F0"/>
+                      </a:solidFill>
+                      <a:prstDash val="solid"/>
+                      <a:round/>
+                      <a:headEnd type="none" w="med" len="med"/>
+                      <a:tailEnd type="none" w="med" len="med"/>
+                    </a:lnB>
+                    <a:solidFill>
+                      <a:srgbClr val="FFFFFF"/>
+                    </a:solidFill>
+                  </a:tcPr>
+                </a:tc>
+                <a:tc>
+                  <a:txBody>
+                    <a:bodyPr/>
+                    <a:lstStyle/>
+                    <a:p>
+                      <a:pPr algn="ctr" indent="0" marL="0">
+                        <a:buNone/>
+                      </a:pPr>
+                      <a:r>
+                        <a:rPr lang="en-US" sz="1150" b="1" dirty="0">
+                          <a:solidFill>
+                            <a:srgbClr val="D62728"/>
+                          </a:solidFill>
+                          <a:latin typeface="Arial" pitchFamily="34" charset="0"/>
+                          <a:ea typeface="Arial" pitchFamily="34" charset="-122"/>
+                          <a:cs typeface="Arial" pitchFamily="34" charset="-120"/>
+                        </a:rPr>
+                        <a:t>+2.7%p</a:t>
+                      </a:r>
+                      <a:endParaRPr lang="en-US" sz="1150" dirty="0">
+                        <a:latin typeface="Arial" charset="0"/>
+                        <a:ea typeface="Arial" charset="0"/>
+                        <a:cs typeface="Arial" charset="0"/>
+                      </a:endParaRPr>
+                    </a:p>
+                  </a:txBody>
+                  <a:tcPr marL="91440" marR="91440" marT="45720" marB="45720" anchor="ctr">
+                    <a:lnL w="9525" cap="flat" cmpd="sng" algn="ctr">
+                      <a:solidFill>
+                        <a:srgbClr val="E2E8F0"/>
+                      </a:solidFill>
+                      <a:prstDash val="solid"/>
+                      <a:round/>
+                      <a:headEnd type="none" w="med" len="med"/>
+                      <a:tailEnd type="none" w="med" len="med"/>
+                    </a:lnL>
+                    <a:lnR w="9525" cap="flat" cmpd="sng" algn="ctr">
+                      <a:solidFill>
+                        <a:srgbClr val="E2E8F0"/>
+                      </a:solidFill>
+                      <a:prstDash val="solid"/>
+                      <a:round/>
+                      <a:headEnd type="none" w="med" len="med"/>
+                      <a:tailEnd type="none" w="med" len="med"/>
+                    </a:lnR>
+                    <a:lnT w="9525" cap="flat" cmpd="sng" algn="ctr">
+                      <a:solidFill>
+                        <a:srgbClr val="E2E8F0"/>
+                      </a:solidFill>
+                      <a:prstDash val="solid"/>
+                      <a:round/>
+                      <a:headEnd type="none" w="med" len="med"/>
+                      <a:tailEnd type="none" w="med" len="med"/>
+                    </a:lnT>
+                    <a:lnB w="9525" cap="flat" cmpd="sng" algn="ctr">
+                      <a:solidFill>
+                        <a:srgbClr val="E2E8F0"/>
+                      </a:solidFill>
+                      <a:prstDash val="solid"/>
+                      <a:round/>
+                      <a:headEnd type="none" w="med" len="med"/>
+                      <a:tailEnd type="none" w="med" len="med"/>
+                    </a:lnB>
+                    <a:solidFill>
+                      <a:srgbClr val="FFFFFF"/>
+                    </a:solidFill>
+                  </a:tcPr>
+                </a:tc>
+              </a:tr>
+            </a:tbl>
+          </a:graphicData>
+        </a:graphic>
+      </p:graphicFrame>
       <p:sp>
         <p:nvSpPr>
           <p:cNvPr id="5" name="Text 2"/>
@@ -8291,8 +9376,8 @@
         </p:nvSpPr>
         <p:spPr>
           <a:xfrm>
-            <a:off x="502920" y="5852160"/>
-            <a:ext cx="11155680" cy="548640"/>
+            <a:off x="914400" y="3566160"/>
+            <a:ext cx="10424160" cy="2103120"/>
           </a:xfrm>
           <a:prstGeom prst="rect">
             <a:avLst/>
@@ -8304,11 +9389,117 @@
           <a:bodyPr wrap="square" lIns="0" tIns="0" rIns="0" bIns="0" rtlCol="0" anchor="ctr"/>
           <a:lstStyle/>
           <a:p>
-            <a:pPr indent="0" marL="0">
-              <a:buNone/>
-            </a:pPr>
-            <a:r>
-              <a:rPr lang="en-US" sz="1100" dirty="0">
+            <a:pPr marL="342900" indent="-342900">
+              <a:spcAft>
+                <a:spcPts val="900"/>
+              </a:spcAft>
+              <a:buSzPct val="100000"/>
+              <a:buChar char="•"/>
+            </a:pPr>
+            <a:r>
+              <a:rPr lang="en-US" sz="1250" dirty="0">
+                <a:solidFill>
+                  <a:srgbClr val="1F3B57"/>
+                </a:solidFill>
+                <a:latin typeface="Arial" pitchFamily="34" charset="0"/>
+                <a:ea typeface="Arial" pitchFamily="34" charset="-122"/>
+                <a:cs typeface="Arial" pitchFamily="34" charset="-120"/>
+              </a:rPr>
+              <a:t>문항의 66%는 어느 층에서 끊어도 정답이라, 문항별로 최적화할 여지 자체가 거의 없다</a:t>
+            </a:r>
+            <a:endParaRPr lang="en-US" sz="1250" dirty="0"/>
+          </a:p>
+          <a:p>
+            <a:pPr marL="342900" indent="-342900">
+              <a:spcAft>
+                <a:spcPts val="900"/>
+              </a:spcAft>
+              <a:buSzPct val="100000"/>
+              <a:buChar char="•"/>
+            </a:pPr>
+            <a:r>
+              <a:rPr lang="en-US" sz="1250" dirty="0">
+                <a:solidFill>
+                  <a:srgbClr val="1F3B57"/>
+                </a:solidFill>
+                <a:latin typeface="Arial" pitchFamily="34" charset="0"/>
+                <a:ea typeface="Arial" pitchFamily="34" charset="-122"/>
+                <a:cs typeface="Arial" pitchFamily="34" charset="-120"/>
+              </a:rPr>
+              <a:t>즉 필요한 것은 '문항마다 조절하는 컨트롤러'가 아니라 '고정 스케줄 하나 + 어느 이미지가 방해인지'뿐이다</a:t>
+            </a:r>
+            <a:endParaRPr lang="en-US" sz="1250" dirty="0"/>
+          </a:p>
+          <a:p>
+            <a:pPr marL="342900" indent="-342900">
+              <a:spcAft>
+                <a:spcPts val="900"/>
+              </a:spcAft>
+              <a:buSzPct val="100000"/>
+              <a:buChar char="•"/>
+            </a:pPr>
+            <a:r>
+              <a:rPr lang="en-US" sz="1250" dirty="0">
+                <a:solidFill>
+                  <a:srgbClr val="1F3B57"/>
+                </a:solidFill>
+                <a:latin typeface="Arial" pitchFamily="34" charset="0"/>
+                <a:ea typeface="Arial" pitchFamily="34" charset="-122"/>
+                <a:cs typeface="Arial" pitchFamily="34" charset="-120"/>
+              </a:rPr>
+              <a:t>선행연구도 같은 방향 — γ-MoD(ICLR'25)는 깊이 여유도를 오프라인 50샘플로 한 번 정하고 고정한다</a:t>
+            </a:r>
+            <a:endParaRPr lang="en-US" sz="1250" dirty="0"/>
+          </a:p>
+          <a:p>
+            <a:pPr marL="342900" indent="-342900">
+              <a:spcAft>
+                <a:spcPts val="900"/>
+              </a:spcAft>
+              <a:buSzPct val="100000"/>
+              <a:buChar char="•"/>
+            </a:pPr>
+            <a:r>
+              <a:rPr lang="en-US" sz="1250" b="1" dirty="0">
+                <a:solidFill>
+                  <a:srgbClr val="1F3B57"/>
+                </a:solidFill>
+                <a:latin typeface="Arial" pitchFamily="34" charset="0"/>
+                <a:ea typeface="Arial" pitchFamily="34" charset="-122"/>
+                <a:cs typeface="Arial" pitchFamily="34" charset="-120"/>
+              </a:rPr>
+              <a:t>→ 나쁜 소식: 연구 이름의 "적응적"을 못 쓴다.  좋은 소식: 방법이 훨씬 단순해진다</a:t>
+            </a:r>
+            <a:endParaRPr lang="en-US" sz="1250" dirty="0"/>
+          </a:p>
+        </p:txBody>
+      </p:sp>
+      <p:sp>
+        <p:nvSpPr>
+          <p:cNvPr id="6" name="Text 3"/>
+          <p:cNvSpPr/>
+          <p:nvPr/>
+        </p:nvSpPr>
+        <p:spPr>
+          <a:xfrm>
+            <a:off x="914400" y="5760720"/>
+            <a:ext cx="10424160" cy="365760"/>
+          </a:xfrm>
+          <a:prstGeom prst="rect">
+            <a:avLst/>
+          </a:prstGeom>
+          <a:noFill/>
+          <a:ln/>
+        </p:spPr>
+        <p:txBody>
+          <a:bodyPr wrap="square" lIns="0" tIns="0" rIns="0" bIns="0" rtlCol="0" anchor="ctr"/>
+          <a:lstStyle/>
+          <a:p>
+            <a:pPr indent="0" marL="0">
+              <a:buNone/>
+            </a:pPr>
+            <a:r>
+              <a:rPr lang="en-US" sz="1100" i="1" dirty="0">
                 <a:solidFill>
                   <a:srgbClr val="6B7280"/>
                 </a:solidFill>
@@ -8316,7 +9507,7 @@
                 <a:ea typeface="Arial" pitchFamily="34" charset="-122"/>
                 <a:cs typeface="Arial" pitchFamily="34" charset="-120"/>
               </a:rPr>
-              <a:t>순서를 뒤집어도 맞는 head: 얕은 층 0.31~0.51(무작위), layer 22에서 0.882가 최고. 개입이 유효한 구간은 16층 이전</a:t>
+              <a:t>※ '이미지 간' 차등(방해는 얕게, 관련은 깊게)은 이것과 별개이며 유효하다 — 본편 참조</a:t>
             </a:r>
             <a:endParaRPr lang="en-US" sz="1100" dirty="0"/>
           </a:p>

</xml_diff>

<commit_message>
Make the allocation result self-explanatory; lead the cover with the causal number
- Cover card 1 now leads with the two strongest, least contestable results
  (81% recovery, 0.79->0.50 reverse control) instead of the allocation gain
- Slide 4 takeaway states the allocation result in plain words rather than the
  jargon phrase '이미지 간 차등 배분 이득'
- Slide 4 headline no longer claims the per-image premise failed — that claim
  contradicted the slide's own takeaway; it now names what actually broke
- New appendix slide spells out the allocation comparison as a table (same total
  compute, 16+16 vs 4+28) and states the weak-baseline limitation explicitly

Co-Authored-By: Claude Fable 5 <noreply@anthropic.com>
</commit_message>
<xml_diff>
--- a/meeting/SourceDepth_meeting_FINAL.pptx
+++ b/meeting/SourceDepth_meeting_FINAL.pptx
@@ -952,7 +952,7 @@
           <a:p>
             <a:r>
               <a:rPr lang="en-US" dirty="0"/>
-              <a:t>이 세 개가 오늘 보고의 중심입니다. 특히 첫 번째 — 순서를 뒤집었더니 신호가 무너진 것 — 은 제 방법만의 문제가 아니라 얕은 층 attention을 쓰는 기존 방법들에도 해당됩니다.</a:t>
+              <a:t>이 세 개가 오늘 보고의 중심입니다. 특히 첫 번째 — 순서를 뒤집었더니 신호가 무너진 것 — 은 제 방법만의 문제가 아니라 얕은 층 attention을 쓰는 기존 방법들에도 해당됩니다. 두 번째는 더 단순합니다 — 계산량을 42% 줄여도 실제 응답 시간은 10%밖에 안 줄었습니다. 이론과 실측이 이만큼 벌어지면 효율성을 기여로 내세울 수 없습니다. 다만 아래 결론처럼, 같은 계산량 안에서 방해 이미지를 먼저 끊는 배분 자체는 순서를 뒤집어도 살아남았습니다.</a:t>
             </a:r>
             <a:endParaRPr lang="en-US" dirty="0"/>
           </a:p>
@@ -2027,7 +2027,7 @@
                 <a:ea typeface="Arial" pitchFamily="34" charset="-122"/>
                 <a:cs typeface="Arial" pitchFamily="34" charset="-120"/>
               </a:rPr>
-              <a:t>차단하면 81%가 회복된다.</a:t>
+              <a:t>그 이미지를 차단하면 오답의 81%가 회복된다.</a:t>
             </a:r>
             <a:endParaRPr lang="en-US" sz="1250" dirty="0"/>
           </a:p>
@@ -2047,7 +2047,7 @@
                 <a:ea typeface="Arial" pitchFamily="34" charset="-122"/>
                 <a:cs typeface="Arial" pitchFamily="34" charset="-120"/>
               </a:rPr>
-              <a:t>이미지 간 차등 배분 이득 +30.7%p (위치 무관)</a:t>
+              <a:t>반대로 정답 이미지를 자르면 0.79 → 0.50으로 붕괴</a:t>
             </a:r>
             <a:endParaRPr lang="en-US" sz="1250" dirty="0"/>
           </a:p>
@@ -2086,7 +2086,7 @@
                 <a:ea typeface="Arial" pitchFamily="34" charset="-122"/>
                 <a:cs typeface="Arial" pitchFamily="34" charset="-120"/>
               </a:rPr>
-              <a:t>인과까지 확인 (p=4×10⁻³⁸)</a:t>
+              <a:t>부작용은 3.7%뿐 · p = 6×10⁻⁷ / 4×10⁻³⁸</a:t>
             </a:r>
             <a:endParaRPr lang="en-US" sz="1100" dirty="0"/>
           </a:p>
@@ -4912,7 +4912,7 @@
                 <a:ea typeface="Arial" pitchFamily="34" charset="-122"/>
                 <a:cs typeface="Arial" pitchFamily="34" charset="-120"/>
               </a:rPr>
-              <a:t>"이미지마다 다르게"라는 전제 자체가 성립하지 않았다</a:t>
+              <a:t>어느 이미지가 방해인지 스스로 알아내지 못했고, 속도 이득도 실현되지 않았다</a:t>
             </a:r>
             <a:endParaRPr lang="en-US" sz="2300" dirty="0"/>
           </a:p>
@@ -5671,7 +5671,7 @@
                 <a:ea typeface="Arial" pitchFamily="34" charset="-122"/>
                 <a:cs typeface="Arial" pitchFamily="34" charset="-120"/>
               </a:rPr>
-              <a:t>→ 다만 좋은 소식도 있습니다: 이미지 간 차등 배분 이득(+30.7%p)은 이미지 순서를 뒤집어도 80% 유지됐습니다 — 위치 때문에 생긴 착시가 아닙니다</a:t>
+              <a:t>→ 다만 좋은 소식 하나: 계산량이 같을 때 '방해 이미지를 먼저 끊는' 배분이 '둘 다 똑같이 끊는' 것보다 나았고, 이미지 순서를 뒤집어도 그 이득의 80%가 유지됐습니다</a:t>
             </a:r>
             <a:endParaRPr lang="en-US" sz="1300" dirty="0"/>
           </a:p>
@@ -8342,36 +8342,1060 @@
                 <a:ea typeface="Arial" pitchFamily="34" charset="-122"/>
                 <a:cs typeface="Arial" pitchFamily="34" charset="-120"/>
               </a:rPr>
-              <a:t>같은 예산에서 배분만 바꿨을 때 (oracle 조건)</a:t>
+              <a:t>계산량은 똑같이 두고 배분만 바꿨을 때 (어느 쪽이 방해인지 아는 조건)</a:t>
             </a:r>
             <a:endParaRPr lang="en-US" sz="2300" dirty="0"/>
           </a:p>
         </p:txBody>
       </p:sp>
-      <p:pic>
-        <p:nvPicPr>
-          <p:cNvPr id="4" name="Image 0" descr="/Users/hansangmin/Source-Depth/results/fig5_allocation_vs_uniform.png">    </p:cNvPr>
-          <p:cNvPicPr>
-            <a:picLocks noChangeAspect="1"/>
-          </p:cNvPicPr>
-          <p:nvPr/>
-        </p:nvPicPr>
-        <p:blipFill>
-          <a:blip r:embed="rId1"/>
-          <a:stretch>
-            <a:fillRect/>
-          </a:stretch>
-        </p:blipFill>
-        <p:spPr>
-          <a:xfrm>
-            <a:off x="548640" y="1463040"/>
-            <a:ext cx="11064240" cy="3931920"/>
-          </a:xfrm>
-          <a:prstGeom prst="rect">
-            <a:avLst/>
-          </a:prstGeom>
-        </p:spPr>
-      </p:pic>
+      <p:graphicFrame>
+        <p:nvGraphicFramePr>
+          <p:cNvPr id="9" name="Table 0"/>
+          <p:cNvGraphicFramePr>
+            <a:graphicFrameLocks noGrp="1"/>
+          </p:cNvGraphicFramePr>
+          <p:nvPr>
+            <p:extLst>
+              <p:ext uri="{D42A27DB-BD31-4B8C-83A1-F6EECF244321}">
+                <p14:modId xmlns:p14="http://schemas.microsoft.com/office/powerpoint/2010/main" val="1579011935"/>
+              </p:ext>
+            </p:extLst>
+          </p:nvPr>
+        </p:nvGraphicFramePr>
+        <p:xfrm>
+          <a:off x="1188720" y="1783080"/>
+          <a:ext cx="9784080" cy="1645920"/>
+        </p:xfrm>
+        <a:graphic>
+          <a:graphicData uri="http://schemas.openxmlformats.org/drawingml/2006/table">
+            <a:tbl>
+              <a:tblPr/>
+              <a:tblGrid>
+                <a:gridCol w="1956816"/>
+                <a:gridCol w="1956816"/>
+                <a:gridCol w="1956816"/>
+                <a:gridCol w="1956816"/>
+                <a:gridCol w="1956816"/>
+              </a:tblGrid>
+              <a:tr h="548640">
+                <a:tc>
+                  <a:txBody>
+                    <a:bodyPr/>
+                    <a:lstStyle/>
+                    <a:p>
+                      <a:pPr algn="ctr" indent="0" marL="0">
+                        <a:buNone/>
+                      </a:pPr>
+                      <a:endParaRPr lang="en-US" sz="1200" dirty="0">
+                        <a:latin typeface="Arial" charset="0"/>
+                        <a:ea typeface="Arial" charset="0"/>
+                        <a:cs typeface="Arial" charset="0"/>
+                      </a:endParaRPr>
+                    </a:p>
+                  </a:txBody>
+                  <a:tcPr marL="91440" marR="91440" marT="45720" marB="45720" anchor="ctr">
+                    <a:lnL w="9525" cap="flat" cmpd="sng" algn="ctr">
+                      <a:solidFill>
+                        <a:srgbClr val="E2E8F0"/>
+                      </a:solidFill>
+                      <a:prstDash val="solid"/>
+                      <a:round/>
+                      <a:headEnd type="none" w="med" len="med"/>
+                      <a:tailEnd type="none" w="med" len="med"/>
+                    </a:lnL>
+                    <a:lnR w="9525" cap="flat" cmpd="sng" algn="ctr">
+                      <a:solidFill>
+                        <a:srgbClr val="E2E8F0"/>
+                      </a:solidFill>
+                      <a:prstDash val="solid"/>
+                      <a:round/>
+                      <a:headEnd type="none" w="med" len="med"/>
+                      <a:tailEnd type="none" w="med" len="med"/>
+                    </a:lnR>
+                    <a:lnT w="9525" cap="flat" cmpd="sng" algn="ctr">
+                      <a:solidFill>
+                        <a:srgbClr val="E2E8F0"/>
+                      </a:solidFill>
+                      <a:prstDash val="solid"/>
+                      <a:round/>
+                      <a:headEnd type="none" w="med" len="med"/>
+                      <a:tailEnd type="none" w="med" len="med"/>
+                    </a:lnT>
+                    <a:lnB w="9525" cap="flat" cmpd="sng" algn="ctr">
+                      <a:solidFill>
+                        <a:srgbClr val="E2E8F0"/>
+                      </a:solidFill>
+                      <a:prstDash val="solid"/>
+                      <a:round/>
+                      <a:headEnd type="none" w="med" len="med"/>
+                      <a:tailEnd type="none" w="med" len="med"/>
+                    </a:lnB>
+                    <a:solidFill>
+                      <a:srgbClr val="1F3B57"/>
+                    </a:solidFill>
+                  </a:tcPr>
+                </a:tc>
+                <a:tc>
+                  <a:txBody>
+                    <a:bodyPr/>
+                    <a:lstStyle/>
+                    <a:p>
+                      <a:pPr algn="ctr" indent="0" marL="0">
+                        <a:buNone/>
+                      </a:pPr>
+                      <a:r>
+                        <a:rPr lang="en-US" sz="1200" b="1" dirty="0">
+                          <a:solidFill>
+                            <a:srgbClr val="FFFFFF"/>
+                          </a:solidFill>
+                          <a:latin typeface="Arial" pitchFamily="34" charset="0"/>
+                          <a:ea typeface="Arial" pitchFamily="34" charset="-122"/>
+                          <a:cs typeface="Arial" pitchFamily="34" charset="-120"/>
+                        </a:rPr>
+                        <a:t>방해 이미지</a:t>
+                      </a:r>
+                      <a:endParaRPr lang="en-US" sz="1200" dirty="0">
+                        <a:latin typeface="Arial" charset="0"/>
+                        <a:ea typeface="Arial" charset="0"/>
+                        <a:cs typeface="Arial" charset="0"/>
+                      </a:endParaRPr>
+                    </a:p>
+                  </a:txBody>
+                  <a:tcPr marL="91440" marR="91440" marT="45720" marB="45720" anchor="ctr">
+                    <a:lnL w="9525" cap="flat" cmpd="sng" algn="ctr">
+                      <a:solidFill>
+                        <a:srgbClr val="E2E8F0"/>
+                      </a:solidFill>
+                      <a:prstDash val="solid"/>
+                      <a:round/>
+                      <a:headEnd type="none" w="med" len="med"/>
+                      <a:tailEnd type="none" w="med" len="med"/>
+                    </a:lnL>
+                    <a:lnR w="9525" cap="flat" cmpd="sng" algn="ctr">
+                      <a:solidFill>
+                        <a:srgbClr val="E2E8F0"/>
+                      </a:solidFill>
+                      <a:prstDash val="solid"/>
+                      <a:round/>
+                      <a:headEnd type="none" w="med" len="med"/>
+                      <a:tailEnd type="none" w="med" len="med"/>
+                    </a:lnR>
+                    <a:lnT w="9525" cap="flat" cmpd="sng" algn="ctr">
+                      <a:solidFill>
+                        <a:srgbClr val="E2E8F0"/>
+                      </a:solidFill>
+                      <a:prstDash val="solid"/>
+                      <a:round/>
+                      <a:headEnd type="none" w="med" len="med"/>
+                      <a:tailEnd type="none" w="med" len="med"/>
+                    </a:lnT>
+                    <a:lnB w="9525" cap="flat" cmpd="sng" algn="ctr">
+                      <a:solidFill>
+                        <a:srgbClr val="E2E8F0"/>
+                      </a:solidFill>
+                      <a:prstDash val="solid"/>
+                      <a:round/>
+                      <a:headEnd type="none" w="med" len="med"/>
+                      <a:tailEnd type="none" w="med" len="med"/>
+                    </a:lnB>
+                    <a:solidFill>
+                      <a:srgbClr val="1F3B57"/>
+                    </a:solidFill>
+                  </a:tcPr>
+                </a:tc>
+                <a:tc>
+                  <a:txBody>
+                    <a:bodyPr/>
+                    <a:lstStyle/>
+                    <a:p>
+                      <a:pPr algn="ctr" indent="0" marL="0">
+                        <a:buNone/>
+                      </a:pPr>
+                      <a:r>
+                        <a:rPr lang="en-US" sz="1200" b="1" dirty="0">
+                          <a:solidFill>
+                            <a:srgbClr val="FFFFFF"/>
+                          </a:solidFill>
+                          <a:latin typeface="Arial" pitchFamily="34" charset="0"/>
+                          <a:ea typeface="Arial" pitchFamily="34" charset="-122"/>
+                          <a:cs typeface="Arial" pitchFamily="34" charset="-120"/>
+                        </a:rPr>
+                        <a:t>정답 이미지</a:t>
+                      </a:r>
+                      <a:endParaRPr lang="en-US" sz="1200" dirty="0">
+                        <a:latin typeface="Arial" charset="0"/>
+                        <a:ea typeface="Arial" charset="0"/>
+                        <a:cs typeface="Arial" charset="0"/>
+                      </a:endParaRPr>
+                    </a:p>
+                  </a:txBody>
+                  <a:tcPr marL="91440" marR="91440" marT="45720" marB="45720" anchor="ctr">
+                    <a:lnL w="9525" cap="flat" cmpd="sng" algn="ctr">
+                      <a:solidFill>
+                        <a:srgbClr val="E2E8F0"/>
+                      </a:solidFill>
+                      <a:prstDash val="solid"/>
+                      <a:round/>
+                      <a:headEnd type="none" w="med" len="med"/>
+                      <a:tailEnd type="none" w="med" len="med"/>
+                    </a:lnL>
+                    <a:lnR w="9525" cap="flat" cmpd="sng" algn="ctr">
+                      <a:solidFill>
+                        <a:srgbClr val="E2E8F0"/>
+                      </a:solidFill>
+                      <a:prstDash val="solid"/>
+                      <a:round/>
+                      <a:headEnd type="none" w="med" len="med"/>
+                      <a:tailEnd type="none" w="med" len="med"/>
+                    </a:lnR>
+                    <a:lnT w="9525" cap="flat" cmpd="sng" algn="ctr">
+                      <a:solidFill>
+                        <a:srgbClr val="E2E8F0"/>
+                      </a:solidFill>
+                      <a:prstDash val="solid"/>
+                      <a:round/>
+                      <a:headEnd type="none" w="med" len="med"/>
+                      <a:tailEnd type="none" w="med" len="med"/>
+                    </a:lnT>
+                    <a:lnB w="9525" cap="flat" cmpd="sng" algn="ctr">
+                      <a:solidFill>
+                        <a:srgbClr val="E2E8F0"/>
+                      </a:solidFill>
+                      <a:prstDash val="solid"/>
+                      <a:round/>
+                      <a:headEnd type="none" w="med" len="med"/>
+                      <a:tailEnd type="none" w="med" len="med"/>
+                    </a:lnB>
+                    <a:solidFill>
+                      <a:srgbClr val="1F3B57"/>
+                    </a:solidFill>
+                  </a:tcPr>
+                </a:tc>
+                <a:tc>
+                  <a:txBody>
+                    <a:bodyPr/>
+                    <a:lstStyle/>
+                    <a:p>
+                      <a:pPr algn="ctr" indent="0" marL="0">
+                        <a:buNone/>
+                      </a:pPr>
+                      <a:r>
+                        <a:rPr lang="en-US" sz="1200" b="1" dirty="0">
+                          <a:solidFill>
+                            <a:srgbClr val="FFFFFF"/>
+                          </a:solidFill>
+                          <a:latin typeface="Arial" pitchFamily="34" charset="0"/>
+                          <a:ea typeface="Arial" pitchFamily="34" charset="-122"/>
+                          <a:cs typeface="Arial" pitchFamily="34" charset="-120"/>
+                        </a:rPr>
+                        <a:t>총 계산량</a:t>
+                      </a:r>
+                      <a:endParaRPr lang="en-US" sz="1200" dirty="0">
+                        <a:latin typeface="Arial" charset="0"/>
+                        <a:ea typeface="Arial" charset="0"/>
+                        <a:cs typeface="Arial" charset="0"/>
+                      </a:endParaRPr>
+                    </a:p>
+                  </a:txBody>
+                  <a:tcPr marL="91440" marR="91440" marT="45720" marB="45720" anchor="ctr">
+                    <a:lnL w="9525" cap="flat" cmpd="sng" algn="ctr">
+                      <a:solidFill>
+                        <a:srgbClr val="E2E8F0"/>
+                      </a:solidFill>
+                      <a:prstDash val="solid"/>
+                      <a:round/>
+                      <a:headEnd type="none" w="med" len="med"/>
+                      <a:tailEnd type="none" w="med" len="med"/>
+                    </a:lnL>
+                    <a:lnR w="9525" cap="flat" cmpd="sng" algn="ctr">
+                      <a:solidFill>
+                        <a:srgbClr val="E2E8F0"/>
+                      </a:solidFill>
+                      <a:prstDash val="solid"/>
+                      <a:round/>
+                      <a:headEnd type="none" w="med" len="med"/>
+                      <a:tailEnd type="none" w="med" len="med"/>
+                    </a:lnR>
+                    <a:lnT w="9525" cap="flat" cmpd="sng" algn="ctr">
+                      <a:solidFill>
+                        <a:srgbClr val="E2E8F0"/>
+                      </a:solidFill>
+                      <a:prstDash val="solid"/>
+                      <a:round/>
+                      <a:headEnd type="none" w="med" len="med"/>
+                      <a:tailEnd type="none" w="med" len="med"/>
+                    </a:lnT>
+                    <a:lnB w="9525" cap="flat" cmpd="sng" algn="ctr">
+                      <a:solidFill>
+                        <a:srgbClr val="E2E8F0"/>
+                      </a:solidFill>
+                      <a:prstDash val="solid"/>
+                      <a:round/>
+                      <a:headEnd type="none" w="med" len="med"/>
+                      <a:tailEnd type="none" w="med" len="med"/>
+                    </a:lnB>
+                    <a:solidFill>
+                      <a:srgbClr val="1F3B57"/>
+                    </a:solidFill>
+                  </a:tcPr>
+                </a:tc>
+                <a:tc>
+                  <a:txBody>
+                    <a:bodyPr/>
+                    <a:lstStyle/>
+                    <a:p>
+                      <a:pPr algn="ctr" indent="0" marL="0">
+                        <a:buNone/>
+                      </a:pPr>
+                      <a:r>
+                        <a:rPr lang="en-US" sz="1200" b="1" dirty="0">
+                          <a:solidFill>
+                            <a:srgbClr val="FFFFFF"/>
+                          </a:solidFill>
+                          <a:latin typeface="Arial" pitchFamily="34" charset="0"/>
+                          <a:ea typeface="Arial" pitchFamily="34" charset="-122"/>
+                          <a:cs typeface="Arial" pitchFamily="34" charset="-120"/>
+                        </a:rPr>
+                        <a:t>정확도</a:t>
+                      </a:r>
+                      <a:endParaRPr lang="en-US" sz="1200" dirty="0">
+                        <a:latin typeface="Arial" charset="0"/>
+                        <a:ea typeface="Arial" charset="0"/>
+                        <a:cs typeface="Arial" charset="0"/>
+                      </a:endParaRPr>
+                    </a:p>
+                  </a:txBody>
+                  <a:tcPr marL="91440" marR="91440" marT="45720" marB="45720" anchor="ctr">
+                    <a:lnL w="9525" cap="flat" cmpd="sng" algn="ctr">
+                      <a:solidFill>
+                        <a:srgbClr val="E2E8F0"/>
+                      </a:solidFill>
+                      <a:prstDash val="solid"/>
+                      <a:round/>
+                      <a:headEnd type="none" w="med" len="med"/>
+                      <a:tailEnd type="none" w="med" len="med"/>
+                    </a:lnL>
+                    <a:lnR w="9525" cap="flat" cmpd="sng" algn="ctr">
+                      <a:solidFill>
+                        <a:srgbClr val="E2E8F0"/>
+                      </a:solidFill>
+                      <a:prstDash val="solid"/>
+                      <a:round/>
+                      <a:headEnd type="none" w="med" len="med"/>
+                      <a:tailEnd type="none" w="med" len="med"/>
+                    </a:lnR>
+                    <a:lnT w="9525" cap="flat" cmpd="sng" algn="ctr">
+                      <a:solidFill>
+                        <a:srgbClr val="E2E8F0"/>
+                      </a:solidFill>
+                      <a:prstDash val="solid"/>
+                      <a:round/>
+                      <a:headEnd type="none" w="med" len="med"/>
+                      <a:tailEnd type="none" w="med" len="med"/>
+                    </a:lnT>
+                    <a:lnB w="9525" cap="flat" cmpd="sng" algn="ctr">
+                      <a:solidFill>
+                        <a:srgbClr val="E2E8F0"/>
+                      </a:solidFill>
+                      <a:prstDash val="solid"/>
+                      <a:round/>
+                      <a:headEnd type="none" w="med" len="med"/>
+                      <a:tailEnd type="none" w="med" len="med"/>
+                    </a:lnB>
+                    <a:solidFill>
+                      <a:srgbClr val="1F3B57"/>
+                    </a:solidFill>
+                  </a:tcPr>
+                </a:tc>
+              </a:tr>
+              <a:tr h="548640">
+                <a:tc>
+                  <a:txBody>
+                    <a:bodyPr/>
+                    <a:lstStyle/>
+                    <a:p>
+                      <a:pPr algn="ctr" indent="0" marL="0">
+                        <a:buNone/>
+                      </a:pPr>
+                      <a:r>
+                        <a:rPr lang="en-US" sz="1200" b="1" dirty="0">
+                          <a:solidFill>
+                            <a:srgbClr val="1F3B57"/>
+                          </a:solidFill>
+                          <a:latin typeface="Arial" pitchFamily="34" charset="0"/>
+                          <a:ea typeface="Arial" pitchFamily="34" charset="-122"/>
+                          <a:cs typeface="Arial" pitchFamily="34" charset="-120"/>
+                        </a:rPr>
+                        <a:t>일괄 (기존 방식)</a:t>
+                      </a:r>
+                      <a:endParaRPr lang="en-US" sz="1200" dirty="0">
+                        <a:latin typeface="Arial" charset="0"/>
+                        <a:ea typeface="Arial" charset="0"/>
+                        <a:cs typeface="Arial" charset="0"/>
+                      </a:endParaRPr>
+                    </a:p>
+                  </a:txBody>
+                  <a:tcPr marL="91440" marR="91440" marT="45720" marB="45720" anchor="ctr">
+                    <a:lnL w="9525" cap="flat" cmpd="sng" algn="ctr">
+                      <a:solidFill>
+                        <a:srgbClr val="E2E8F0"/>
+                      </a:solidFill>
+                      <a:prstDash val="solid"/>
+                      <a:round/>
+                      <a:headEnd type="none" w="med" len="med"/>
+                      <a:tailEnd type="none" w="med" len="med"/>
+                    </a:lnL>
+                    <a:lnR w="9525" cap="flat" cmpd="sng" algn="ctr">
+                      <a:solidFill>
+                        <a:srgbClr val="E2E8F0"/>
+                      </a:solidFill>
+                      <a:prstDash val="solid"/>
+                      <a:round/>
+                      <a:headEnd type="none" w="med" len="med"/>
+                      <a:tailEnd type="none" w="med" len="med"/>
+                    </a:lnR>
+                    <a:lnT w="9525" cap="flat" cmpd="sng" algn="ctr">
+                      <a:solidFill>
+                        <a:srgbClr val="E2E8F0"/>
+                      </a:solidFill>
+                      <a:prstDash val="solid"/>
+                      <a:round/>
+                      <a:headEnd type="none" w="med" len="med"/>
+                      <a:tailEnd type="none" w="med" len="med"/>
+                    </a:lnT>
+                    <a:lnB w="9525" cap="flat" cmpd="sng" algn="ctr">
+                      <a:solidFill>
+                        <a:srgbClr val="E2E8F0"/>
+                      </a:solidFill>
+                      <a:prstDash val="solid"/>
+                      <a:round/>
+                      <a:headEnd type="none" w="med" len="med"/>
+                      <a:tailEnd type="none" w="med" len="med"/>
+                    </a:lnB>
+                    <a:solidFill>
+                      <a:srgbClr val="FFFFFF"/>
+                    </a:solidFill>
+                  </a:tcPr>
+                </a:tc>
+                <a:tc>
+                  <a:txBody>
+                    <a:bodyPr/>
+                    <a:lstStyle/>
+                    <a:p>
+                      <a:pPr algn="ctr" indent="0" marL="0">
+                        <a:buNone/>
+                      </a:pPr>
+                      <a:r>
+                        <a:rPr lang="en-US" sz="1200" dirty="0">
+                          <a:solidFill>
+                            <a:srgbClr val="1F3B57"/>
+                          </a:solidFill>
+                          <a:latin typeface="Arial" pitchFamily="34" charset="0"/>
+                          <a:ea typeface="Arial" pitchFamily="34" charset="-122"/>
+                          <a:cs typeface="Arial" pitchFamily="34" charset="-120"/>
+                        </a:rPr>
+                        <a:t>16층까지</a:t>
+                      </a:r>
+                      <a:endParaRPr lang="en-US" sz="1200" dirty="0">
+                        <a:latin typeface="Arial" charset="0"/>
+                        <a:ea typeface="Arial" charset="0"/>
+                        <a:cs typeface="Arial" charset="0"/>
+                      </a:endParaRPr>
+                    </a:p>
+                  </a:txBody>
+                  <a:tcPr marL="91440" marR="91440" marT="45720" marB="45720" anchor="ctr">
+                    <a:lnL w="9525" cap="flat" cmpd="sng" algn="ctr">
+                      <a:solidFill>
+                        <a:srgbClr val="E2E8F0"/>
+                      </a:solidFill>
+                      <a:prstDash val="solid"/>
+                      <a:round/>
+                      <a:headEnd type="none" w="med" len="med"/>
+                      <a:tailEnd type="none" w="med" len="med"/>
+                    </a:lnL>
+                    <a:lnR w="9525" cap="flat" cmpd="sng" algn="ctr">
+                      <a:solidFill>
+                        <a:srgbClr val="E2E8F0"/>
+                      </a:solidFill>
+                      <a:prstDash val="solid"/>
+                      <a:round/>
+                      <a:headEnd type="none" w="med" len="med"/>
+                      <a:tailEnd type="none" w="med" len="med"/>
+                    </a:lnR>
+                    <a:lnT w="9525" cap="flat" cmpd="sng" algn="ctr">
+                      <a:solidFill>
+                        <a:srgbClr val="E2E8F0"/>
+                      </a:solidFill>
+                      <a:prstDash val="solid"/>
+                      <a:round/>
+                      <a:headEnd type="none" w="med" len="med"/>
+                      <a:tailEnd type="none" w="med" len="med"/>
+                    </a:lnT>
+                    <a:lnB w="9525" cap="flat" cmpd="sng" algn="ctr">
+                      <a:solidFill>
+                        <a:srgbClr val="E2E8F0"/>
+                      </a:solidFill>
+                      <a:prstDash val="solid"/>
+                      <a:round/>
+                      <a:headEnd type="none" w="med" len="med"/>
+                      <a:tailEnd type="none" w="med" len="med"/>
+                    </a:lnB>
+                    <a:solidFill>
+                      <a:srgbClr val="FFFFFF"/>
+                    </a:solidFill>
+                  </a:tcPr>
+                </a:tc>
+                <a:tc>
+                  <a:txBody>
+                    <a:bodyPr/>
+                    <a:lstStyle/>
+                    <a:p>
+                      <a:pPr algn="ctr" indent="0" marL="0">
+                        <a:buNone/>
+                      </a:pPr>
+                      <a:r>
+                        <a:rPr lang="en-US" sz="1200" dirty="0">
+                          <a:solidFill>
+                            <a:srgbClr val="1F3B57"/>
+                          </a:solidFill>
+                          <a:latin typeface="Arial" pitchFamily="34" charset="0"/>
+                          <a:ea typeface="Arial" pitchFamily="34" charset="-122"/>
+                          <a:cs typeface="Arial" pitchFamily="34" charset="-120"/>
+                        </a:rPr>
+                        <a:t>16층까지</a:t>
+                      </a:r>
+                      <a:endParaRPr lang="en-US" sz="1200" dirty="0">
+                        <a:latin typeface="Arial" charset="0"/>
+                        <a:ea typeface="Arial" charset="0"/>
+                        <a:cs typeface="Arial" charset="0"/>
+                      </a:endParaRPr>
+                    </a:p>
+                  </a:txBody>
+                  <a:tcPr marL="91440" marR="91440" marT="45720" marB="45720" anchor="ctr">
+                    <a:lnL w="9525" cap="flat" cmpd="sng" algn="ctr">
+                      <a:solidFill>
+                        <a:srgbClr val="E2E8F0"/>
+                      </a:solidFill>
+                      <a:prstDash val="solid"/>
+                      <a:round/>
+                      <a:headEnd type="none" w="med" len="med"/>
+                      <a:tailEnd type="none" w="med" len="med"/>
+                    </a:lnL>
+                    <a:lnR w="9525" cap="flat" cmpd="sng" algn="ctr">
+                      <a:solidFill>
+                        <a:srgbClr val="E2E8F0"/>
+                      </a:solidFill>
+                      <a:prstDash val="solid"/>
+                      <a:round/>
+                      <a:headEnd type="none" w="med" len="med"/>
+                      <a:tailEnd type="none" w="med" len="med"/>
+                    </a:lnR>
+                    <a:lnT w="9525" cap="flat" cmpd="sng" algn="ctr">
+                      <a:solidFill>
+                        <a:srgbClr val="E2E8F0"/>
+                      </a:solidFill>
+                      <a:prstDash val="solid"/>
+                      <a:round/>
+                      <a:headEnd type="none" w="med" len="med"/>
+                      <a:tailEnd type="none" w="med" len="med"/>
+                    </a:lnT>
+                    <a:lnB w="9525" cap="flat" cmpd="sng" algn="ctr">
+                      <a:solidFill>
+                        <a:srgbClr val="E2E8F0"/>
+                      </a:solidFill>
+                      <a:prstDash val="solid"/>
+                      <a:round/>
+                      <a:headEnd type="none" w="med" len="med"/>
+                      <a:tailEnd type="none" w="med" len="med"/>
+                    </a:lnB>
+                    <a:solidFill>
+                      <a:srgbClr val="FFFFFF"/>
+                    </a:solidFill>
+                  </a:tcPr>
+                </a:tc>
+                <a:tc>
+                  <a:txBody>
+                    <a:bodyPr/>
+                    <a:lstStyle/>
+                    <a:p>
+                      <a:pPr algn="ctr" indent="0" marL="0">
+                        <a:buNone/>
+                      </a:pPr>
+                      <a:r>
+                        <a:rPr lang="en-US" sz="1200" b="1" dirty="0">
+                          <a:solidFill>
+                            <a:srgbClr val="1F3B57"/>
+                          </a:solidFill>
+                          <a:latin typeface="Arial" pitchFamily="34" charset="0"/>
+                          <a:ea typeface="Arial" pitchFamily="34" charset="-122"/>
+                          <a:cs typeface="Arial" pitchFamily="34" charset="-120"/>
+                        </a:rPr>
+                        <a:t>16 + 16 = 32</a:t>
+                      </a:r>
+                      <a:endParaRPr lang="en-US" sz="1200" dirty="0">
+                        <a:latin typeface="Arial" charset="0"/>
+                        <a:ea typeface="Arial" charset="0"/>
+                        <a:cs typeface="Arial" charset="0"/>
+                      </a:endParaRPr>
+                    </a:p>
+                  </a:txBody>
+                  <a:tcPr marL="91440" marR="91440" marT="45720" marB="45720" anchor="ctr">
+                    <a:lnL w="9525" cap="flat" cmpd="sng" algn="ctr">
+                      <a:solidFill>
+                        <a:srgbClr val="E2E8F0"/>
+                      </a:solidFill>
+                      <a:prstDash val="solid"/>
+                      <a:round/>
+                      <a:headEnd type="none" w="med" len="med"/>
+                      <a:tailEnd type="none" w="med" len="med"/>
+                    </a:lnL>
+                    <a:lnR w="9525" cap="flat" cmpd="sng" algn="ctr">
+                      <a:solidFill>
+                        <a:srgbClr val="E2E8F0"/>
+                      </a:solidFill>
+                      <a:prstDash val="solid"/>
+                      <a:round/>
+                      <a:headEnd type="none" w="med" len="med"/>
+                      <a:tailEnd type="none" w="med" len="med"/>
+                    </a:lnR>
+                    <a:lnT w="9525" cap="flat" cmpd="sng" algn="ctr">
+                      <a:solidFill>
+                        <a:srgbClr val="E2E8F0"/>
+                      </a:solidFill>
+                      <a:prstDash val="solid"/>
+                      <a:round/>
+                      <a:headEnd type="none" w="med" len="med"/>
+                      <a:tailEnd type="none" w="med" len="med"/>
+                    </a:lnT>
+                    <a:lnB w="9525" cap="flat" cmpd="sng" algn="ctr">
+                      <a:solidFill>
+                        <a:srgbClr val="E2E8F0"/>
+                      </a:solidFill>
+                      <a:prstDash val="solid"/>
+                      <a:round/>
+                      <a:headEnd type="none" w="med" len="med"/>
+                      <a:tailEnd type="none" w="med" len="med"/>
+                    </a:lnB>
+                    <a:solidFill>
+                      <a:srgbClr val="FFFFFF"/>
+                    </a:solidFill>
+                  </a:tcPr>
+                </a:tc>
+                <a:tc>
+                  <a:txBody>
+                    <a:bodyPr/>
+                    <a:lstStyle/>
+                    <a:p>
+                      <a:pPr algn="ctr" indent="0" marL="0">
+                        <a:buNone/>
+                      </a:pPr>
+                      <a:r>
+                        <a:rPr lang="en-US" sz="1200" b="1" dirty="0">
+                          <a:solidFill>
+                            <a:srgbClr val="D62728"/>
+                          </a:solidFill>
+                          <a:latin typeface="Arial" pitchFamily="34" charset="0"/>
+                          <a:ea typeface="Arial" pitchFamily="34" charset="-122"/>
+                          <a:cs typeface="Arial" pitchFamily="34" charset="-120"/>
+                        </a:rPr>
+                        <a:t>0.550</a:t>
+                      </a:r>
+                      <a:endParaRPr lang="en-US" sz="1200" dirty="0">
+                        <a:latin typeface="Arial" charset="0"/>
+                        <a:ea typeface="Arial" charset="0"/>
+                        <a:cs typeface="Arial" charset="0"/>
+                      </a:endParaRPr>
+                    </a:p>
+                  </a:txBody>
+                  <a:tcPr marL="91440" marR="91440" marT="45720" marB="45720" anchor="ctr">
+                    <a:lnL w="9525" cap="flat" cmpd="sng" algn="ctr">
+                      <a:solidFill>
+                        <a:srgbClr val="E2E8F0"/>
+                      </a:solidFill>
+                      <a:prstDash val="solid"/>
+                      <a:round/>
+                      <a:headEnd type="none" w="med" len="med"/>
+                      <a:tailEnd type="none" w="med" len="med"/>
+                    </a:lnL>
+                    <a:lnR w="9525" cap="flat" cmpd="sng" algn="ctr">
+                      <a:solidFill>
+                        <a:srgbClr val="E2E8F0"/>
+                      </a:solidFill>
+                      <a:prstDash val="solid"/>
+                      <a:round/>
+                      <a:headEnd type="none" w="med" len="med"/>
+                      <a:tailEnd type="none" w="med" len="med"/>
+                    </a:lnR>
+                    <a:lnT w="9525" cap="flat" cmpd="sng" algn="ctr">
+                      <a:solidFill>
+                        <a:srgbClr val="E2E8F0"/>
+                      </a:solidFill>
+                      <a:prstDash val="solid"/>
+                      <a:round/>
+                      <a:headEnd type="none" w="med" len="med"/>
+                      <a:tailEnd type="none" w="med" len="med"/>
+                    </a:lnT>
+                    <a:lnB w="9525" cap="flat" cmpd="sng" algn="ctr">
+                      <a:solidFill>
+                        <a:srgbClr val="E2E8F0"/>
+                      </a:solidFill>
+                      <a:prstDash val="solid"/>
+                      <a:round/>
+                      <a:headEnd type="none" w="med" len="med"/>
+                      <a:tailEnd type="none" w="med" len="med"/>
+                    </a:lnB>
+                    <a:solidFill>
+                      <a:srgbClr val="FFFFFF"/>
+                    </a:solidFill>
+                  </a:tcPr>
+                </a:tc>
+              </a:tr>
+              <a:tr h="548640">
+                <a:tc>
+                  <a:txBody>
+                    <a:bodyPr/>
+                    <a:lstStyle/>
+                    <a:p>
+                      <a:pPr algn="ctr" indent="0" marL="0">
+                        <a:buNone/>
+                      </a:pPr>
+                      <a:r>
+                        <a:rPr lang="en-US" sz="1200" b="1" dirty="0">
+                          <a:solidFill>
+                            <a:srgbClr val="1F3B57"/>
+                          </a:solidFill>
+                          <a:latin typeface="Arial" pitchFamily="34" charset="0"/>
+                          <a:ea typeface="Arial" pitchFamily="34" charset="-122"/>
+                          <a:cs typeface="Arial" pitchFamily="34" charset="-120"/>
+                        </a:rPr>
+                        <a:t>차등 (우리)</a:t>
+                      </a:r>
+                      <a:endParaRPr lang="en-US" sz="1200" dirty="0">
+                        <a:latin typeface="Arial" charset="0"/>
+                        <a:ea typeface="Arial" charset="0"/>
+                        <a:cs typeface="Arial" charset="0"/>
+                      </a:endParaRPr>
+                    </a:p>
+                  </a:txBody>
+                  <a:tcPr marL="91440" marR="91440" marT="45720" marB="45720" anchor="ctr">
+                    <a:lnL w="9525" cap="flat" cmpd="sng" algn="ctr">
+                      <a:solidFill>
+                        <a:srgbClr val="E2E8F0"/>
+                      </a:solidFill>
+                      <a:prstDash val="solid"/>
+                      <a:round/>
+                      <a:headEnd type="none" w="med" len="med"/>
+                      <a:tailEnd type="none" w="med" len="med"/>
+                    </a:lnL>
+                    <a:lnR w="9525" cap="flat" cmpd="sng" algn="ctr">
+                      <a:solidFill>
+                        <a:srgbClr val="E2E8F0"/>
+                      </a:solidFill>
+                      <a:prstDash val="solid"/>
+                      <a:round/>
+                      <a:headEnd type="none" w="med" len="med"/>
+                      <a:tailEnd type="none" w="med" len="med"/>
+                    </a:lnR>
+                    <a:lnT w="9525" cap="flat" cmpd="sng" algn="ctr">
+                      <a:solidFill>
+                        <a:srgbClr val="E2E8F0"/>
+                      </a:solidFill>
+                      <a:prstDash val="solid"/>
+                      <a:round/>
+                      <a:headEnd type="none" w="med" len="med"/>
+                      <a:tailEnd type="none" w="med" len="med"/>
+                    </a:lnT>
+                    <a:lnB w="9525" cap="flat" cmpd="sng" algn="ctr">
+                      <a:solidFill>
+                        <a:srgbClr val="E2E8F0"/>
+                      </a:solidFill>
+                      <a:prstDash val="solid"/>
+                      <a:round/>
+                      <a:headEnd type="none" w="med" len="med"/>
+                      <a:tailEnd type="none" w="med" len="med"/>
+                    </a:lnB>
+                    <a:solidFill>
+                      <a:srgbClr val="FFFFFF"/>
+                    </a:solidFill>
+                  </a:tcPr>
+                </a:tc>
+                <a:tc>
+                  <a:txBody>
+                    <a:bodyPr/>
+                    <a:lstStyle/>
+                    <a:p>
+                      <a:pPr algn="ctr" indent="0" marL="0">
+                        <a:buNone/>
+                      </a:pPr>
+                      <a:r>
+                        <a:rPr lang="en-US" sz="1200" dirty="0">
+                          <a:solidFill>
+                            <a:srgbClr val="1F77B4"/>
+                          </a:solidFill>
+                          <a:latin typeface="Arial" pitchFamily="34" charset="0"/>
+                          <a:ea typeface="Arial" pitchFamily="34" charset="-122"/>
+                          <a:cs typeface="Arial" pitchFamily="34" charset="-120"/>
+                        </a:rPr>
+                        <a:t>4층까지만</a:t>
+                      </a:r>
+                      <a:endParaRPr lang="en-US" sz="1200" dirty="0">
+                        <a:latin typeface="Arial" charset="0"/>
+                        <a:ea typeface="Arial" charset="0"/>
+                        <a:cs typeface="Arial" charset="0"/>
+                      </a:endParaRPr>
+                    </a:p>
+                  </a:txBody>
+                  <a:tcPr marL="91440" marR="91440" marT="45720" marB="45720" anchor="ctr">
+                    <a:lnL w="9525" cap="flat" cmpd="sng" algn="ctr">
+                      <a:solidFill>
+                        <a:srgbClr val="E2E8F0"/>
+                      </a:solidFill>
+                      <a:prstDash val="solid"/>
+                      <a:round/>
+                      <a:headEnd type="none" w="med" len="med"/>
+                      <a:tailEnd type="none" w="med" len="med"/>
+                    </a:lnL>
+                    <a:lnR w="9525" cap="flat" cmpd="sng" algn="ctr">
+                      <a:solidFill>
+                        <a:srgbClr val="E2E8F0"/>
+                      </a:solidFill>
+                      <a:prstDash val="solid"/>
+                      <a:round/>
+                      <a:headEnd type="none" w="med" len="med"/>
+                      <a:tailEnd type="none" w="med" len="med"/>
+                    </a:lnR>
+                    <a:lnT w="9525" cap="flat" cmpd="sng" algn="ctr">
+                      <a:solidFill>
+                        <a:srgbClr val="E2E8F0"/>
+                      </a:solidFill>
+                      <a:prstDash val="solid"/>
+                      <a:round/>
+                      <a:headEnd type="none" w="med" len="med"/>
+                      <a:tailEnd type="none" w="med" len="med"/>
+                    </a:lnT>
+                    <a:lnB w="9525" cap="flat" cmpd="sng" algn="ctr">
+                      <a:solidFill>
+                        <a:srgbClr val="E2E8F0"/>
+                      </a:solidFill>
+                      <a:prstDash val="solid"/>
+                      <a:round/>
+                      <a:headEnd type="none" w="med" len="med"/>
+                      <a:tailEnd type="none" w="med" len="med"/>
+                    </a:lnB>
+                    <a:solidFill>
+                      <a:srgbClr val="FFFFFF"/>
+                    </a:solidFill>
+                  </a:tcPr>
+                </a:tc>
+                <a:tc>
+                  <a:txBody>
+                    <a:bodyPr/>
+                    <a:lstStyle/>
+                    <a:p>
+                      <a:pPr algn="ctr" indent="0" marL="0">
+                        <a:buNone/>
+                      </a:pPr>
+                      <a:r>
+                        <a:rPr lang="en-US" sz="1200" dirty="0">
+                          <a:solidFill>
+                            <a:srgbClr val="1F77B4"/>
+                          </a:solidFill>
+                          <a:latin typeface="Arial" pitchFamily="34" charset="0"/>
+                          <a:ea typeface="Arial" pitchFamily="34" charset="-122"/>
+                          <a:cs typeface="Arial" pitchFamily="34" charset="-120"/>
+                        </a:rPr>
+                        <a:t>28층까지</a:t>
+                      </a:r>
+                      <a:endParaRPr lang="en-US" sz="1200" dirty="0">
+                        <a:latin typeface="Arial" charset="0"/>
+                        <a:ea typeface="Arial" charset="0"/>
+                        <a:cs typeface="Arial" charset="0"/>
+                      </a:endParaRPr>
+                    </a:p>
+                  </a:txBody>
+                  <a:tcPr marL="91440" marR="91440" marT="45720" marB="45720" anchor="ctr">
+                    <a:lnL w="9525" cap="flat" cmpd="sng" algn="ctr">
+                      <a:solidFill>
+                        <a:srgbClr val="E2E8F0"/>
+                      </a:solidFill>
+                      <a:prstDash val="solid"/>
+                      <a:round/>
+                      <a:headEnd type="none" w="med" len="med"/>
+                      <a:tailEnd type="none" w="med" len="med"/>
+                    </a:lnL>
+                    <a:lnR w="9525" cap="flat" cmpd="sng" algn="ctr">
+                      <a:solidFill>
+                        <a:srgbClr val="E2E8F0"/>
+                      </a:solidFill>
+                      <a:prstDash val="solid"/>
+                      <a:round/>
+                      <a:headEnd type="none" w="med" len="med"/>
+                      <a:tailEnd type="none" w="med" len="med"/>
+                    </a:lnR>
+                    <a:lnT w="9525" cap="flat" cmpd="sng" algn="ctr">
+                      <a:solidFill>
+                        <a:srgbClr val="E2E8F0"/>
+                      </a:solidFill>
+                      <a:prstDash val="solid"/>
+                      <a:round/>
+                      <a:headEnd type="none" w="med" len="med"/>
+                      <a:tailEnd type="none" w="med" len="med"/>
+                    </a:lnT>
+                    <a:lnB w="9525" cap="flat" cmpd="sng" algn="ctr">
+                      <a:solidFill>
+                        <a:srgbClr val="E2E8F0"/>
+                      </a:solidFill>
+                      <a:prstDash val="solid"/>
+                      <a:round/>
+                      <a:headEnd type="none" w="med" len="med"/>
+                      <a:tailEnd type="none" w="med" len="med"/>
+                    </a:lnB>
+                    <a:solidFill>
+                      <a:srgbClr val="FFFFFF"/>
+                    </a:solidFill>
+                  </a:tcPr>
+                </a:tc>
+                <a:tc>
+                  <a:txBody>
+                    <a:bodyPr/>
+                    <a:lstStyle/>
+                    <a:p>
+                      <a:pPr algn="ctr" indent="0" marL="0">
+                        <a:buNone/>
+                      </a:pPr>
+                      <a:r>
+                        <a:rPr lang="en-US" sz="1200" b="1" dirty="0">
+                          <a:solidFill>
+                            <a:srgbClr val="1F3B57"/>
+                          </a:solidFill>
+                          <a:latin typeface="Arial" pitchFamily="34" charset="0"/>
+                          <a:ea typeface="Arial" pitchFamily="34" charset="-122"/>
+                          <a:cs typeface="Arial" pitchFamily="34" charset="-120"/>
+                        </a:rPr>
+                        <a:t>4 + 28 = 32</a:t>
+                      </a:r>
+                      <a:endParaRPr lang="en-US" sz="1200" dirty="0">
+                        <a:latin typeface="Arial" charset="0"/>
+                        <a:ea typeface="Arial" charset="0"/>
+                        <a:cs typeface="Arial" charset="0"/>
+                      </a:endParaRPr>
+                    </a:p>
+                  </a:txBody>
+                  <a:tcPr marL="91440" marR="91440" marT="45720" marB="45720" anchor="ctr">
+                    <a:lnL w="9525" cap="flat" cmpd="sng" algn="ctr">
+                      <a:solidFill>
+                        <a:srgbClr val="E2E8F0"/>
+                      </a:solidFill>
+                      <a:prstDash val="solid"/>
+                      <a:round/>
+                      <a:headEnd type="none" w="med" len="med"/>
+                      <a:tailEnd type="none" w="med" len="med"/>
+                    </a:lnL>
+                    <a:lnR w="9525" cap="flat" cmpd="sng" algn="ctr">
+                      <a:solidFill>
+                        <a:srgbClr val="E2E8F0"/>
+                      </a:solidFill>
+                      <a:prstDash val="solid"/>
+                      <a:round/>
+                      <a:headEnd type="none" w="med" len="med"/>
+                      <a:tailEnd type="none" w="med" len="med"/>
+                    </a:lnR>
+                    <a:lnT w="9525" cap="flat" cmpd="sng" algn="ctr">
+                      <a:solidFill>
+                        <a:srgbClr val="E2E8F0"/>
+                      </a:solidFill>
+                      <a:prstDash val="solid"/>
+                      <a:round/>
+                      <a:headEnd type="none" w="med" len="med"/>
+                      <a:tailEnd type="none" w="med" len="med"/>
+                    </a:lnT>
+                    <a:lnB w="9525" cap="flat" cmpd="sng" algn="ctr">
+                      <a:solidFill>
+                        <a:srgbClr val="E2E8F0"/>
+                      </a:solidFill>
+                      <a:prstDash val="solid"/>
+                      <a:round/>
+                      <a:headEnd type="none" w="med" len="med"/>
+                      <a:tailEnd type="none" w="med" len="med"/>
+                    </a:lnB>
+                    <a:solidFill>
+                      <a:srgbClr val="FFFFFF"/>
+                    </a:solidFill>
+                  </a:tcPr>
+                </a:tc>
+                <a:tc>
+                  <a:txBody>
+                    <a:bodyPr/>
+                    <a:lstStyle/>
+                    <a:p>
+                      <a:pPr algn="ctr" indent="0" marL="0">
+                        <a:buNone/>
+                      </a:pPr>
+                      <a:r>
+                        <a:rPr lang="en-US" sz="1200" b="1" dirty="0">
+                          <a:solidFill>
+                            <a:srgbClr val="2E8B57"/>
+                          </a:solidFill>
+                          <a:latin typeface="Arial" pitchFamily="34" charset="0"/>
+                          <a:ea typeface="Arial" pitchFamily="34" charset="-122"/>
+                          <a:cs typeface="Arial" pitchFamily="34" charset="-120"/>
+                        </a:rPr>
+                        <a:t>0.837</a:t>
+                      </a:r>
+                      <a:endParaRPr lang="en-US" sz="1200" dirty="0">
+                        <a:latin typeface="Arial" charset="0"/>
+                        <a:ea typeface="Arial" charset="0"/>
+                        <a:cs typeface="Arial" charset="0"/>
+                      </a:endParaRPr>
+                    </a:p>
+                  </a:txBody>
+                  <a:tcPr marL="91440" marR="91440" marT="45720" marB="45720" anchor="ctr">
+                    <a:lnL w="9525" cap="flat" cmpd="sng" algn="ctr">
+                      <a:solidFill>
+                        <a:srgbClr val="E2E8F0"/>
+                      </a:solidFill>
+                      <a:prstDash val="solid"/>
+                      <a:round/>
+                      <a:headEnd type="none" w="med" len="med"/>
+                      <a:tailEnd type="none" w="med" len="med"/>
+                    </a:lnL>
+                    <a:lnR w="9525" cap="flat" cmpd="sng" algn="ctr">
+                      <a:solidFill>
+                        <a:srgbClr val="E2E8F0"/>
+                      </a:solidFill>
+                      <a:prstDash val="solid"/>
+                      <a:round/>
+                      <a:headEnd type="none" w="med" len="med"/>
+                      <a:tailEnd type="none" w="med" len="med"/>
+                    </a:lnR>
+                    <a:lnT w="9525" cap="flat" cmpd="sng" algn="ctr">
+                      <a:solidFill>
+                        <a:srgbClr val="E2E8F0"/>
+                      </a:solidFill>
+                      <a:prstDash val="solid"/>
+                      <a:round/>
+                      <a:headEnd type="none" w="med" len="med"/>
+                      <a:tailEnd type="none" w="med" len="med"/>
+                    </a:lnT>
+                    <a:lnB w="9525" cap="flat" cmpd="sng" algn="ctr">
+                      <a:solidFill>
+                        <a:srgbClr val="E2E8F0"/>
+                      </a:solidFill>
+                      <a:prstDash val="solid"/>
+                      <a:round/>
+                      <a:headEnd type="none" w="med" len="med"/>
+                      <a:tailEnd type="none" w="med" len="med"/>
+                    </a:lnB>
+                    <a:solidFill>
+                      <a:srgbClr val="FFFFFF"/>
+                    </a:solidFill>
+                  </a:tcPr>
+                </a:tc>
+              </a:tr>
+            </a:tbl>
+          </a:graphicData>
+        </a:graphic>
+      </p:graphicFrame>
       <p:sp>
         <p:nvSpPr>
           <p:cNvPr id="5" name="Text 2"/>
@@ -8380,8 +9404,8 @@
         </p:nvSpPr>
         <p:spPr>
           <a:xfrm>
-            <a:off x="502920" y="5852160"/>
-            <a:ext cx="11155680" cy="548640"/>
+            <a:off x="822960" y="3749040"/>
+            <a:ext cx="10607040" cy="2377440"/>
           </a:xfrm>
           <a:prstGeom prst="rect">
             <a:avLst/>
@@ -8393,11 +9417,138 @@
           <a:bodyPr wrap="square" lIns="0" tIns="0" rIns="0" bIns="0" rtlCol="0" anchor="ctr"/>
           <a:lstStyle/>
           <a:p>
+            <a:pPr marL="342900" indent="-342900">
+              <a:spcAft>
+                <a:spcPts val="900"/>
+              </a:spcAft>
+              <a:buSzPct val="100000"/>
+              <a:buChar char="•"/>
+            </a:pPr>
+            <a:r>
+              <a:rPr lang="en-US" sz="1200" dirty="0">
+                <a:solidFill>
+                  <a:srgbClr val="1F3B57"/>
+                </a:solidFill>
+                <a:latin typeface="Arial" pitchFamily="34" charset="0"/>
+                <a:ea typeface="Arial" pitchFamily="34" charset="-122"/>
+                <a:cs typeface="Arial" pitchFamily="34" charset="-120"/>
+              </a:rPr>
+              <a:t>총 계산량이 정확히 같은데 정확도는 28.7%p 차이난다 — 예산을 똑같이 나누는 것보다 필요한 쪽에 몰아주는 편이 낫다</a:t>
+            </a:r>
+            <a:endParaRPr lang="en-US" sz="1200" dirty="0"/>
+          </a:p>
+          <a:p>
+            <a:pPr marL="342900" indent="-342900">
+              <a:spcAft>
+                <a:spcPts val="900"/>
+              </a:spcAft>
+              <a:buSzPct val="100000"/>
+              <a:buChar char="•"/>
+            </a:pPr>
+            <a:r>
+              <a:rPr lang="en-US" sz="1200" dirty="0">
+                <a:solidFill>
+                  <a:srgbClr val="1F3B57"/>
+                </a:solidFill>
+                <a:latin typeface="Arial" pitchFamily="34" charset="0"/>
+                <a:ea typeface="Arial" pitchFamily="34" charset="-122"/>
+                <a:cs typeface="Arial" pitchFamily="34" charset="-120"/>
+              </a:rPr>
+              <a:t>이유는 단순하다: 일괄 방식은 정답 이미지까지 16층에서 잘라버려 정작 필요한 정보를 함께 날린다</a:t>
+            </a:r>
+            <a:endParaRPr lang="en-US" sz="1200" dirty="0"/>
+          </a:p>
+          <a:p>
+            <a:pPr marL="342900" indent="-342900">
+              <a:spcAft>
+                <a:spcPts val="900"/>
+              </a:spcAft>
+              <a:buSzPct val="100000"/>
+              <a:buChar char="•"/>
+            </a:pPr>
+            <a:r>
+              <a:rPr lang="en-US" sz="1200" dirty="0">
+                <a:solidFill>
+                  <a:srgbClr val="1F3B57"/>
+                </a:solidFill>
+                <a:latin typeface="Arial" pitchFamily="34" charset="0"/>
+                <a:ea typeface="Arial" pitchFamily="34" charset="-122"/>
+                <a:cs typeface="Arial" pitchFamily="34" charset="-120"/>
+              </a:rPr>
+              <a:t>이미지 순서를 뒤집어 재측정해도 이득의 80%가 유지됐다 (원순서 +34.2%p → 뒤집기 +27.3%p, 양방향 평균 +30.7%p)</a:t>
+            </a:r>
+            <a:endParaRPr lang="en-US" sz="1200" dirty="0"/>
+          </a:p>
+          <a:p>
+            <a:pPr marL="342900" indent="-342900">
+              <a:spcAft>
+                <a:spcPts val="900"/>
+              </a:spcAft>
+              <a:buSzPct val="100000"/>
+              <a:buChar char="•"/>
+            </a:pPr>
+            <a:r>
+              <a:rPr lang="en-US" sz="1200" dirty="0">
+                <a:solidFill>
+                  <a:srgbClr val="1F3B57"/>
+                </a:solidFill>
+                <a:latin typeface="Arial" pitchFamily="34" charset="0"/>
+                <a:ea typeface="Arial" pitchFamily="34" charset="-122"/>
+                <a:cs typeface="Arial" pitchFamily="34" charset="-120"/>
+              </a:rPr>
+              <a:t>7B에서도 같은 방향 — 38.9% 절감 구간에서 0.802 vs 0.715 (+8.7%p). 무개입 기준선은 0.790</a:t>
+            </a:r>
+            <a:endParaRPr lang="en-US" sz="1200" dirty="0"/>
+          </a:p>
+          <a:p>
+            <a:pPr marL="342900" indent="-342900">
+              <a:spcAft>
+                <a:spcPts val="900"/>
+              </a:spcAft>
+              <a:buSzPct val="100000"/>
+              <a:buChar char="•"/>
+            </a:pPr>
+            <a:r>
+              <a:rPr lang="en-US" sz="1200" b="1" dirty="0">
+                <a:solidFill>
+                  <a:srgbClr val="D62728"/>
+                </a:solidFill>
+                <a:latin typeface="Arial" pitchFamily="34" charset="0"/>
+                <a:ea typeface="Arial" pitchFamily="34" charset="-122"/>
+                <a:cs typeface="Arial" pitchFamily="34" charset="-120"/>
+              </a:rPr>
+              <a:t>한계: 비교 대상인 일괄 차단(0.550)이 무개입(0.790)보다도 낮은 약한 baseline이다. random 배분 대조군으로 보강해야 한다 (게이트 4)</a:t>
+            </a:r>
+            <a:endParaRPr lang="en-US" sz="1200" dirty="0"/>
+          </a:p>
+        </p:txBody>
+      </p:sp>
+      <p:sp>
+        <p:nvSpPr>
+          <p:cNvPr id="6" name="Text 3"/>
+          <p:cNvSpPr/>
+          <p:nvPr/>
+        </p:nvSpPr>
+        <p:spPr>
+          <a:xfrm>
+            <a:off x="822960" y="6263640"/>
+            <a:ext cx="10607040" cy="365760"/>
+          </a:xfrm>
+          <a:prstGeom prst="rect">
+            <a:avLst/>
+          </a:prstGeom>
+          <a:noFill/>
+          <a:ln/>
+        </p:spPr>
+        <p:txBody>
+          <a:bodyPr wrap="square" lIns="0" tIns="0" rIns="0" bIns="0" rtlCol="0" anchor="ctr"/>
+          <a:lstStyle/>
+          <a:p>
             <a:pPr indent="0" marL="0">
               <a:buNone/>
             </a:pPr>
             <a:r>
-              <a:rPr lang="en-US" sz="1100" dirty="0">
+              <a:rPr lang="en-US" sz="1050" i="1" dirty="0">
                 <a:solidFill>
                   <a:srgbClr val="6B7280"/>
                 </a:solidFill>
@@ -8405,9 +9556,9 @@
                 <a:ea typeface="Arial" pitchFamily="34" charset="-122"/>
                 <a:cs typeface="Arial" pitchFamily="34" charset="-120"/>
               </a:rPr>
-              <a:t>차등 배분(방해 4층 + 대상 28층) vs 일괄 차단(둘 다 16층). 3B 50.5% 절감에서 0.837 vs 0.550, 7B 38.9%에서 0.802 vs 0.715. 기준선 0.790</a:t>
-            </a:r>
-            <a:endParaRPr lang="en-US" sz="1100" dirty="0"/>
+              <a:t>※ 어느 쪽이 방해인지 미리 알려준 조건(oracle)에서의 상한값이다 — 이것을 자동 판정하는 부분이 무너진 지점(본편 4번 슬라이드)</a:t>
+            </a:r>
+            <a:endParaRPr lang="en-US" sz="1050" dirty="0"/>
           </a:p>
         </p:txBody>
       </p:sp>

</xml_diff>

<commit_message>
Cut slides 5 and 6 down to one message each
Slide 5 (prior work): the 4-row comparison table forced the reader to work out
which differences mattered. Reduced to the two rows that define the open slot
(training required / hallucination evaluated). The misread-correction (+3.3 pts),
the out-of-domain drop, and the image-count difference move to speaker notes.
Takeaway replaces the three-way intersection phrase with plain wording.

Slide 6 (plan): five items were listed identically, but only two were decision
gates — the kill rule at the bottom said so. Now two large gates, each stated as
question -> what we do -> explicit failure condition, with the other three
demoted to a single supporting line. Gate 1 (position balancing) is already
answered, so it is replaced by the layer-0 full-removal comparison, which the
verification doc names as the real gate for the depth axis.

Co-Authored-By: Claude Fable 5 <noreply@anthropic.com>
</commit_message>
<xml_diff>
--- a/meeting/SourceDepth_meeting_FINAL.pptx
+++ b/meeting/SourceDepth_meeting_FINAL.pptx
@@ -1040,7 +1040,7 @@
           <a:p>
             <a:r>
               <a:rPr lang="en-US" dirty="0"/>
-              <a:t>어제 저는 이 논문 때문에 접어야겠다고 판단했었습니다. 그런데 원문 19페이지를 직접 대조해 보니 핵심 수치를 잘못 읽었더군요. 보고된 큰 향상은 마스킹이 아니라 학습 데이터가 만든 것이고, 동일 조건에서 마스킹 단독 효과는 3.3점입니다. 게다가 파인튜닝이 전제입니다.</a:t>
+              <a:t>어제 저는 이 논문 때문에 접어야겠다고 판단했었습니다. 그런데 원문 19페이지를 직접 대조해 보니 핵심 수치를 잘못 읽었더군요. 26.4에서 49.4로 올랐다고 보고된 부분은 마스킹이 아니라 198K 합성 학습데이터가 만든 것이고, 동일 조건에서 마스킹 단독 효과는 3.3점입니다. 그리고 파인튜닝이 전제입니다. 덧붙이면 그들의 마스킹은 자체 벤치 밖에서는 오히려 평균이 42.7에서 41.2로 내려갑니다. 다루는 이미지 장수도 중앙값 4~7장의 집계 태스크라 저희 2장 출처 귀속과는 다릅니다.</a:t>
             </a:r>
             <a:endParaRPr lang="en-US" dirty="0"/>
           </a:p>
@@ -1128,7 +1128,7 @@
           <a:p>
             <a:r>
               <a:rPr lang="en-US" dirty="0"/>
-              <a:t>1주일이면 충분합니다. 인프라와 데이터가 이미 다 있어서 새로 만들 게 없습니다. 그리고 이번에도 판정 기준을 먼저 정해두고 들어가겠습니다 — 게이트 1과 2가 모두 실패하면 미련 없이 접겠습니다.</a:t>
+              <a:t>게이트 A가 더 무겁습니다. 방해 이미지를 0층에서 그냥 지워버린 쪽이 깊이를 조절한 것보다 좋다면, 애초에 '깊이'라는 축을 쓸 이유가 없어집니다. 연구의 전제 자체가 걸린 시험이라 이걸 먼저 하겠습니다. 게이트 B는 자동화 가능성입니다 — 오늘 보고드린 위치 편향 문제를 다른 신호로 넘을 수 있는지 봅니다. 두 게이트 다 통과 기준 숫자는 실험 전에 먼저 못 박고 들어가겠습니다. 1주일이면 충분합니다. 인프라와 데이터가 이미 다 있어서 새로 만들 게 없습니다.</a:t>
             </a:r>
             <a:endParaRPr lang="en-US" dirty="0"/>
           </a:p>
@@ -5795,7 +5795,7 @@
           </p:nvPr>
         </p:nvGraphicFramePr>
         <p:xfrm>
-          <a:off x="502920" y="1645920"/>
+          <a:off x="502920" y="1783080"/>
           <a:ext cx="11201400" cy="914400"/>
         </p:xfrm>
         <a:graphic>
@@ -5807,7 +5807,7 @@
                 <a:gridCol w="3733800"/>
                 <a:gridCol w="3733800"/>
               </a:tblGrid>
-              <a:tr h="411480">
+              <a:tr h="457200">
                 <a:tc>
                   <a:txBody>
                     <a:bodyPr/>
@@ -5816,7 +5816,7 @@
                       <a:pPr algn="ctr" indent="0" marL="0">
                         <a:buNone/>
                       </a:pPr>
-                      <a:endParaRPr lang="en-US" sz="1100" dirty="0">
+                      <a:endParaRPr lang="en-US" sz="1250" dirty="0">
                         <a:latin typeface="Arial" charset="0"/>
                         <a:ea typeface="Arial" charset="0"/>
                         <a:cs typeface="Arial" charset="0"/>
@@ -5874,7 +5874,7 @@
                         <a:buNone/>
                       </a:pPr>
                       <a:r>
-                        <a:rPr lang="en-US" sz="1100" b="1" dirty="0">
+                        <a:rPr lang="en-US" sz="1250" b="1" dirty="0">
                           <a:solidFill>
                             <a:srgbClr val="FFFFFF"/>
                           </a:solidFill>
@@ -5882,9 +5882,9 @@
                           <a:ea typeface="Arial" pitchFamily="34" charset="-122"/>
                           <a:cs typeface="Arial" pitchFamily="34" charset="-120"/>
                         </a:rPr>
-                        <a:t>가장 가까운 연구 (2026.01, arXiv 2601.07812)</a:t>
+                        <a:t>MIMIC (CVPR 2026, arXiv 2601.07812)</a:t>
                       </a:r>
-                      <a:endParaRPr lang="en-US" sz="1100" dirty="0">
+                      <a:endParaRPr lang="en-US" sz="1250" dirty="0">
                         <a:latin typeface="Arial" charset="0"/>
                         <a:ea typeface="Arial" charset="0"/>
                         <a:cs typeface="Arial" charset="0"/>
@@ -5942,7 +5942,7 @@
                         <a:buNone/>
                       </a:pPr>
                       <a:r>
-                        <a:rPr lang="en-US" sz="1100" b="1" dirty="0">
+                        <a:rPr lang="en-US" sz="1250" b="1" dirty="0">
                           <a:solidFill>
                             <a:srgbClr val="FFFFFF"/>
                           </a:solidFill>
@@ -5952,7 +5952,7 @@
                         </a:rPr>
                         <a:t>우리</a:t>
                       </a:r>
-                      <a:endParaRPr lang="en-US" sz="1100" dirty="0">
+                      <a:endParaRPr lang="en-US" sz="1250" dirty="0">
                         <a:latin typeface="Arial" charset="0"/>
                         <a:ea typeface="Arial" charset="0"/>
                         <a:cs typeface="Arial" charset="0"/>
@@ -6002,7 +6002,7 @@
                   </a:tcPr>
                 </a:tc>
               </a:tr>
-              <a:tr h="548640">
+              <a:tr h="822960">
                 <a:tc>
                   <a:txBody>
                     <a:bodyPr/>
@@ -6012,7 +6012,7 @@
                         <a:buNone/>
                       </a:pPr>
                       <a:r>
-                        <a:rPr lang="en-US" sz="1100" b="1" dirty="0">
+                        <a:rPr lang="en-US" sz="1400" b="1" dirty="0">
                           <a:solidFill>
                             <a:srgbClr val="1F3B57"/>
                           </a:solidFill>
@@ -6020,9 +6020,9 @@
                           <a:ea typeface="Arial" pitchFamily="34" charset="-122"/>
                           <a:cs typeface="Arial" pitchFamily="34" charset="-120"/>
                         </a:rPr>
-                        <a:t>적용 방식</a:t>
+                        <a:t>학습</a:t>
                       </a:r>
-                      <a:endParaRPr lang="en-US" sz="1100" dirty="0">
+                      <a:endParaRPr lang="en-US" sz="1400" dirty="0">
                         <a:latin typeface="Arial" charset="0"/>
                         <a:ea typeface="Arial" charset="0"/>
                         <a:cs typeface="Arial" charset="0"/>
@@ -6080,17 +6080,17 @@
                         <a:buNone/>
                       </a:pPr>
                       <a:r>
-                        <a:rPr lang="en-US" sz="1100" dirty="0">
+                        <a:rPr lang="en-US" sz="1350" b="1" dirty="0">
                           <a:solidFill>
-                            <a:srgbClr val="1F3B57"/>
+                            <a:srgbClr val="D62728"/>
                           </a:solidFill>
                           <a:latin typeface="Arial" pitchFamily="34" charset="0"/>
                           <a:ea typeface="Arial" pitchFamily="34" charset="-122"/>
                           <a:cs typeface="Arial" pitchFamily="34" charset="-120"/>
                         </a:rPr>
-                        <a:t>LoRA 파인튜닝 필수 · 8×H100 · 합성데이터 198K</a:t>
+                        <a:t>필요  —  8×H100 · 합성데이터 198K</a:t>
                       </a:r>
-                      <a:endParaRPr lang="en-US" sz="1100" dirty="0">
+                      <a:endParaRPr lang="en-US" sz="1350" dirty="0">
                         <a:latin typeface="Arial" charset="0"/>
                         <a:ea typeface="Arial" charset="0"/>
                         <a:cs typeface="Arial" charset="0"/>
@@ -6148,7 +6148,7 @@
                         <a:buNone/>
                       </a:pPr>
                       <a:r>
-                        <a:rPr lang="en-US" sz="1100" b="1" dirty="0">
+                        <a:rPr lang="en-US" sz="1350" b="1" dirty="0">
                           <a:solidFill>
                             <a:srgbClr val="2E8B57"/>
                           </a:solidFill>
@@ -6156,9 +6156,9 @@
                           <a:ea typeface="Arial" pitchFamily="34" charset="-122"/>
                           <a:cs typeface="Arial" pitchFamily="34" charset="-120"/>
                         </a:rPr>
-                        <a:t>추론 시 개입 (학습 없음)</a:t>
+                        <a:t>불필요  —  추론 중 개입만</a:t>
                       </a:r>
-                      <a:endParaRPr lang="en-US" sz="1100" dirty="0">
+                      <a:endParaRPr lang="en-US" sz="1350" dirty="0">
                         <a:latin typeface="Arial" charset="0"/>
                         <a:ea typeface="Arial" charset="0"/>
                         <a:cs typeface="Arial" charset="0"/>
@@ -6208,7 +6208,7 @@
                   </a:tcPr>
                 </a:tc>
               </a:tr>
-              <a:tr h="457200">
+              <a:tr h="822960">
                 <a:tc>
                   <a:txBody>
                     <a:bodyPr/>
@@ -6218,7 +6218,7 @@
                         <a:buNone/>
                       </a:pPr>
                       <a:r>
-                        <a:rPr lang="en-US" sz="1100" b="1" dirty="0">
+                        <a:rPr lang="en-US" sz="1400" b="1" dirty="0">
                           <a:solidFill>
                             <a:srgbClr val="1F3B57"/>
                           </a:solidFill>
@@ -6226,9 +6226,9 @@
                           <a:ea typeface="Arial" pitchFamily="34" charset="-122"/>
                           <a:cs typeface="Arial" pitchFamily="34" charset="-120"/>
                         </a:rPr>
-                        <a:t>마스킹 단독 효과</a:t>
+                        <a:t>환각 평가</a:t>
                       </a:r>
-                      <a:endParaRPr lang="en-US" sz="1100" dirty="0">
+                      <a:endParaRPr lang="en-US" sz="1400" dirty="0">
                         <a:latin typeface="Arial" charset="0"/>
                         <a:ea typeface="Arial" charset="0"/>
                         <a:cs typeface="Arial" charset="0"/>
@@ -6286,17 +6286,17 @@
                         <a:buNone/>
                       </a:pPr>
                       <a:r>
-                        <a:rPr lang="en-US" sz="1100" dirty="0">
+                        <a:rPr lang="en-US" sz="1350" b="1" dirty="0">
                           <a:solidFill>
-                            <a:srgbClr val="1F3B57"/>
+                            <a:srgbClr val="D62728"/>
                           </a:solidFill>
                           <a:latin typeface="Arial" pitchFamily="34" charset="0"/>
                           <a:ea typeface="Arial" pitchFamily="34" charset="-122"/>
                           <a:cs typeface="Arial" pitchFamily="34" charset="-120"/>
                         </a:rPr>
-                        <a:t>+3.3점 — 보고된 큰 향상은 대부분 데이터 기여</a:t>
+                        <a:t>안 함  —  POPE 언급 0회</a:t>
                       </a:r>
-                      <a:endParaRPr lang="en-US" sz="1100" dirty="0">
+                      <a:endParaRPr lang="en-US" sz="1350" dirty="0">
                         <a:latin typeface="Arial" charset="0"/>
                         <a:ea typeface="Arial" charset="0"/>
                         <a:cs typeface="Arial" charset="0"/>
@@ -6354,213 +6354,7 @@
                         <a:buNone/>
                       </a:pPr>
                       <a:r>
-                        <a:rPr lang="en-US" sz="1100" dirty="0">
-                          <a:solidFill>
-                            <a:srgbClr val="1F3B57"/>
-                          </a:solidFill>
-                          <a:latin typeface="Arial" pitchFamily="34" charset="0"/>
-                          <a:ea typeface="Arial" pitchFamily="34" charset="-122"/>
-                          <a:cs typeface="Arial" pitchFamily="34" charset="-120"/>
-                        </a:rPr>
-                        <a:t>—</a:t>
-                      </a:r>
-                      <a:endParaRPr lang="en-US" sz="1100" dirty="0">
-                        <a:latin typeface="Arial" charset="0"/>
-                        <a:ea typeface="Arial" charset="0"/>
-                        <a:cs typeface="Arial" charset="0"/>
-                      </a:endParaRPr>
-                    </a:p>
-                  </a:txBody>
-                  <a:tcPr marL="91440" marR="91440" marT="45720" marB="45720" anchor="ctr">
-                    <a:lnL w="9525" cap="flat" cmpd="sng" algn="ctr">
-                      <a:solidFill>
-                        <a:srgbClr val="E2E8F0"/>
-                      </a:solidFill>
-                      <a:prstDash val="solid"/>
-                      <a:round/>
-                      <a:headEnd type="none" w="med" len="med"/>
-                      <a:tailEnd type="none" w="med" len="med"/>
-                    </a:lnL>
-                    <a:lnR w="9525" cap="flat" cmpd="sng" algn="ctr">
-                      <a:solidFill>
-                        <a:srgbClr val="E2E8F0"/>
-                      </a:solidFill>
-                      <a:prstDash val="solid"/>
-                      <a:round/>
-                      <a:headEnd type="none" w="med" len="med"/>
-                      <a:tailEnd type="none" w="med" len="med"/>
-                    </a:lnR>
-                    <a:lnT w="9525" cap="flat" cmpd="sng" algn="ctr">
-                      <a:solidFill>
-                        <a:srgbClr val="E2E8F0"/>
-                      </a:solidFill>
-                      <a:prstDash val="solid"/>
-                      <a:round/>
-                      <a:headEnd type="none" w="med" len="med"/>
-                      <a:tailEnd type="none" w="med" len="med"/>
-                    </a:lnT>
-                    <a:lnB w="9525" cap="flat" cmpd="sng" algn="ctr">
-                      <a:solidFill>
-                        <a:srgbClr val="E2E8F0"/>
-                      </a:solidFill>
-                      <a:prstDash val="solid"/>
-                      <a:round/>
-                      <a:headEnd type="none" w="med" len="med"/>
-                      <a:tailEnd type="none" w="med" len="med"/>
-                    </a:lnB>
-                    <a:solidFill>
-                      <a:srgbClr val="FFFFFF"/>
-                    </a:solidFill>
-                  </a:tcPr>
-                </a:tc>
-              </a:tr>
-              <a:tr h="457200">
-                <a:tc>
-                  <a:txBody>
-                    <a:bodyPr/>
-                    <a:lstStyle/>
-                    <a:p>
-                      <a:pPr algn="ctr" indent="0" marL="0">
-                        <a:buNone/>
-                      </a:pPr>
-                      <a:r>
-                        <a:rPr lang="en-US" sz="1100" b="1" dirty="0">
-                          <a:solidFill>
-                            <a:srgbClr val="1F3B57"/>
-                          </a:solidFill>
-                          <a:latin typeface="Arial" pitchFamily="34" charset="0"/>
-                          <a:ea typeface="Arial" pitchFamily="34" charset="-122"/>
-                          <a:cs typeface="Arial" pitchFamily="34" charset="-120"/>
-                        </a:rPr>
-                        <a:t>환각 평가</a:t>
-                      </a:r>
-                      <a:endParaRPr lang="en-US" sz="1100" dirty="0">
-                        <a:latin typeface="Arial" charset="0"/>
-                        <a:ea typeface="Arial" charset="0"/>
-                        <a:cs typeface="Arial" charset="0"/>
-                      </a:endParaRPr>
-                    </a:p>
-                  </a:txBody>
-                  <a:tcPr marL="91440" marR="91440" marT="45720" marB="45720" anchor="ctr">
-                    <a:lnL w="9525" cap="flat" cmpd="sng" algn="ctr">
-                      <a:solidFill>
-                        <a:srgbClr val="E2E8F0"/>
-                      </a:solidFill>
-                      <a:prstDash val="solid"/>
-                      <a:round/>
-                      <a:headEnd type="none" w="med" len="med"/>
-                      <a:tailEnd type="none" w="med" len="med"/>
-                    </a:lnL>
-                    <a:lnR w="9525" cap="flat" cmpd="sng" algn="ctr">
-                      <a:solidFill>
-                        <a:srgbClr val="E2E8F0"/>
-                      </a:solidFill>
-                      <a:prstDash val="solid"/>
-                      <a:round/>
-                      <a:headEnd type="none" w="med" len="med"/>
-                      <a:tailEnd type="none" w="med" len="med"/>
-                    </a:lnR>
-                    <a:lnT w="9525" cap="flat" cmpd="sng" algn="ctr">
-                      <a:solidFill>
-                        <a:srgbClr val="E2E8F0"/>
-                      </a:solidFill>
-                      <a:prstDash val="solid"/>
-                      <a:round/>
-                      <a:headEnd type="none" w="med" len="med"/>
-                      <a:tailEnd type="none" w="med" len="med"/>
-                    </a:lnT>
-                    <a:lnB w="9525" cap="flat" cmpd="sng" algn="ctr">
-                      <a:solidFill>
-                        <a:srgbClr val="E2E8F0"/>
-                      </a:solidFill>
-                      <a:prstDash val="solid"/>
-                      <a:round/>
-                      <a:headEnd type="none" w="med" len="med"/>
-                      <a:tailEnd type="none" w="med" len="med"/>
-                    </a:lnB>
-                    <a:solidFill>
-                      <a:srgbClr val="FFFFFF"/>
-                    </a:solidFill>
-                  </a:tcPr>
-                </a:tc>
-                <a:tc>
-                  <a:txBody>
-                    <a:bodyPr/>
-                    <a:lstStyle/>
-                    <a:p>
-                      <a:pPr algn="ctr" indent="0" marL="0">
-                        <a:buNone/>
-                      </a:pPr>
-                      <a:r>
-                        <a:rPr lang="en-US" sz="1100" dirty="0">
-                          <a:solidFill>
-                            <a:srgbClr val="1F3B57"/>
-                          </a:solidFill>
-                          <a:latin typeface="Arial" pitchFamily="34" charset="0"/>
-                          <a:ea typeface="Arial" pitchFamily="34" charset="-122"/>
-                          <a:cs typeface="Arial" pitchFamily="34" charset="-120"/>
-                        </a:rPr>
-                        <a:t>없음 (POPE 언급 0회)</a:t>
-                      </a:r>
-                      <a:endParaRPr lang="en-US" sz="1100" dirty="0">
-                        <a:latin typeface="Arial" charset="0"/>
-                        <a:ea typeface="Arial" charset="0"/>
-                        <a:cs typeface="Arial" charset="0"/>
-                      </a:endParaRPr>
-                    </a:p>
-                  </a:txBody>
-                  <a:tcPr marL="91440" marR="91440" marT="45720" marB="45720" anchor="ctr">
-                    <a:lnL w="9525" cap="flat" cmpd="sng" algn="ctr">
-                      <a:solidFill>
-                        <a:srgbClr val="E2E8F0"/>
-                      </a:solidFill>
-                      <a:prstDash val="solid"/>
-                      <a:round/>
-                      <a:headEnd type="none" w="med" len="med"/>
-                      <a:tailEnd type="none" w="med" len="med"/>
-                    </a:lnL>
-                    <a:lnR w="9525" cap="flat" cmpd="sng" algn="ctr">
-                      <a:solidFill>
-                        <a:srgbClr val="E2E8F0"/>
-                      </a:solidFill>
-                      <a:prstDash val="solid"/>
-                      <a:round/>
-                      <a:headEnd type="none" w="med" len="med"/>
-                      <a:tailEnd type="none" w="med" len="med"/>
-                    </a:lnR>
-                    <a:lnT w="9525" cap="flat" cmpd="sng" algn="ctr">
-                      <a:solidFill>
-                        <a:srgbClr val="E2E8F0"/>
-                      </a:solidFill>
-                      <a:prstDash val="solid"/>
-                      <a:round/>
-                      <a:headEnd type="none" w="med" len="med"/>
-                      <a:tailEnd type="none" w="med" len="med"/>
-                    </a:lnT>
-                    <a:lnB w="9525" cap="flat" cmpd="sng" algn="ctr">
-                      <a:solidFill>
-                        <a:srgbClr val="E2E8F0"/>
-                      </a:solidFill>
-                      <a:prstDash val="solid"/>
-                      <a:round/>
-                      <a:headEnd type="none" w="med" len="med"/>
-                      <a:tailEnd type="none" w="med" len="med"/>
-                    </a:lnB>
-                    <a:solidFill>
-                      <a:srgbClr val="FFFFFF"/>
-                    </a:solidFill>
-                  </a:tcPr>
-                </a:tc>
-                <a:tc>
-                  <a:txBody>
-                    <a:bodyPr/>
-                    <a:lstStyle/>
-                    <a:p>
-                      <a:pPr algn="ctr" indent="0" marL="0">
-                        <a:buNone/>
-                      </a:pPr>
-                      <a:r>
-                        <a:rPr lang="en-US" sz="1100" b="1" dirty="0">
+                        <a:rPr lang="en-US" sz="1350" b="1" dirty="0">
                           <a:solidFill>
                             <a:srgbClr val="2E8B57"/>
                           </a:solidFill>
@@ -6568,215 +6362,9 @@
                           <a:ea typeface="Arial" pitchFamily="34" charset="-122"/>
                           <a:cs typeface="Arial" pitchFamily="34" charset="-120"/>
                         </a:rPr>
-                        <a:t>POPE 4셀 통제 설계</a:t>
+                        <a:t>주 평가 대상  —  POPE 4셀 통제 설계</a:t>
                       </a:r>
-                      <a:endParaRPr lang="en-US" sz="1100" dirty="0">
-                        <a:latin typeface="Arial" charset="0"/>
-                        <a:ea typeface="Arial" charset="0"/>
-                        <a:cs typeface="Arial" charset="0"/>
-                      </a:endParaRPr>
-                    </a:p>
-                  </a:txBody>
-                  <a:tcPr marL="91440" marR="91440" marT="45720" marB="45720" anchor="ctr">
-                    <a:lnL w="9525" cap="flat" cmpd="sng" algn="ctr">
-                      <a:solidFill>
-                        <a:srgbClr val="E2E8F0"/>
-                      </a:solidFill>
-                      <a:prstDash val="solid"/>
-                      <a:round/>
-                      <a:headEnd type="none" w="med" len="med"/>
-                      <a:tailEnd type="none" w="med" len="med"/>
-                    </a:lnL>
-                    <a:lnR w="9525" cap="flat" cmpd="sng" algn="ctr">
-                      <a:solidFill>
-                        <a:srgbClr val="E2E8F0"/>
-                      </a:solidFill>
-                      <a:prstDash val="solid"/>
-                      <a:round/>
-                      <a:headEnd type="none" w="med" len="med"/>
-                      <a:tailEnd type="none" w="med" len="med"/>
-                    </a:lnR>
-                    <a:lnT w="9525" cap="flat" cmpd="sng" algn="ctr">
-                      <a:solidFill>
-                        <a:srgbClr val="E2E8F0"/>
-                      </a:solidFill>
-                      <a:prstDash val="solid"/>
-                      <a:round/>
-                      <a:headEnd type="none" w="med" len="med"/>
-                      <a:tailEnd type="none" w="med" len="med"/>
-                    </a:lnT>
-                    <a:lnB w="9525" cap="flat" cmpd="sng" algn="ctr">
-                      <a:solidFill>
-                        <a:srgbClr val="E2E8F0"/>
-                      </a:solidFill>
-                      <a:prstDash val="solid"/>
-                      <a:round/>
-                      <a:headEnd type="none" w="med" len="med"/>
-                      <a:tailEnd type="none" w="med" len="med"/>
-                    </a:lnB>
-                    <a:solidFill>
-                      <a:srgbClr val="FFFFFF"/>
-                    </a:solidFill>
-                  </a:tcPr>
-                </a:tc>
-              </a:tr>
-              <a:tr h="457200">
-                <a:tc>
-                  <a:txBody>
-                    <a:bodyPr/>
-                    <a:lstStyle/>
-                    <a:p>
-                      <a:pPr algn="ctr" indent="0" marL="0">
-                        <a:buNone/>
-                      </a:pPr>
-                      <a:r>
-                        <a:rPr lang="en-US" sz="1100" b="1" dirty="0">
-                          <a:solidFill>
-                            <a:srgbClr val="1F3B57"/>
-                          </a:solidFill>
-                          <a:latin typeface="Arial" pitchFamily="34" charset="0"/>
-                          <a:ea typeface="Arial" pitchFamily="34" charset="-122"/>
-                          <a:cs typeface="Arial" pitchFamily="34" charset="-120"/>
-                        </a:rPr>
-                        <a:t>일반화</a:t>
-                      </a:r>
-                      <a:endParaRPr lang="en-US" sz="1100" dirty="0">
-                        <a:latin typeface="Arial" charset="0"/>
-                        <a:ea typeface="Arial" charset="0"/>
-                        <a:cs typeface="Arial" charset="0"/>
-                      </a:endParaRPr>
-                    </a:p>
-                  </a:txBody>
-                  <a:tcPr marL="91440" marR="91440" marT="45720" marB="45720" anchor="ctr">
-                    <a:lnL w="9525" cap="flat" cmpd="sng" algn="ctr">
-                      <a:solidFill>
-                        <a:srgbClr val="E2E8F0"/>
-                      </a:solidFill>
-                      <a:prstDash val="solid"/>
-                      <a:round/>
-                      <a:headEnd type="none" w="med" len="med"/>
-                      <a:tailEnd type="none" w="med" len="med"/>
-                    </a:lnL>
-                    <a:lnR w="9525" cap="flat" cmpd="sng" algn="ctr">
-                      <a:solidFill>
-                        <a:srgbClr val="E2E8F0"/>
-                      </a:solidFill>
-                      <a:prstDash val="solid"/>
-                      <a:round/>
-                      <a:headEnd type="none" w="med" len="med"/>
-                      <a:tailEnd type="none" w="med" len="med"/>
-                    </a:lnR>
-                    <a:lnT w="9525" cap="flat" cmpd="sng" algn="ctr">
-                      <a:solidFill>
-                        <a:srgbClr val="E2E8F0"/>
-                      </a:solidFill>
-                      <a:prstDash val="solid"/>
-                      <a:round/>
-                      <a:headEnd type="none" w="med" len="med"/>
-                      <a:tailEnd type="none" w="med" len="med"/>
-                    </a:lnT>
-                    <a:lnB w="9525" cap="flat" cmpd="sng" algn="ctr">
-                      <a:solidFill>
-                        <a:srgbClr val="E2E8F0"/>
-                      </a:solidFill>
-                      <a:prstDash val="solid"/>
-                      <a:round/>
-                      <a:headEnd type="none" w="med" len="med"/>
-                      <a:tailEnd type="none" w="med" len="med"/>
-                    </a:lnB>
-                    <a:solidFill>
-                      <a:srgbClr val="FFFFFF"/>
-                    </a:solidFill>
-                  </a:tcPr>
-                </a:tc>
-                <a:tc>
-                  <a:txBody>
-                    <a:bodyPr/>
-                    <a:lstStyle/>
-                    <a:p>
-                      <a:pPr algn="ctr" indent="0" marL="0">
-                        <a:buNone/>
-                      </a:pPr>
-                      <a:r>
-                        <a:rPr lang="en-US" sz="1100" dirty="0">
-                          <a:solidFill>
-                            <a:srgbClr val="D62728"/>
-                          </a:solidFill>
-                          <a:latin typeface="Arial" pitchFamily="34" charset="0"/>
-                          <a:ea typeface="Arial" pitchFamily="34" charset="-122"/>
-                          <a:cs typeface="Arial" pitchFamily="34" charset="-120"/>
-                        </a:rPr>
-                        <a:t>자체 벤치 밖에서는 오히려 하락 (42.7→41.2)</a:t>
-                      </a:r>
-                      <a:endParaRPr lang="en-US" sz="1100" dirty="0">
-                        <a:latin typeface="Arial" charset="0"/>
-                        <a:ea typeface="Arial" charset="0"/>
-                        <a:cs typeface="Arial" charset="0"/>
-                      </a:endParaRPr>
-                    </a:p>
-                  </a:txBody>
-                  <a:tcPr marL="91440" marR="91440" marT="45720" marB="45720" anchor="ctr">
-                    <a:lnL w="9525" cap="flat" cmpd="sng" algn="ctr">
-                      <a:solidFill>
-                        <a:srgbClr val="E2E8F0"/>
-                      </a:solidFill>
-                      <a:prstDash val="solid"/>
-                      <a:round/>
-                      <a:headEnd type="none" w="med" len="med"/>
-                      <a:tailEnd type="none" w="med" len="med"/>
-                    </a:lnL>
-                    <a:lnR w="9525" cap="flat" cmpd="sng" algn="ctr">
-                      <a:solidFill>
-                        <a:srgbClr val="E2E8F0"/>
-                      </a:solidFill>
-                      <a:prstDash val="solid"/>
-                      <a:round/>
-                      <a:headEnd type="none" w="med" len="med"/>
-                      <a:tailEnd type="none" w="med" len="med"/>
-                    </a:lnR>
-                    <a:lnT w="9525" cap="flat" cmpd="sng" algn="ctr">
-                      <a:solidFill>
-                        <a:srgbClr val="E2E8F0"/>
-                      </a:solidFill>
-                      <a:prstDash val="solid"/>
-                      <a:round/>
-                      <a:headEnd type="none" w="med" len="med"/>
-                      <a:tailEnd type="none" w="med" len="med"/>
-                    </a:lnT>
-                    <a:lnB w="9525" cap="flat" cmpd="sng" algn="ctr">
-                      <a:solidFill>
-                        <a:srgbClr val="E2E8F0"/>
-                      </a:solidFill>
-                      <a:prstDash val="solid"/>
-                      <a:round/>
-                      <a:headEnd type="none" w="med" len="med"/>
-                      <a:tailEnd type="none" w="med" len="med"/>
-                    </a:lnB>
-                    <a:solidFill>
-                      <a:srgbClr val="FFFFFF"/>
-                    </a:solidFill>
-                  </a:tcPr>
-                </a:tc>
-                <a:tc>
-                  <a:txBody>
-                    <a:bodyPr/>
-                    <a:lstStyle/>
-                    <a:p>
-                      <a:pPr algn="ctr" indent="0" marL="0">
-                        <a:buNone/>
-                      </a:pPr>
-                      <a:r>
-                        <a:rPr lang="en-US" sz="1100" dirty="0">
-                          <a:solidFill>
-                            <a:srgbClr val="1F3B57"/>
-                          </a:solidFill>
-                          <a:latin typeface="Arial" pitchFamily="34" charset="0"/>
-                          <a:ea typeface="Arial" pitchFamily="34" charset="-122"/>
-                          <a:cs typeface="Arial" pitchFamily="34" charset="-120"/>
-                        </a:rPr>
-                        <a:t>—</a:t>
-                      </a:r>
-                      <a:endParaRPr lang="en-US" sz="1100" dirty="0">
+                      <a:endParaRPr lang="en-US" sz="1350" dirty="0">
                         <a:latin typeface="Arial" charset="0"/>
                         <a:ea typeface="Arial" charset="0"/>
                         <a:cs typeface="Arial" charset="0"/>
@@ -6838,12 +6426,12 @@
         </p:nvSpPr>
         <p:spPr>
           <a:xfrm>
-            <a:off x="502920" y="4251960"/>
-            <a:ext cx="11201400" cy="1417320"/>
+            <a:off x="502920" y="4206240"/>
+            <a:ext cx="11201400" cy="1600200"/>
           </a:xfrm>
           <a:prstGeom prst="roundRect">
             <a:avLst>
-              <a:gd name="adj" fmla="val 5806"/>
+              <a:gd name="adj" fmla="val 5143"/>
             </a:avLst>
           </a:prstGeom>
           <a:solidFill>
@@ -6865,8 +6453,8 @@
         </p:nvSpPr>
         <p:spPr>
           <a:xfrm>
-            <a:off x="777240" y="4370832"/>
-            <a:ext cx="10698480" cy="1234440"/>
+            <a:off x="822960" y="4343400"/>
+            <a:ext cx="10607040" cy="1371600"/>
           </a:xfrm>
           <a:prstGeom prst="rect">
             <a:avLst/>
@@ -6880,12 +6468,12 @@
           <a:p>
             <a:pPr indent="0" marL="0">
               <a:spcAft>
-                <a:spcPts val="500"/>
+                <a:spcPts val="700"/>
               </a:spcAft>
               <a:buNone/>
             </a:pPr>
             <a:r>
-              <a:rPr lang="en-US" sz="1400" b="1" dirty="0">
+              <a:rPr lang="en-US" sz="1500" b="1" dirty="0">
                 <a:solidFill>
                   <a:srgbClr val="2E8B57"/>
                 </a:solidFill>
@@ -6893,19 +6481,19 @@
                 <a:ea typeface="Arial" pitchFamily="34" charset="-122"/>
                 <a:cs typeface="Arial" pitchFamily="34" charset="-120"/>
               </a:rPr>
-              <a:t>그들이 남긴 열린 질문이 우리 데이터와 맞물립니다</a:t>
-            </a:r>
-            <a:endParaRPr lang="en-US" sz="1400" dirty="0"/>
+              <a:t>그들이 설명하지 못한 것을, 우리는 이미 측정했습니다</a:t>
+            </a:r>
+            <a:endParaRPr lang="en-US" sz="1500" dirty="0"/>
           </a:p>
           <a:p>
             <a:pPr indent="0" marL="0">
               <a:spcAft>
-                <a:spcPts val="500"/>
+                <a:spcPts val="700"/>
               </a:spcAft>
               <a:buNone/>
             </a:pPr>
             <a:r>
-              <a:rPr lang="en-US" sz="1200" dirty="0">
+              <a:rPr lang="en-US" sz="1300" dirty="0">
                 <a:solidFill>
                   <a:srgbClr val="1F3B57"/>
                 </a:solidFill>
@@ -6915,17 +6503,17 @@
               </a:rPr>
               <a:t>그들의 마스킹은 자체 벤치에서는 오르고 다른 벤치에서는 내려가는데, 왜 그런지 설명이 없습니다.</a:t>
             </a:r>
-            <a:endParaRPr lang="en-US" sz="1400" dirty="0"/>
+            <a:endParaRPr lang="en-US" sz="1500" dirty="0"/>
           </a:p>
           <a:p>
             <a:pPr indent="0" marL="0">
               <a:spcAft>
-                <a:spcPts val="500"/>
+                <a:spcPts val="700"/>
               </a:spcAft>
               <a:buNone/>
             </a:pPr>
             <a:r>
-              <a:rPr lang="en-US" sz="1200" dirty="0">
+              <a:rPr lang="en-US" sz="1300" b="1" dirty="0">
                 <a:solidFill>
                   <a:srgbClr val="1F3B57"/>
                 </a:solidFill>
@@ -6933,9 +6521,9 @@
                 <a:ea typeface="Arial" pitchFamily="34" charset="-122"/>
                 <a:cs typeface="Arial" pitchFamily="34" charset="-120"/>
               </a:rPr>
-              <a:t>우리는 같은 개입이 질문 유형에 따라 부호가 뒤집히는 것을 이미 측정했습니다 — 단일이미지 질문에서 +21%p, 두 이미지 비교 질문에서 −51%p (3B 기준, 7B에서도 −41%p로 재현).</a:t>
-            </a:r>
-            <a:endParaRPr lang="en-US" sz="1400" dirty="0"/>
+              <a:t>우리 데이터에서는 질문 유형에 따라 부호가 뒤집힙니다 — 단일 이미지 질문 +21%p  ↔  두 이미지 비교 질문 −51%p (7B에서도 −41%p로 재현)</a:t>
+            </a:r>
+            <a:endParaRPr lang="en-US" sz="1500" dirty="0"/>
           </a:p>
         </p:txBody>
       </p:sp>
@@ -6994,7 +6582,7 @@
                 <a:ea typeface="Arial" pitchFamily="34" charset="-122"/>
                 <a:cs typeface="Arial" pitchFamily="34" charset="-120"/>
               </a:rPr>
-              <a:t>→ training-free × 환각 × 질문 유형 조건부 — 이 칸은 아직 비어 있습니다. 다만 확인하려면 검증이 더 필요합니다</a:t>
+              <a:t>→ 학습 없이, 환각을 대상으로 하는 자리는 아직 비어 있습니다 — 다만 확인하려면 검증이 더 필요합니다</a:t>
             </a:r>
             <a:endParaRPr lang="en-US" sz="1300" dirty="0"/>
           </a:p>
@@ -7104,7 +6692,7 @@
                 <a:ea typeface="Arial" pitchFamily="34" charset="-122"/>
                 <a:cs typeface="Arial" pitchFamily="34" charset="-120"/>
               </a:rPr>
-              <a:t>1주일 안에 진행/중단을 확정하겠습니다</a:t>
+              <a:t>1주일 뒤에 진행/중단을 확정하겠습니다</a:t>
             </a:r>
             <a:endParaRPr lang="en-US" sz="2300" dirty="0"/>
           </a:p>
@@ -7118,8 +6706,35 @@
         </p:nvSpPr>
         <p:spPr>
           <a:xfrm>
-            <a:off x="548640" y="1627632"/>
-            <a:ext cx="402336" cy="402336"/>
+            <a:off x="502920" y="1481328"/>
+            <a:ext cx="11201400" cy="1664208"/>
+          </a:xfrm>
+          <a:prstGeom prst="roundRect">
+            <a:avLst>
+              <a:gd name="adj" fmla="val 4945"/>
+            </a:avLst>
+          </a:prstGeom>
+          <a:solidFill>
+            <a:srgbClr val="1A3247"/>
+          </a:solidFill>
+          <a:ln w="15875">
+            <a:solidFill>
+              <a:srgbClr val="2E4E6B"/>
+            </a:solidFill>
+            <a:prstDash val="solid"/>
+          </a:ln>
+        </p:spPr>
+      </p:sp>
+      <p:sp>
+        <p:nvSpPr>
+          <p:cNvPr id="5" name="Shape 3"/>
+          <p:cNvSpPr/>
+          <p:nvPr/>
+        </p:nvSpPr>
+        <p:spPr>
+          <a:xfrm>
+            <a:off x="868680" y="1984248"/>
+            <a:ext cx="658368" cy="658368"/>
           </a:xfrm>
           <a:prstGeom prst="ellipse">
             <a:avLst/>
@@ -7132,14 +6747,14 @@
       </p:sp>
       <p:sp>
         <p:nvSpPr>
-          <p:cNvPr id="5" name="Text 3"/>
-          <p:cNvSpPr/>
-          <p:nvPr/>
-        </p:nvSpPr>
-        <p:spPr>
-          <a:xfrm>
-            <a:off x="548640" y="1627632"/>
-            <a:ext cx="402336" cy="402336"/>
+          <p:cNvPr id="6" name="Text 4"/>
+          <p:cNvSpPr/>
+          <p:nvPr/>
+        </p:nvSpPr>
+        <p:spPr>
+          <a:xfrm>
+            <a:off x="868680" y="1984248"/>
+            <a:ext cx="658368" cy="658368"/>
           </a:xfrm>
           <a:prstGeom prst="rect">
             <a:avLst/>
@@ -7155,7 +6770,7 @@
               <a:buNone/>
             </a:pPr>
             <a:r>
-              <a:rPr lang="en-US" sz="1300" b="1" dirty="0">
+              <a:rPr lang="en-US" sz="2200" b="1" dirty="0">
                 <a:solidFill>
                   <a:srgbClr val="142638"/>
                 </a:solidFill>
@@ -7163,22 +6778,22 @@
                 <a:ea typeface="Arial" pitchFamily="34" charset="-122"/>
                 <a:cs typeface="Arial" pitchFamily="34" charset="-120"/>
               </a:rPr>
-              <a:t>1</a:t>
-            </a:r>
-            <a:endParaRPr lang="en-US" sz="1300" dirty="0"/>
-          </a:p>
-        </p:txBody>
-      </p:sp>
-      <p:sp>
-        <p:nvSpPr>
-          <p:cNvPr id="6" name="Text 4"/>
-          <p:cNvSpPr/>
-          <p:nvPr/>
-        </p:nvSpPr>
-        <p:spPr>
-          <a:xfrm>
-            <a:off x="1078992" y="1572768"/>
-            <a:ext cx="2743200" cy="365760"/>
+              <a:t>A</a:t>
+            </a:r>
+            <a:endParaRPr lang="en-US" sz="2200" dirty="0"/>
+          </a:p>
+        </p:txBody>
+      </p:sp>
+      <p:sp>
+        <p:nvSpPr>
+          <p:cNvPr id="7" name="Text 5"/>
+          <p:cNvSpPr/>
+          <p:nvPr/>
+        </p:nvSpPr>
+        <p:spPr>
+          <a:xfrm>
+            <a:off x="1783080" y="1700784"/>
+            <a:ext cx="2743200" cy="274320"/>
           </a:xfrm>
           <a:prstGeom prst="rect">
             <a:avLst/>
@@ -7194,30 +6809,30 @@
               <a:buNone/>
             </a:pPr>
             <a:r>
-              <a:rPr lang="en-US" sz="1250" b="1" dirty="0">
-                <a:solidFill>
-                  <a:srgbClr val="FFFFFF"/>
-                </a:solidFill>
-                <a:latin typeface="Arial" pitchFamily="34" charset="0"/>
-                <a:ea typeface="Arial" pitchFamily="34" charset="-122"/>
-                <a:cs typeface="Arial" pitchFamily="34" charset="-120"/>
-              </a:rPr>
-              <a:t>위치 균형화 재측정</a:t>
-            </a:r>
-            <a:endParaRPr lang="en-US" sz="1250" dirty="0"/>
-          </a:p>
-        </p:txBody>
-      </p:sp>
-      <p:sp>
-        <p:nvSpPr>
-          <p:cNvPr id="7" name="Text 5"/>
-          <p:cNvSpPr/>
-          <p:nvPr/>
-        </p:nvSpPr>
-        <p:spPr>
-          <a:xfrm>
-            <a:off x="1078992" y="1901952"/>
-            <a:ext cx="5212080" cy="438912"/>
+              <a:rPr lang="en-US" sz="1100" b="1" dirty="0">
+                <a:solidFill>
+                  <a:srgbClr val="7EC8F5"/>
+                </a:solidFill>
+                <a:latin typeface="Arial" pitchFamily="34" charset="0"/>
+                <a:ea typeface="Arial" pitchFamily="34" charset="-122"/>
+                <a:cs typeface="Arial" pitchFamily="34" charset="-120"/>
+              </a:rPr>
+              <a:t>게이트 A</a:t>
+            </a:r>
+            <a:endParaRPr lang="en-US" sz="1100" dirty="0"/>
+          </a:p>
+        </p:txBody>
+      </p:sp>
+      <p:sp>
+        <p:nvSpPr>
+          <p:cNvPr id="8" name="Text 6"/>
+          <p:cNvSpPr/>
+          <p:nvPr/>
+        </p:nvSpPr>
+        <p:spPr>
+          <a:xfrm>
+            <a:off x="1783080" y="1956816"/>
+            <a:ext cx="9144000" cy="411480"/>
           </a:xfrm>
           <a:prstGeom prst="rect">
             <a:avLst/>
@@ -7233,30 +6848,30 @@
               <a:buNone/>
             </a:pPr>
             <a:r>
-              <a:rPr lang="en-US" sz="1030" dirty="0">
-                <a:solidFill>
-                  <a:srgbClr val="9FB8CE"/>
-                </a:solidFill>
-                <a:latin typeface="Arial" pitchFamily="34" charset="0"/>
-                <a:ea typeface="Arial" pitchFamily="34" charset="-122"/>
-                <a:cs typeface="Arial" pitchFamily="34" charset="-120"/>
-              </a:rPr>
-              <a:t>관련 이미지를 2번 자리로 옮겨 재측정 — 중간집계 결과 배분 이득 80% 유지(양방향 평균 +30.7%p)</a:t>
-            </a:r>
-            <a:endParaRPr lang="en-US" sz="1030" dirty="0"/>
-          </a:p>
-        </p:txBody>
-      </p:sp>
-      <p:sp>
-        <p:nvSpPr>
-          <p:cNvPr id="8" name="Text 6"/>
-          <p:cNvSpPr/>
-          <p:nvPr/>
-        </p:nvSpPr>
-        <p:spPr>
-          <a:xfrm>
-            <a:off x="6492240" y="1609344"/>
-            <a:ext cx="5212080" cy="438912"/>
+              <a:rPr lang="en-US" sz="1800" b="1" dirty="0">
+                <a:solidFill>
+                  <a:srgbClr val="FFFFFF"/>
+                </a:solidFill>
+                <a:latin typeface="Arial" pitchFamily="34" charset="0"/>
+                <a:ea typeface="Arial" pitchFamily="34" charset="-122"/>
+                <a:cs typeface="Arial" pitchFamily="34" charset="-120"/>
+              </a:rPr>
+              <a:t>깊이를 조절할 이유가 있는가?</a:t>
+            </a:r>
+            <a:endParaRPr lang="en-US" sz="1800" dirty="0"/>
+          </a:p>
+        </p:txBody>
+      </p:sp>
+      <p:sp>
+        <p:nvSpPr>
+          <p:cNvPr id="9" name="Text 7"/>
+          <p:cNvSpPr/>
+          <p:nvPr/>
+        </p:nvSpPr>
+        <p:spPr>
+          <a:xfrm>
+            <a:off x="1783080" y="2414016"/>
+            <a:ext cx="9144000" cy="292608"/>
           </a:xfrm>
           <a:prstGeom prst="rect">
             <a:avLst/>
@@ -7272,30 +6887,110 @@
               <a:buNone/>
             </a:pPr>
             <a:r>
-              <a:rPr lang="en-US" sz="1150" dirty="0">
-                <a:solidFill>
-                  <a:srgbClr val="8CE0B0"/>
-                </a:solidFill>
-                <a:latin typeface="Arial" pitchFamily="34" charset="0"/>
-                <a:ea typeface="Arial" pitchFamily="34" charset="-122"/>
-                <a:cs typeface="Arial" pitchFamily="34" charset="-120"/>
-              </a:rPr>
-              <a:t>→ 배분 이득이 실재하는가</a:t>
-            </a:r>
-            <a:endParaRPr lang="en-US" sz="1150" dirty="0"/>
-          </a:p>
-        </p:txBody>
-      </p:sp>
-      <p:sp>
-        <p:nvSpPr>
-          <p:cNvPr id="9" name="Shape 7"/>
-          <p:cNvSpPr/>
-          <p:nvPr/>
-        </p:nvSpPr>
-        <p:spPr>
-          <a:xfrm>
-            <a:off x="548640" y="2414016"/>
-            <a:ext cx="402336" cy="402336"/>
+              <a:rPr lang="en-US" sz="1250" dirty="0">
+                <a:solidFill>
+                  <a:srgbClr val="9FB8CE"/>
+                </a:solidFill>
+                <a:latin typeface="Arial" pitchFamily="34" charset="0"/>
+                <a:ea typeface="Arial" pitchFamily="34" charset="-122"/>
+                <a:cs typeface="Arial" pitchFamily="34" charset="-120"/>
+              </a:rPr>
+              <a:t>방해 이미지를 0층에서 아예 지운 것과 직접 비교한다 (셀 2·3 대상)</a:t>
+            </a:r>
+            <a:endParaRPr lang="en-US" sz="1250" dirty="0"/>
+          </a:p>
+        </p:txBody>
+      </p:sp>
+      <p:sp>
+        <p:nvSpPr>
+          <p:cNvPr id="10" name="Text 8"/>
+          <p:cNvSpPr/>
+          <p:nvPr/>
+        </p:nvSpPr>
+        <p:spPr>
+          <a:xfrm>
+            <a:off x="1783080" y="2743200"/>
+            <a:ext cx="9144000" cy="310896"/>
+          </a:xfrm>
+          <a:prstGeom prst="rect">
+            <a:avLst/>
+          </a:prstGeom>
+          <a:noFill/>
+          <a:ln/>
+        </p:spPr>
+        <p:txBody>
+          <a:bodyPr wrap="square" lIns="0" tIns="0" rIns="0" bIns="0" rtlCol="0" anchor="ctr"/>
+          <a:lstStyle/>
+          <a:p>
+            <a:pPr indent="0" marL="0">
+              <a:buNone/>
+            </a:pPr>
+            <a:r>
+              <a:rPr lang="en-US" sz="1200" b="1" dirty="0">
+                <a:solidFill>
+                  <a:srgbClr val="FF9E80"/>
+                </a:solidFill>
+                <a:latin typeface="Arial" pitchFamily="34" charset="0"/>
+                <a:ea typeface="Arial" pitchFamily="34" charset="-122"/>
+                <a:cs typeface="Arial" pitchFamily="34" charset="-120"/>
+              </a:rPr>
+              <a:t>실패 조건   </a:t>
+            </a:r>
+            <a:pPr indent="0" marL="0">
+              <a:buNone/>
+            </a:pPr>
+            <a:r>
+              <a:rPr lang="en-US" sz="1250" b="1" dirty="0">
+                <a:solidFill>
+                  <a:srgbClr val="FFC94D"/>
+                </a:solidFill>
+                <a:latin typeface="Arial" pitchFamily="34" charset="0"/>
+                <a:ea typeface="Arial" pitchFamily="34" charset="-122"/>
+                <a:cs typeface="Arial" pitchFamily="34" charset="-120"/>
+              </a:rPr>
+              <a:t>아예 지우는 쪽이 같거나 더 좋으면  →  이 주제는 폐기</a:t>
+            </a:r>
+            <a:endParaRPr lang="en-US" sz="1200" dirty="0"/>
+          </a:p>
+        </p:txBody>
+      </p:sp>
+      <p:sp>
+        <p:nvSpPr>
+          <p:cNvPr id="11" name="Shape 9"/>
+          <p:cNvSpPr/>
+          <p:nvPr/>
+        </p:nvSpPr>
+        <p:spPr>
+          <a:xfrm>
+            <a:off x="502920" y="3310128"/>
+            <a:ext cx="11201400" cy="1664208"/>
+          </a:xfrm>
+          <a:prstGeom prst="roundRect">
+            <a:avLst>
+              <a:gd name="adj" fmla="val 4945"/>
+            </a:avLst>
+          </a:prstGeom>
+          <a:solidFill>
+            <a:srgbClr val="1A3247"/>
+          </a:solidFill>
+          <a:ln w="15875">
+            <a:solidFill>
+              <a:srgbClr val="2E4E6B"/>
+            </a:solidFill>
+            <a:prstDash val="solid"/>
+          </a:ln>
+        </p:spPr>
+      </p:sp>
+      <p:sp>
+        <p:nvSpPr>
+          <p:cNvPr id="12" name="Shape 10"/>
+          <p:cNvSpPr/>
+          <p:nvPr/>
+        </p:nvSpPr>
+        <p:spPr>
+          <a:xfrm>
+            <a:off x="868680" y="3813048"/>
+            <a:ext cx="658368" cy="658368"/>
           </a:xfrm>
           <a:prstGeom prst="ellipse">
             <a:avLst/>
@@ -7308,14 +7003,14 @@
       </p:sp>
       <p:sp>
         <p:nvSpPr>
-          <p:cNvPr id="10" name="Text 8"/>
-          <p:cNvSpPr/>
-          <p:nvPr/>
-        </p:nvSpPr>
-        <p:spPr>
-          <a:xfrm>
-            <a:off x="548640" y="2414016"/>
-            <a:ext cx="402336" cy="402336"/>
+          <p:cNvPr id="13" name="Text 11"/>
+          <p:cNvSpPr/>
+          <p:nvPr/>
+        </p:nvSpPr>
+        <p:spPr>
+          <a:xfrm>
+            <a:off x="868680" y="3813048"/>
+            <a:ext cx="658368" cy="658368"/>
           </a:xfrm>
           <a:prstGeom prst="rect">
             <a:avLst/>
@@ -7331,7 +7026,7 @@
               <a:buNone/>
             </a:pPr>
             <a:r>
-              <a:rPr lang="en-US" sz="1300" b="1" dirty="0">
+              <a:rPr lang="en-US" sz="2200" b="1" dirty="0">
                 <a:solidFill>
                   <a:srgbClr val="142638"/>
                 </a:solidFill>
@@ -7339,22 +7034,22 @@
                 <a:ea typeface="Arial" pitchFamily="34" charset="-122"/>
                 <a:cs typeface="Arial" pitchFamily="34" charset="-120"/>
               </a:rPr>
-              <a:t>2</a:t>
-            </a:r>
-            <a:endParaRPr lang="en-US" sz="1300" dirty="0"/>
-          </a:p>
-        </p:txBody>
-      </p:sp>
-      <p:sp>
-        <p:nvSpPr>
-          <p:cNvPr id="11" name="Text 9"/>
-          <p:cNvSpPr/>
-          <p:nvPr/>
-        </p:nvSpPr>
-        <p:spPr>
-          <a:xfrm>
-            <a:off x="1078992" y="2359152"/>
-            <a:ext cx="2743200" cy="365760"/>
+              <a:t>B</a:t>
+            </a:r>
+            <a:endParaRPr lang="en-US" sz="2200" dirty="0"/>
+          </a:p>
+        </p:txBody>
+      </p:sp>
+      <p:sp>
+        <p:nvSpPr>
+          <p:cNvPr id="14" name="Text 12"/>
+          <p:cNvSpPr/>
+          <p:nvPr/>
+        </p:nvSpPr>
+        <p:spPr>
+          <a:xfrm>
+            <a:off x="1783080" y="3529584"/>
+            <a:ext cx="2743200" cy="274320"/>
           </a:xfrm>
           <a:prstGeom prst="rect">
             <a:avLst/>
@@ -7370,30 +7065,30 @@
               <a:buNone/>
             </a:pPr>
             <a:r>
-              <a:rPr lang="en-US" sz="1250" b="1" dirty="0">
-                <a:solidFill>
-                  <a:srgbClr val="FFFFFF"/>
-                </a:solidFill>
-                <a:latin typeface="Arial" pitchFamily="34" charset="0"/>
-                <a:ea typeface="Arial" pitchFamily="34" charset="-122"/>
-                <a:cs typeface="Arial" pitchFamily="34" charset="-120"/>
-              </a:rPr>
-              <a:t>컨트롤러 신호 확장</a:t>
-            </a:r>
-            <a:endParaRPr lang="en-US" sz="1250" dirty="0"/>
-          </a:p>
-        </p:txBody>
-      </p:sp>
-      <p:sp>
-        <p:nvSpPr>
-          <p:cNvPr id="12" name="Text 10"/>
-          <p:cNvSpPr/>
-          <p:nvPr/>
-        </p:nvSpPr>
-        <p:spPr>
-          <a:xfrm>
-            <a:off x="1078992" y="2688336"/>
-            <a:ext cx="5212080" cy="438912"/>
+              <a:rPr lang="en-US" sz="1100" b="1" dirty="0">
+                <a:solidFill>
+                  <a:srgbClr val="7EC8F5"/>
+                </a:solidFill>
+                <a:latin typeface="Arial" pitchFamily="34" charset="0"/>
+                <a:ea typeface="Arial" pitchFamily="34" charset="-122"/>
+                <a:cs typeface="Arial" pitchFamily="34" charset="-120"/>
+              </a:rPr>
+              <a:t>게이트 B</a:t>
+            </a:r>
+            <a:endParaRPr lang="en-US" sz="1100" dirty="0"/>
+          </a:p>
+        </p:txBody>
+      </p:sp>
+      <p:sp>
+        <p:nvSpPr>
+          <p:cNvPr id="15" name="Text 13"/>
+          <p:cNvSpPr/>
+          <p:nvPr/>
+        </p:nvSpPr>
+        <p:spPr>
+          <a:xfrm>
+            <a:off x="1783080" y="3785616"/>
+            <a:ext cx="9144000" cy="411480"/>
           </a:xfrm>
           <a:prstGeom prst="rect">
             <a:avLst/>
@@ -7409,30 +7104,30 @@
               <a:buNone/>
             </a:pPr>
             <a:r>
-              <a:rPr lang="en-US" sz="1030" dirty="0">
-                <a:solidFill>
-                  <a:srgbClr val="9FB8CE"/>
-                </a:solidFill>
-                <a:latin typeface="Arial" pitchFamily="34" charset="0"/>
-                <a:ea typeface="Arial" pitchFamily="34" charset="-122"/>
-                <a:cs typeface="Arial" pitchFamily="34" charset="-120"/>
-              </a:rPr>
-              <a:t>attention 질량 대신 vision feature · hidden state probe</a:t>
-            </a:r>
-            <a:endParaRPr lang="en-US" sz="1030" dirty="0"/>
-          </a:p>
-        </p:txBody>
-      </p:sp>
-      <p:sp>
-        <p:nvSpPr>
-          <p:cNvPr id="13" name="Text 11"/>
-          <p:cNvSpPr/>
-          <p:nvPr/>
-        </p:nvSpPr>
-        <p:spPr>
-          <a:xfrm>
-            <a:off x="6492240" y="2395728"/>
-            <a:ext cx="5212080" cy="438912"/>
+              <a:rPr lang="en-US" sz="1800" b="1" dirty="0">
+                <a:solidFill>
+                  <a:srgbClr val="FFFFFF"/>
+                </a:solidFill>
+                <a:latin typeface="Arial" pitchFamily="34" charset="0"/>
+                <a:ea typeface="Arial" pitchFamily="34" charset="-122"/>
+                <a:cs typeface="Arial" pitchFamily="34" charset="-120"/>
+              </a:rPr>
+              <a:t>어느 이미지가 방해인지 자동으로 알 수 있는가?</a:t>
+            </a:r>
+            <a:endParaRPr lang="en-US" sz="1800" dirty="0"/>
+          </a:p>
+        </p:txBody>
+      </p:sp>
+      <p:sp>
+        <p:nvSpPr>
+          <p:cNvPr id="16" name="Text 14"/>
+          <p:cNvSpPr/>
+          <p:nvPr/>
+        </p:nvSpPr>
+        <p:spPr>
+          <a:xfrm>
+            <a:off x="1783080" y="4242816"/>
+            <a:ext cx="9144000" cy="292608"/>
           </a:xfrm>
           <a:prstGeom prst="rect">
             <a:avLst/>
@@ -7448,50 +7143,30 @@
               <a:buNone/>
             </a:pPr>
             <a:r>
-              <a:rPr lang="en-US" sz="1150" dirty="0">
-                <a:solidFill>
-                  <a:srgbClr val="8CE0B0"/>
-                </a:solidFill>
-                <a:latin typeface="Arial" pitchFamily="34" charset="0"/>
-                <a:ea typeface="Arial" pitchFamily="34" charset="-122"/>
-                <a:cs typeface="Arial" pitchFamily="34" charset="-120"/>
-              </a:rPr>
-              <a:t>→ 얕은 층에서 판정 가능한가</a:t>
-            </a:r>
-            <a:endParaRPr lang="en-US" sz="1150" dirty="0"/>
-          </a:p>
-        </p:txBody>
-      </p:sp>
-      <p:sp>
-        <p:nvSpPr>
-          <p:cNvPr id="14" name="Shape 12"/>
-          <p:cNvSpPr/>
-          <p:nvPr/>
-        </p:nvSpPr>
-        <p:spPr>
-          <a:xfrm>
-            <a:off x="548640" y="3200400"/>
-            <a:ext cx="402336" cy="402336"/>
-          </a:xfrm>
-          <a:prstGeom prst="ellipse">
-            <a:avLst/>
-          </a:prstGeom>
-          <a:solidFill>
-            <a:srgbClr val="7EC8F5"/>
-          </a:solidFill>
-          <a:ln/>
-        </p:spPr>
-      </p:sp>
-      <p:sp>
-        <p:nvSpPr>
-          <p:cNvPr id="15" name="Text 13"/>
-          <p:cNvSpPr/>
-          <p:nvPr/>
-        </p:nvSpPr>
-        <p:spPr>
-          <a:xfrm>
-            <a:off x="548640" y="3200400"/>
-            <a:ext cx="402336" cy="402336"/>
+              <a:rPr lang="en-US" sz="1250" dirty="0">
+                <a:solidFill>
+                  <a:srgbClr val="9FB8CE"/>
+                </a:solidFill>
+                <a:latin typeface="Arial" pitchFamily="34" charset="0"/>
+                <a:ea typeface="Arial" pitchFamily="34" charset="-122"/>
+                <a:cs typeface="Arial" pitchFamily="34" charset="-120"/>
+              </a:rPr>
+              <a:t>attention 대신 vision feature · hidden state로 16층 이전에서 판정</a:t>
+            </a:r>
+            <a:endParaRPr lang="en-US" sz="1250" dirty="0"/>
+          </a:p>
+        </p:txBody>
+      </p:sp>
+      <p:sp>
+        <p:nvSpPr>
+          <p:cNvPr id="17" name="Text 15"/>
+          <p:cNvSpPr/>
+          <p:nvPr/>
+        </p:nvSpPr>
+        <p:spPr>
+          <a:xfrm>
+            <a:off x="1783080" y="4572000"/>
+            <a:ext cx="9144000" cy="310896"/>
           </a:xfrm>
           <a:prstGeom prst="rect">
             <a:avLst/>
@@ -7503,34 +7178,48 @@
           <a:bodyPr wrap="square" lIns="0" tIns="0" rIns="0" bIns="0" rtlCol="0" anchor="ctr"/>
           <a:lstStyle/>
           <a:p>
-            <a:pPr algn="ctr" indent="0" marL="0">
-              <a:buNone/>
-            </a:pPr>
-            <a:r>
-              <a:rPr lang="en-US" sz="1300" b="1" dirty="0">
-                <a:solidFill>
-                  <a:srgbClr val="142638"/>
-                </a:solidFill>
-                <a:latin typeface="Arial" pitchFamily="34" charset="0"/>
-                <a:ea typeface="Arial" pitchFamily="34" charset="-122"/>
-                <a:cs typeface="Arial" pitchFamily="34" charset="-120"/>
-              </a:rPr>
-              <a:t>3</a:t>
-            </a:r>
-            <a:endParaRPr lang="en-US" sz="1300" dirty="0"/>
-          </a:p>
-        </p:txBody>
-      </p:sp>
-      <p:sp>
-        <p:nvSpPr>
-          <p:cNvPr id="16" name="Text 14"/>
-          <p:cNvSpPr/>
-          <p:nvPr/>
-        </p:nvSpPr>
-        <p:spPr>
-          <a:xfrm>
-            <a:off x="1078992" y="3145536"/>
-            <a:ext cx="2743200" cy="365760"/>
+            <a:pPr indent="0" marL="0">
+              <a:buNone/>
+            </a:pPr>
+            <a:r>
+              <a:rPr lang="en-US" sz="1200" b="1" dirty="0">
+                <a:solidFill>
+                  <a:srgbClr val="FF9E80"/>
+                </a:solidFill>
+                <a:latin typeface="Arial" pitchFamily="34" charset="0"/>
+                <a:ea typeface="Arial" pitchFamily="34" charset="-122"/>
+                <a:cs typeface="Arial" pitchFamily="34" charset="-120"/>
+              </a:rPr>
+              <a:t>실패 조건   </a:t>
+            </a:r>
+            <a:pPr indent="0" marL="0">
+              <a:buNone/>
+            </a:pPr>
+            <a:r>
+              <a:rPr lang="en-US" sz="1250" b="1" dirty="0">
+                <a:solidFill>
+                  <a:srgbClr val="FFC94D"/>
+                </a:solidFill>
+                <a:latin typeface="Arial" pitchFamily="34" charset="0"/>
+                <a:ea typeface="Arial" pitchFamily="34" charset="-122"/>
+                <a:cs typeface="Arial" pitchFamily="34" charset="-120"/>
+              </a:rPr>
+              <a:t>이미지 순서를 뒤집었을 때 유지되지 않으면  →  이 주제는 폐기</a:t>
+            </a:r>
+            <a:endParaRPr lang="en-US" sz="1200" dirty="0"/>
+          </a:p>
+        </p:txBody>
+      </p:sp>
+      <p:sp>
+        <p:nvSpPr>
+          <p:cNvPr id="18" name="Text 16"/>
+          <p:cNvSpPr/>
+          <p:nvPr/>
+        </p:nvSpPr>
+        <p:spPr>
+          <a:xfrm>
+            <a:off x="502920" y="5230368"/>
+            <a:ext cx="11201400" cy="310896"/>
           </a:xfrm>
           <a:prstGeom prst="rect">
             <a:avLst/>
@@ -7546,95 +7235,17 @@
               <a:buNone/>
             </a:pPr>
             <a:r>
-              <a:rPr lang="en-US" sz="1250" b="1" dirty="0">
-                <a:solidFill>
-                  <a:srgbClr val="FFFFFF"/>
-                </a:solidFill>
-                <a:latin typeface="Arial" pitchFamily="34" charset="0"/>
-                <a:ea typeface="Arial" pitchFamily="34" charset="-122"/>
-                <a:cs typeface="Arial" pitchFamily="34" charset="-120"/>
-              </a:rPr>
-              <a:t>질문 유형 게이트</a:t>
-            </a:r>
-            <a:endParaRPr lang="en-US" sz="1250" dirty="0"/>
-          </a:p>
-        </p:txBody>
-      </p:sp>
-      <p:sp>
-        <p:nvSpPr>
-          <p:cNvPr id="17" name="Text 15"/>
-          <p:cNvSpPr/>
-          <p:nvPr/>
-        </p:nvSpPr>
-        <p:spPr>
-          <a:xfrm>
-            <a:off x="1078992" y="3474720"/>
-            <a:ext cx="5212080" cy="438912"/>
-          </a:xfrm>
-          <a:prstGeom prst="rect">
-            <a:avLst/>
-          </a:prstGeom>
-          <a:noFill/>
-          <a:ln/>
-        </p:spPr>
-        <p:txBody>
-          <a:bodyPr wrap="square" lIns="0" tIns="0" rIns="0" bIns="0" rtlCol="0" anchor="ctr"/>
-          <a:lstStyle/>
-          <a:p>
-            <a:pPr indent="0" marL="0">
-              <a:buNone/>
-            </a:pPr>
-            <a:r>
-              <a:rPr lang="en-US" sz="1030" dirty="0">
-                <a:solidFill>
-                  <a:srgbClr val="9FB8CE"/>
-                </a:solidFill>
-                <a:latin typeface="Arial" pitchFamily="34" charset="0"/>
-                <a:ea typeface="Arial" pitchFamily="34" charset="-122"/>
-                <a:cs typeface="Arial" pitchFamily="34" charset="-120"/>
-              </a:rPr>
-              <a:t>질문 유형은 텍스트만으로 0층에서 판정 가능</a:t>
-            </a:r>
-            <a:endParaRPr lang="en-US" sz="1030" dirty="0"/>
-          </a:p>
-        </p:txBody>
-      </p:sp>
-      <p:sp>
-        <p:nvSpPr>
-          <p:cNvPr id="18" name="Text 16"/>
-          <p:cNvSpPr/>
-          <p:nvPr/>
-        </p:nvSpPr>
-        <p:spPr>
-          <a:xfrm>
-            <a:off x="6492240" y="3182112"/>
-            <a:ext cx="5212080" cy="438912"/>
-          </a:xfrm>
-          <a:prstGeom prst="rect">
-            <a:avLst/>
-          </a:prstGeom>
-          <a:noFill/>
-          <a:ln/>
-        </p:spPr>
-        <p:txBody>
-          <a:bodyPr wrap="square" lIns="0" tIns="0" rIns="0" bIns="0" rtlCol="0" anchor="ctr"/>
-          <a:lstStyle/>
-          <a:p>
-            <a:pPr indent="0" marL="0">
-              <a:buNone/>
-            </a:pPr>
-            <a:r>
-              <a:rPr lang="en-US" sz="1150" dirty="0">
-                <a:solidFill>
-                  <a:srgbClr val="8CE0B0"/>
-                </a:solidFill>
-                <a:latin typeface="Arial" pitchFamily="34" charset="0"/>
-                <a:ea typeface="Arial" pitchFamily="34" charset="-122"/>
-                <a:cs typeface="Arial" pitchFamily="34" charset="-120"/>
-              </a:rPr>
-              <a:t>→ −51%p 실패를 피할 수 있는가</a:t>
-            </a:r>
-            <a:endParaRPr lang="en-US" sz="1150" dirty="0"/>
+              <a:rPr lang="en-US" sz="1200" dirty="0">
+                <a:solidFill>
+                  <a:srgbClr val="8AA5BC"/>
+                </a:solidFill>
+                <a:latin typeface="Arial" pitchFamily="34" charset="0"/>
+                <a:ea typeface="Arial" pitchFamily="34" charset="-122"/>
+                <a:cs typeface="Arial" pitchFamily="34" charset="-120"/>
+              </a:rPr>
+              <a:t>그 외 보조 3건 — 질문 유형 게이트 · random 배분 대조군 · 선행연구가 남긴 열린 질문 검증</a:t>
+            </a:r>
+            <a:endParaRPr lang="en-US" sz="1200" dirty="0"/>
           </a:p>
         </p:txBody>
       </p:sp>
@@ -7646,359 +7257,7 @@
         </p:nvSpPr>
         <p:spPr>
           <a:xfrm>
-            <a:off x="548640" y="3986784"/>
-            <a:ext cx="402336" cy="402336"/>
-          </a:xfrm>
-          <a:prstGeom prst="ellipse">
-            <a:avLst/>
-          </a:prstGeom>
-          <a:solidFill>
-            <a:srgbClr val="7EC8F5"/>
-          </a:solidFill>
-          <a:ln/>
-        </p:spPr>
-      </p:sp>
-      <p:sp>
-        <p:nvSpPr>
-          <p:cNvPr id="20" name="Text 18"/>
-          <p:cNvSpPr/>
-          <p:nvPr/>
-        </p:nvSpPr>
-        <p:spPr>
-          <a:xfrm>
-            <a:off x="548640" y="3986784"/>
-            <a:ext cx="402336" cy="402336"/>
-          </a:xfrm>
-          <a:prstGeom prst="rect">
-            <a:avLst/>
-          </a:prstGeom>
-          <a:noFill/>
-          <a:ln/>
-        </p:spPr>
-        <p:txBody>
-          <a:bodyPr wrap="square" lIns="0" tIns="0" rIns="0" bIns="0" rtlCol="0" anchor="ctr"/>
-          <a:lstStyle/>
-          <a:p>
-            <a:pPr algn="ctr" indent="0" marL="0">
-              <a:buNone/>
-            </a:pPr>
-            <a:r>
-              <a:rPr lang="en-US" sz="1300" b="1" dirty="0">
-                <a:solidFill>
-                  <a:srgbClr val="142638"/>
-                </a:solidFill>
-                <a:latin typeface="Arial" pitchFamily="34" charset="0"/>
-                <a:ea typeface="Arial" pitchFamily="34" charset="-122"/>
-                <a:cs typeface="Arial" pitchFamily="34" charset="-120"/>
-              </a:rPr>
-              <a:t>4</a:t>
-            </a:r>
-            <a:endParaRPr lang="en-US" sz="1300" dirty="0"/>
-          </a:p>
-        </p:txBody>
-      </p:sp>
-      <p:sp>
-        <p:nvSpPr>
-          <p:cNvPr id="21" name="Text 19"/>
-          <p:cNvSpPr/>
-          <p:nvPr/>
-        </p:nvSpPr>
-        <p:spPr>
-          <a:xfrm>
-            <a:off x="1078992" y="3931920"/>
-            <a:ext cx="2743200" cy="365760"/>
-          </a:xfrm>
-          <a:prstGeom prst="rect">
-            <a:avLst/>
-          </a:prstGeom>
-          <a:noFill/>
-          <a:ln/>
-        </p:spPr>
-        <p:txBody>
-          <a:bodyPr wrap="square" lIns="0" tIns="0" rIns="0" bIns="0" rtlCol="0" anchor="ctr"/>
-          <a:lstStyle/>
-          <a:p>
-            <a:pPr indent="0" marL="0">
-              <a:buNone/>
-            </a:pPr>
-            <a:r>
-              <a:rPr lang="en-US" sz="1250" b="1" dirty="0">
-                <a:solidFill>
-                  <a:srgbClr val="FFFFFF"/>
-                </a:solidFill>
-                <a:latin typeface="Arial" pitchFamily="34" charset="0"/>
-                <a:ea typeface="Arial" pitchFamily="34" charset="-122"/>
-                <a:cs typeface="Arial" pitchFamily="34" charset="-120"/>
-              </a:rPr>
-              <a:t>대조군 보강</a:t>
-            </a:r>
-            <a:endParaRPr lang="en-US" sz="1250" dirty="0"/>
-          </a:p>
-        </p:txBody>
-      </p:sp>
-      <p:sp>
-        <p:nvSpPr>
-          <p:cNvPr id="22" name="Text 20"/>
-          <p:cNvSpPr/>
-          <p:nvPr/>
-        </p:nvSpPr>
-        <p:spPr>
-          <a:xfrm>
-            <a:off x="1078992" y="4261104"/>
-            <a:ext cx="5212080" cy="438912"/>
-          </a:xfrm>
-          <a:prstGeom prst="rect">
-            <a:avLst/>
-          </a:prstGeom>
-          <a:noFill/>
-          <a:ln/>
-        </p:spPr>
-        <p:txBody>
-          <a:bodyPr wrap="square" lIns="0" tIns="0" rIns="0" bIns="0" rtlCol="0" anchor="ctr"/>
-          <a:lstStyle/>
-          <a:p>
-            <a:pPr indent="0" marL="0">
-              <a:buNone/>
-            </a:pPr>
-            <a:r>
-              <a:rPr lang="en-US" sz="1030" dirty="0">
-                <a:solidFill>
-                  <a:srgbClr val="9FB8CE"/>
-                </a:solidFill>
-                <a:latin typeface="Arial" pitchFamily="34" charset="0"/>
-                <a:ea typeface="Arial" pitchFamily="34" charset="-122"/>
-                <a:cs typeface="Arial" pitchFamily="34" charset="-120"/>
-              </a:rPr>
-              <a:t>random 배분 · 완전 제거 상한</a:t>
-            </a:r>
-            <a:endParaRPr lang="en-US" sz="1030" dirty="0"/>
-          </a:p>
-        </p:txBody>
-      </p:sp>
-      <p:sp>
-        <p:nvSpPr>
-          <p:cNvPr id="23" name="Text 21"/>
-          <p:cNvSpPr/>
-          <p:nvPr/>
-        </p:nvSpPr>
-        <p:spPr>
-          <a:xfrm>
-            <a:off x="6492240" y="3968496"/>
-            <a:ext cx="5212080" cy="438912"/>
-          </a:xfrm>
-          <a:prstGeom prst="rect">
-            <a:avLst/>
-          </a:prstGeom>
-          <a:noFill/>
-          <a:ln/>
-        </p:spPr>
-        <p:txBody>
-          <a:bodyPr wrap="square" lIns="0" tIns="0" rIns="0" bIns="0" rtlCol="0" anchor="ctr"/>
-          <a:lstStyle/>
-          <a:p>
-            <a:pPr indent="0" marL="0">
-              <a:buNone/>
-            </a:pPr>
-            <a:r>
-              <a:rPr lang="en-US" sz="1150" dirty="0">
-                <a:solidFill>
-                  <a:srgbClr val="8CE0B0"/>
-                </a:solidFill>
-                <a:latin typeface="Arial" pitchFamily="34" charset="0"/>
-                <a:ea typeface="Arial" pitchFamily="34" charset="-122"/>
-                <a:cs typeface="Arial" pitchFamily="34" charset="-120"/>
-              </a:rPr>
-              <a:t>→ 이득이 강건한가</a:t>
-            </a:r>
-            <a:endParaRPr lang="en-US" sz="1150" dirty="0"/>
-          </a:p>
-        </p:txBody>
-      </p:sp>
-      <p:sp>
-        <p:nvSpPr>
-          <p:cNvPr id="24" name="Shape 22"/>
-          <p:cNvSpPr/>
-          <p:nvPr/>
-        </p:nvSpPr>
-        <p:spPr>
-          <a:xfrm>
-            <a:off x="548640" y="4773168"/>
-            <a:ext cx="402336" cy="402336"/>
-          </a:xfrm>
-          <a:prstGeom prst="ellipse">
-            <a:avLst/>
-          </a:prstGeom>
-          <a:solidFill>
-            <a:srgbClr val="7EC8F5"/>
-          </a:solidFill>
-          <a:ln/>
-        </p:spPr>
-      </p:sp>
-      <p:sp>
-        <p:nvSpPr>
-          <p:cNvPr id="25" name="Text 23"/>
-          <p:cNvSpPr/>
-          <p:nvPr/>
-        </p:nvSpPr>
-        <p:spPr>
-          <a:xfrm>
-            <a:off x="548640" y="4773168"/>
-            <a:ext cx="402336" cy="402336"/>
-          </a:xfrm>
-          <a:prstGeom prst="rect">
-            <a:avLst/>
-          </a:prstGeom>
-          <a:noFill/>
-          <a:ln/>
-        </p:spPr>
-        <p:txBody>
-          <a:bodyPr wrap="square" lIns="0" tIns="0" rIns="0" bIns="0" rtlCol="0" anchor="ctr"/>
-          <a:lstStyle/>
-          <a:p>
-            <a:pPr algn="ctr" indent="0" marL="0">
-              <a:buNone/>
-            </a:pPr>
-            <a:r>
-              <a:rPr lang="en-US" sz="1300" b="1" dirty="0">
-                <a:solidFill>
-                  <a:srgbClr val="142638"/>
-                </a:solidFill>
-                <a:latin typeface="Arial" pitchFamily="34" charset="0"/>
-                <a:ea typeface="Arial" pitchFamily="34" charset="-122"/>
-                <a:cs typeface="Arial" pitchFamily="34" charset="-120"/>
-              </a:rPr>
-              <a:t>5</a:t>
-            </a:r>
-            <a:endParaRPr lang="en-US" sz="1300" dirty="0"/>
-          </a:p>
-        </p:txBody>
-      </p:sp>
-      <p:sp>
-        <p:nvSpPr>
-          <p:cNvPr id="26" name="Text 24"/>
-          <p:cNvSpPr/>
-          <p:nvPr/>
-        </p:nvSpPr>
-        <p:spPr>
-          <a:xfrm>
-            <a:off x="1078992" y="4718304"/>
-            <a:ext cx="2743200" cy="365760"/>
-          </a:xfrm>
-          <a:prstGeom prst="rect">
-            <a:avLst/>
-          </a:prstGeom>
-          <a:noFill/>
-          <a:ln/>
-        </p:spPr>
-        <p:txBody>
-          <a:bodyPr wrap="square" lIns="0" tIns="0" rIns="0" bIns="0" rtlCol="0" anchor="ctr"/>
-          <a:lstStyle/>
-          <a:p>
-            <a:pPr indent="0" marL="0">
-              <a:buNone/>
-            </a:pPr>
-            <a:r>
-              <a:rPr lang="en-US" sz="1250" b="1" dirty="0">
-                <a:solidFill>
-                  <a:srgbClr val="FFFFFF"/>
-                </a:solidFill>
-                <a:latin typeface="Arial" pitchFamily="34" charset="0"/>
-                <a:ea typeface="Arial" pitchFamily="34" charset="-122"/>
-                <a:cs typeface="Arial" pitchFamily="34" charset="-120"/>
-              </a:rPr>
-              <a:t>선행연구 열린 질문</a:t>
-            </a:r>
-            <a:endParaRPr lang="en-US" sz="1250" dirty="0"/>
-          </a:p>
-        </p:txBody>
-      </p:sp>
-      <p:sp>
-        <p:nvSpPr>
-          <p:cNvPr id="27" name="Text 25"/>
-          <p:cNvSpPr/>
-          <p:nvPr/>
-        </p:nvSpPr>
-        <p:spPr>
-          <a:xfrm>
-            <a:off x="1078992" y="5047488"/>
-            <a:ext cx="5212080" cy="438912"/>
-          </a:xfrm>
-          <a:prstGeom prst="rect">
-            <a:avLst/>
-          </a:prstGeom>
-          <a:noFill/>
-          <a:ln/>
-        </p:spPr>
-        <p:txBody>
-          <a:bodyPr wrap="square" lIns="0" tIns="0" rIns="0" bIns="0" rtlCol="0" anchor="ctr"/>
-          <a:lstStyle/>
-          <a:p>
-            <a:pPr indent="0" marL="0">
-              <a:buNone/>
-            </a:pPr>
-            <a:r>
-              <a:rPr lang="en-US" sz="1030" dirty="0">
-                <a:solidFill>
-                  <a:srgbClr val="9FB8CE"/>
-                </a:solidFill>
-                <a:latin typeface="Arial" pitchFamily="34" charset="0"/>
-                <a:ea typeface="Arial" pitchFamily="34" charset="-122"/>
-                <a:cs typeface="Arial" pitchFamily="34" charset="-120"/>
-              </a:rPr>
-              <a:t>마스킹이 언제 도움/해가 되는지 질문 유형 축으로</a:t>
-            </a:r>
-            <a:endParaRPr lang="en-US" sz="1030" dirty="0"/>
-          </a:p>
-        </p:txBody>
-      </p:sp>
-      <p:sp>
-        <p:nvSpPr>
-          <p:cNvPr id="28" name="Text 26"/>
-          <p:cNvSpPr/>
-          <p:nvPr/>
-        </p:nvSpPr>
-        <p:spPr>
-          <a:xfrm>
-            <a:off x="6492240" y="4754880"/>
-            <a:ext cx="5212080" cy="438912"/>
-          </a:xfrm>
-          <a:prstGeom prst="rect">
-            <a:avLst/>
-          </a:prstGeom>
-          <a:noFill/>
-          <a:ln/>
-        </p:spPr>
-        <p:txBody>
-          <a:bodyPr wrap="square" lIns="0" tIns="0" rIns="0" bIns="0" rtlCol="0" anchor="ctr"/>
-          <a:lstStyle/>
-          <a:p>
-            <a:pPr indent="0" marL="0">
-              <a:buNone/>
-            </a:pPr>
-            <a:r>
-              <a:rPr lang="en-US" sz="1150" dirty="0">
-                <a:solidFill>
-                  <a:srgbClr val="8CE0B0"/>
-                </a:solidFill>
-                <a:latin typeface="Arial" pitchFamily="34" charset="0"/>
-                <a:ea typeface="Arial" pitchFamily="34" charset="-122"/>
-                <a:cs typeface="Arial" pitchFamily="34" charset="-120"/>
-              </a:rPr>
-              <a:t>→ 우리 기여가 성립하는가</a:t>
-            </a:r>
-            <a:endParaRPr lang="en-US" sz="1150" dirty="0"/>
-          </a:p>
-        </p:txBody>
-      </p:sp>
-      <p:sp>
-        <p:nvSpPr>
-          <p:cNvPr id="29" name="Shape 27"/>
-          <p:cNvSpPr/>
-          <p:nvPr/>
-        </p:nvSpPr>
-        <p:spPr>
-          <a:xfrm>
-            <a:off x="502920" y="5669280"/>
+            <a:off x="502920" y="5687568"/>
             <a:ext cx="11201400" cy="868680"/>
           </a:xfrm>
           <a:prstGeom prst="roundRect">
@@ -8019,13 +7278,13 @@
       </p:sp>
       <p:sp>
         <p:nvSpPr>
-          <p:cNvPr id="30" name="Text 28"/>
-          <p:cNvSpPr/>
-          <p:nvPr/>
-        </p:nvSpPr>
-        <p:spPr>
-          <a:xfrm>
-            <a:off x="777240" y="5760720"/>
+          <p:cNvPr id="20" name="Text 18"/>
+          <p:cNvSpPr/>
+          <p:nvPr/>
+        </p:nvSpPr>
+        <p:spPr>
+          <a:xfrm>
+            <a:off x="777240" y="5779008"/>
             <a:ext cx="10698480" cy="731520"/>
           </a:xfrm>
           <a:prstGeom prst="rect">
@@ -8053,7 +7312,7 @@
                 <a:ea typeface="Arial" pitchFamily="34" charset="-122"/>
                 <a:cs typeface="Arial" pitchFamily="34" charset="-120"/>
               </a:rPr>
-              <a:t>중단 규칙을 먼저 정해두겠습니다 — 게이트 1과 2가 모두 실패하면 이 주제는 접고 다른 방향으로 넘어가겠습니다.</a:t>
+              <a:t>중단 규칙을 먼저 정해두겠습니다 — A와 B가 모두 실패하면 이 주제는 접고 다른 방향으로 넘어가겠습니다.</a:t>
             </a:r>
             <a:endParaRPr lang="en-US" sz="1250" dirty="0"/>
           </a:p>

</xml_diff>